<commit_message>
slight update: process some review comments
</commit_message>
<xml_diff>
--- a/conference-talks/LangDev/2026/LangDev 2026 Talk.pptx
+++ b/conference-talks/LangDev/2026/LangDev 2026 Talk.pptx
@@ -20,6 +20,7 @@
     <p:sldId id="265" r:id="rId17"/>
     <p:sldId id="266" r:id="rId18"/>
     <p:sldId id="267" r:id="rId19"/>
+    <p:sldId id="268" r:id="rId20"/>
   </p:sldIdLst>
   <p:sldSz cx="12192000" cy="6858000"/>
   <p:notesSz cx="6858000" cy="9144000"/>
@@ -6984,7 +6985,7 @@
       </p:grpSpPr>
       <p:sp>
         <p:nvSpPr>
-          <p:cNvPr id="374" name="Title 1"/>
+          <p:cNvPr id="375" name="Title 1"/>
           <p:cNvSpPr txBox="1"/>
           <p:nvPr>
             <p:ph type="title"/>
@@ -7012,7 +7013,7 @@
       </p:sp>
       <p:sp>
         <p:nvSpPr>
-          <p:cNvPr id="375" name="Content Placeholder 2"/>
+          <p:cNvPr id="376" name="Content Placeholder 2"/>
           <p:cNvSpPr txBox="1"/>
           <p:nvPr>
             <p:ph type="body" idx="1"/>
@@ -7117,7 +7118,7 @@
       </p:grpSpPr>
       <p:sp>
         <p:nvSpPr>
-          <p:cNvPr id="377" name="Title 1"/>
+          <p:cNvPr id="378" name="Title 1"/>
           <p:cNvSpPr txBox="1"/>
           <p:nvPr>
             <p:ph type="title"/>
@@ -7141,7 +7142,7 @@
       </p:sp>
       <p:sp>
         <p:nvSpPr>
-          <p:cNvPr id="378" name="Text Placeholder 4"/>
+          <p:cNvPr id="379" name="Text Placeholder 4"/>
           <p:cNvSpPr txBox="1"/>
           <p:nvPr>
             <p:ph type="body" sz="quarter" idx="1"/>
@@ -7162,7 +7163,7 @@
       </p:sp>
       <p:pic>
         <p:nvPicPr>
-          <p:cNvPr id="379" name="Graphic 5" descr="Graphic 5"/>
+          <p:cNvPr id="380" name="Graphic 5" descr="Graphic 5"/>
           <p:cNvPicPr>
             <a:picLocks noChangeAspect="1"/>
           </p:cNvPicPr>
@@ -7215,9 +7216,162 @@
           <a:chExt cx="0" cy="0"/>
         </a:xfrm>
       </p:grpSpPr>
+      <p:sp>
+        <p:nvSpPr>
+          <p:cNvPr id="382" name="Title 1"/>
+          <p:cNvSpPr txBox="1"/>
+          <p:nvPr>
+            <p:ph type="title"/>
+          </p:nvPr>
+        </p:nvSpPr>
+        <p:spPr>
+          <a:xfrm>
+            <a:off x="0" y="0"/>
+            <a:ext cx="12192000" cy="1264249"/>
+          </a:xfrm>
+          <a:prstGeom prst="rect">
+            <a:avLst/>
+          </a:prstGeom>
+        </p:spPr>
+        <p:txBody>
+          <a:bodyPr/>
+          <a:lstStyle/>
+          <a:p>
+            <a:pPr/>
+            <a:r>
+              <a:t>Use cases</a:t>
+            </a:r>
+          </a:p>
+        </p:txBody>
+      </p:sp>
+      <p:sp>
+        <p:nvSpPr>
+          <p:cNvPr id="383" name="Content Placeholder 2"/>
+          <p:cNvSpPr txBox="1"/>
+          <p:nvPr>
+            <p:ph type="body" idx="1"/>
+          </p:nvPr>
+        </p:nvSpPr>
+        <p:spPr>
+          <a:prstGeom prst="rect">
+            <a:avLst/>
+          </a:prstGeom>
+        </p:spPr>
+        <p:txBody>
+          <a:bodyPr/>
+          <a:lstStyle/>
+          <a:p>
+            <a:pPr lvl="1" marL="828842" indent="-320842">
+              <a:buAutoNum type="arabicPeriod" startAt="1"/>
+              <a:defRPr>
+                <a:latin typeface="Lato Regular"/>
+                <a:ea typeface="Lato Regular"/>
+                <a:cs typeface="Lato Regular"/>
+                <a:sym typeface="Lato Regular"/>
+              </a:defRPr>
+            </a:pPr>
+            <a:r>
+              <a:t>Strumenta: legacy transformation of huge code bases</a:t>
+            </a:r>
+          </a:p>
+          <a:p>
+            <a:pPr lvl="1" marL="828842" indent="-320842">
+              <a:buAutoNum type="arabicPeriod" startAt="1"/>
+              <a:defRPr>
+                <a:latin typeface="Lato Regular"/>
+                <a:ea typeface="Lato Regular"/>
+                <a:cs typeface="Lato Regular"/>
+                <a:sym typeface="Lato Regular"/>
+              </a:defRPr>
+            </a:pPr>
+            <a:r>
+              <a:t>TRUMPF: essential part of infrastructure</a:t>
+            </a:r>
+          </a:p>
+          <a:p>
+            <a:pPr lvl="1" marL="828842" indent="-320842">
+              <a:buAutoNum type="arabicPeriod" startAt="1"/>
+              <a:defRPr>
+                <a:latin typeface="Lato Regular"/>
+                <a:ea typeface="Lato Regular"/>
+                <a:cs typeface="Lato Regular"/>
+                <a:sym typeface="Lato Regular"/>
+              </a:defRPr>
+            </a:pPr>
+            <a:r>
+              <a:t>LionWeb implementation of an MCP</a:t>
+            </a:r>
+          </a:p>
+          <a:p>
+            <a:pPr lvl="1" marL="828842" indent="-320842">
+              <a:buAutoNum type="arabicPeriod" startAt="1"/>
+              <a:defRPr>
+                <a:latin typeface="Lato Regular"/>
+                <a:ea typeface="Lato Regular"/>
+                <a:cs typeface="Lato Regular"/>
+                <a:sym typeface="Lato Regular"/>
+              </a:defRPr>
+            </a:pPr>
+            <a:r>
+              <a:t>How to implement an LWB with LionWeb</a:t>
+            </a:r>
+          </a:p>
+          <a:p>
+            <a:pPr lvl="1" marL="828842" indent="-320842">
+              <a:buAutoNum type="arabicPeriod" startAt="1"/>
+              <a:defRPr>
+                <a:latin typeface="Lato Regular"/>
+                <a:ea typeface="Lato Regular"/>
+                <a:cs typeface="Lato Regular"/>
+                <a:sym typeface="Lato Regular"/>
+              </a:defRPr>
+            </a:pPr>
+            <a:r>
+              <a:t>LionWeb as integration platform</a:t>
+            </a:r>
+          </a:p>
+          <a:p>
+            <a:pPr lvl="1" marL="828842" indent="-320842">
+              <a:buAutoNum type="arabicPeriod" startAt="1"/>
+              <a:defRPr>
+                <a:latin typeface="Lato Regular"/>
+                <a:ea typeface="Lato Regular"/>
+                <a:cs typeface="Lato Regular"/>
+                <a:sym typeface="Lato Regular"/>
+              </a:defRPr>
+            </a:pPr>
+          </a:p>
+        </p:txBody>
+      </p:sp>
+    </p:spTree>
+  </p:cSld>
+  <p:clrMapOvr>
+    <a:masterClrMapping/>
+  </p:clrMapOvr>
+  <p:transition xmlns:p14="http://schemas.microsoft.com/office/powerpoint/2010/main" spd="med" advClick="1"/>
+</p:sld>
+</file>
+
+<file path=ppt/slides/slide13.xml><?xml version="1.0" encoding="utf-8"?>
+<p:sld xmlns:a="http://schemas.openxmlformats.org/drawingml/2006/main" xmlns:r="http://schemas.openxmlformats.org/officeDocument/2006/relationships" xmlns:p="http://schemas.openxmlformats.org/presentationml/2006/main" xmlns:m="http://schemas.openxmlformats.org/officeDocument/2006/math" xmlns:a14="http://schemas.microsoft.com/office/drawing/2010/main" showMasterSp="1" showMasterPhAnim="1">
+  <p:cSld>
+    <p:spTree>
+      <p:nvGrpSpPr>
+        <p:cNvPr id="1" name=""/>
+        <p:cNvGrpSpPr/>
+        <p:nvPr/>
+      </p:nvGrpSpPr>
+      <p:grpSpPr>
+        <a:xfrm>
+          <a:off x="0" y="0"/>
+          <a:ext cx="0" cy="0"/>
+          <a:chOff x="0" y="0"/>
+          <a:chExt cx="0" cy="0"/>
+        </a:xfrm>
+      </p:grpSpPr>
       <p:grpSp>
         <p:nvGrpSpPr>
-          <p:cNvPr id="383" name="TextBox 7"/>
+          <p:cNvPr id="387" name="TextBox 7"/>
           <p:cNvGrpSpPr/>
           <p:nvPr/>
         </p:nvGrpSpPr>
@@ -7231,7 +7385,7 @@
         </p:grpSpPr>
         <p:sp>
           <p:nvSpPr>
-            <p:cNvPr id="381" name="Rectangle"/>
+            <p:cNvPr id="385" name="Rectangle"/>
             <p:cNvSpPr/>
             <p:nvPr/>
           </p:nvSpPr>
@@ -7275,7 +7429,7 @@
         </p:sp>
         <p:sp>
           <p:nvSpPr>
-            <p:cNvPr id="382" name="Meinte Boersma DSL Consultancy…"/>
+            <p:cNvPr id="386" name="Meinte Boersma DSL Consultancy…"/>
             <p:cNvSpPr txBox="1"/>
             <p:nvPr/>
           </p:nvSpPr>
@@ -7527,7 +7681,7 @@
       </p:grpSp>
       <p:sp>
         <p:nvSpPr>
-          <p:cNvPr id="384" name="PlaceHolder 1"/>
+          <p:cNvPr id="388" name="PlaceHolder 1"/>
           <p:cNvSpPr txBox="1"/>
           <p:nvPr>
             <p:ph type="title"/>
@@ -7555,7 +7709,7 @@
       </p:sp>
       <p:grpSp>
         <p:nvGrpSpPr>
-          <p:cNvPr id="387" name="Title 1"/>
+          <p:cNvPr id="391" name="Title 1"/>
           <p:cNvGrpSpPr/>
           <p:nvPr/>
         </p:nvGrpSpPr>
@@ -7569,7 +7723,7 @@
         </p:grpSpPr>
         <p:sp>
           <p:nvSpPr>
-            <p:cNvPr id="385" name="Rectangle"/>
+            <p:cNvPr id="389" name="Rectangle"/>
             <p:cNvSpPr/>
             <p:nvPr/>
           </p:nvSpPr>
@@ -7611,7 +7765,7 @@
         </p:sp>
         <p:sp>
           <p:nvSpPr>
-            <p:cNvPr id="386" name="Team"/>
+            <p:cNvPr id="390" name="Team"/>
             <p:cNvSpPr txBox="1"/>
             <p:nvPr/>
           </p:nvSpPr>
@@ -7673,7 +7827,7 @@
       </p:grpSp>
       <p:grpSp>
         <p:nvGrpSpPr>
-          <p:cNvPr id="390" name="TextBox 14"/>
+          <p:cNvPr id="394" name="TextBox 14"/>
           <p:cNvGrpSpPr/>
           <p:nvPr/>
         </p:nvGrpSpPr>
@@ -7687,7 +7841,7 @@
         </p:grpSpPr>
         <p:sp>
           <p:nvSpPr>
-            <p:cNvPr id="388" name="Rectangle"/>
+            <p:cNvPr id="392" name="Rectangle"/>
             <p:cNvSpPr/>
             <p:nvPr/>
           </p:nvSpPr>
@@ -7728,7 +7882,7 @@
         </p:sp>
         <p:sp>
           <p:nvSpPr>
-            <p:cNvPr id="389" name="Want to work with us: GitHub: Web:…"/>
+            <p:cNvPr id="393" name="Want to work with us: GitHub: Web:…"/>
             <p:cNvSpPr txBox="1"/>
             <p:nvPr/>
           </p:nvSpPr>
@@ -7941,7 +8095,7 @@
       </p:grpSp>
       <p:grpSp>
         <p:nvGrpSpPr>
-          <p:cNvPr id="393" name="Title 1"/>
+          <p:cNvPr id="397" name="Title 1"/>
           <p:cNvGrpSpPr/>
           <p:nvPr/>
         </p:nvGrpSpPr>
@@ -7955,7 +8109,7 @@
         </p:grpSpPr>
         <p:sp>
           <p:nvSpPr>
-            <p:cNvPr id="391" name="Rectangle"/>
+            <p:cNvPr id="395" name="Rectangle"/>
             <p:cNvSpPr/>
             <p:nvPr/>
           </p:nvSpPr>
@@ -7997,7 +8151,7 @@
         </p:sp>
         <p:sp>
           <p:nvSpPr>
-            <p:cNvPr id="392" name="Contact"/>
+            <p:cNvPr id="396" name="Contact"/>
             <p:cNvSpPr txBox="1"/>
             <p:nvPr/>
           </p:nvSpPr>
@@ -8059,7 +8213,7 @@
       </p:grpSp>
       <p:grpSp>
         <p:nvGrpSpPr>
-          <p:cNvPr id="396" name="TextBox 15"/>
+          <p:cNvPr id="400" name="TextBox 15"/>
           <p:cNvGrpSpPr/>
           <p:nvPr/>
         </p:nvGrpSpPr>
@@ -8073,7 +8227,7 @@
         </p:grpSpPr>
         <p:sp>
           <p:nvSpPr>
-            <p:cNvPr id="394" name="Rectangle"/>
+            <p:cNvPr id="398" name="Rectangle"/>
             <p:cNvSpPr/>
             <p:nvPr/>
           </p:nvSpPr>
@@ -8117,7 +8271,7 @@
         </p:sp>
         <p:sp>
           <p:nvSpPr>
-            <p:cNvPr id="395" name="Alex Shatalin JetBrains (MPS)…"/>
+            <p:cNvPr id="399" name="Alex Shatalin JetBrains (MPS)…"/>
             <p:cNvSpPr txBox="1"/>
             <p:nvPr/>
           </p:nvSpPr>
@@ -8347,7 +8501,7 @@
                 </a:rPr>
               </a:br>
               <a:r>
-                <a:t>Sergej Zverlov</a:t>
+                <a:t>Sergey Zverlov</a:t>
               </a:r>
               <a:r>
                 <a:rPr>
@@ -8356,7 +8510,7 @@
                   <a:cs typeface="Lato Regular"/>
                   <a:sym typeface="Lato Regular"/>
                 </a:rPr>
-                <a:t>                  </a:t>
+                <a:t>                 </a:t>
               </a:r>
               <a:r>
                 <a:rPr>
@@ -8373,7 +8527,7 @@
       </p:grpSp>
       <p:pic>
         <p:nvPicPr>
-          <p:cNvPr id="397" name="Picture 3" descr="Picture 3"/>
+          <p:cNvPr id="401" name="Picture 3" descr="Picture 3"/>
           <p:cNvPicPr>
             <a:picLocks noChangeAspect="1"/>
           </p:cNvPicPr>
@@ -8402,7 +8556,7 @@
       </p:pic>
       <p:pic>
         <p:nvPicPr>
-          <p:cNvPr id="398" name="Graphic 6" descr="Graphic 6"/>
+          <p:cNvPr id="402" name="Graphic 6" descr="Graphic 6"/>
           <p:cNvPicPr>
             <a:picLocks noChangeAspect="1"/>
           </p:cNvPicPr>
@@ -14784,24 +14938,7 @@
           <a:p>
             <a:pPr/>
             <a:r>
-              <a:t>Reference Architecture (</a:t>
-            </a:r>
-            <a:r>
-              <a:rPr u="sng">
-                <a:solidFill>
-                  <a:srgbClr val="0563C1"/>
-                </a:solidFill>
-                <a:uFill>
-                  <a:solidFill>
-                    <a:srgbClr val="0563C1"/>
-                  </a:solidFill>
-                </a:uFill>
-                <a:hlinkClick r:id="rId2" invalidUrl="" action="" tgtFrame="" tooltip="" history="1" highlightClick="0" endSnd="0"/>
-              </a:rPr>
-              <a:t>link</a:t>
-            </a:r>
-            <a:r>
-              <a:t>)</a:t>
+              <a:t>Reference Architecture</a:t>
             </a:r>
           </a:p>
         </p:txBody>
@@ -16138,8 +16275,8 @@
             </p:nvSpPr>
             <p:spPr>
               <a:xfrm>
-                <a:off x="667445" y="126764"/>
-                <a:ext cx="3895701" cy="828041"/>
+                <a:off x="603513" y="126764"/>
+                <a:ext cx="4023565" cy="828041"/>
               </a:xfrm>
               <a:prstGeom prst="rect">
                 <a:avLst/>
@@ -16193,7 +16330,7 @@
                   </a:defRPr>
                 </a:pPr>
                 <a:r>
-                  <a:t>Contents (JSON + Protobuf)</a:t>
+                  <a:t>Contents (JSON + Protobuf*)</a:t>
                 </a:r>
               </a:p>
             </p:txBody>
@@ -16208,7 +16345,7 @@
             <p:nvPr/>
           </p:nvPicPr>
           <p:blipFill>
-            <a:blip r:embed="rId3">
+            <a:blip r:embed="rId2">
               <a:extLst/>
             </a:blip>
             <a:stretch>
@@ -16240,7 +16377,7 @@
           <p:nvPr/>
         </p:nvPicPr>
         <p:blipFill>
-          <a:blip r:embed="rId3">
+          <a:blip r:embed="rId2">
             <a:extLst/>
           </a:blip>
           <a:stretch>
@@ -17534,6 +17671,61 @@
           </p:grpSp>
         </p:grpSp>
       </p:grpSp>
+      <p:sp>
+        <p:nvSpPr>
+          <p:cNvPr id="356" name="Text Placeholder 2"/>
+          <p:cNvSpPr txBox="1"/>
+          <p:nvPr/>
+        </p:nvSpPr>
+        <p:spPr>
+          <a:xfrm>
+            <a:off x="8264849" y="6342440"/>
+            <a:ext cx="1121758" cy="251637"/>
+          </a:xfrm>
+          <a:prstGeom prst="rect">
+            <a:avLst/>
+          </a:prstGeom>
+          <a:ln w="12700">
+            <a:miter lim="400000"/>
+          </a:ln>
+          <a:extLst>
+            <a:ext uri="{C572A759-6A51-4108-AA02-DFA0A04FC94B}">
+              <ma14:wrappingTextBoxFlag xmlns:ma14="http://schemas.microsoft.com/office/mac/drawingml/2011/main" val="1"/>
+            </a:ext>
+          </a:extLst>
+        </p:spPr>
+        <p:txBody>
+          <a:bodyPr lIns="45719" rIns="45719">
+            <a:normAutofit fontScale="100000" lnSpcReduction="0"/>
+          </a:bodyPr>
+          <a:lstStyle>
+            <a:lvl1pPr indent="95501" defTabSz="438911">
+              <a:lnSpc>
+                <a:spcPct val="115000"/>
+              </a:lnSpc>
+              <a:spcBef>
+                <a:spcPts val="100"/>
+              </a:spcBef>
+              <a:buFont typeface="Arial"/>
+              <a:defRPr sz="1152">
+                <a:solidFill>
+                  <a:srgbClr val="1F2328"/>
+                </a:solidFill>
+                <a:latin typeface="Lato Bold"/>
+                <a:ea typeface="Lato Bold"/>
+                <a:cs typeface="Lato Bold"/>
+                <a:sym typeface="Lato Bold"/>
+              </a:defRPr>
+            </a:lvl1pPr>
+          </a:lstStyle>
+          <a:p>
+            <a:pPr/>
+            <a:r>
+              <a:t>*) unofficial</a:t>
+            </a:r>
+          </a:p>
+        </p:txBody>
+      </p:sp>
     </p:spTree>
   </p:cSld>
   <p:clrMapOvr>
@@ -17562,7 +17754,7 @@
       </p:grpSpPr>
       <p:sp>
         <p:nvSpPr>
-          <p:cNvPr id="357" name="Title 1"/>
+          <p:cNvPr id="358" name="Title 1"/>
           <p:cNvSpPr txBox="1"/>
           <p:nvPr>
             <p:ph type="title"/>
@@ -17590,7 +17782,7 @@
       </p:sp>
       <p:sp>
         <p:nvSpPr>
-          <p:cNvPr id="358" name="Text Placeholder 2"/>
+          <p:cNvPr id="359" name="Text Placeholder 2"/>
           <p:cNvSpPr txBox="1"/>
           <p:nvPr>
             <p:ph type="body" idx="1"/>
@@ -17808,7 +18000,7 @@
               </a:defRPr>
             </a:pPr>
             <a:r>
-              <a:t>MBSE 2025 (</a:t>
+              <a:t>LangDev 2025 (</a:t>
             </a:r>
             <a:r>
               <a:rPr u="sng">
@@ -17821,6 +18013,40 @@
                   </a:solidFill>
                 </a:uFill>
                 <a:hlinkClick r:id="rId9" invalidUrl="" action="" tgtFrame="" tooltip="" history="1" highlightClick="0" endSnd="0"/>
+              </a:rPr>
+              <a:t>slides</a:t>
+            </a:r>
+            <a:r>
+              <a:t>)</a:t>
+            </a:r>
+          </a:p>
+          <a:p>
+            <a:pPr lvl="1" marL="685800" indent="-228600">
+              <a:spcBef>
+                <a:spcPts val="500"/>
+              </a:spcBef>
+              <a:buFont typeface="Arial"/>
+              <a:defRPr sz="2000">
+                <a:latin typeface="Lato Regular"/>
+                <a:ea typeface="Lato Regular"/>
+                <a:cs typeface="Lato Regular"/>
+                <a:sym typeface="Lato Regular"/>
+              </a:defRPr>
+            </a:pPr>
+            <a:r>
+              <a:t>MBSE 2025 (slides, </a:t>
+            </a:r>
+            <a:r>
+              <a:rPr u="sng">
+                <a:solidFill>
+                  <a:srgbClr val="0563C1"/>
+                </a:solidFill>
+                <a:uFill>
+                  <a:solidFill>
+                    <a:srgbClr val="0563C1"/>
+                  </a:solidFill>
+                </a:uFill>
+                <a:hlinkClick r:id="rId10" invalidUrl="" action="" tgtFrame="" tooltip="" history="1" highlightClick="0" endSnd="0"/>
               </a:rPr>
               <a:t>conference</a:t>
             </a:r>
@@ -17842,31 +18068,14 @@
               </a:defRPr>
             </a:pPr>
             <a:r>
-              <a:t>LangDev 2025 (</a:t>
-            </a:r>
-            <a:r>
-              <a:rPr u="sng">
-                <a:solidFill>
-                  <a:srgbClr val="0563C1"/>
-                </a:solidFill>
-                <a:uFill>
-                  <a:solidFill>
-                    <a:srgbClr val="0563C1"/>
-                  </a:solidFill>
-                </a:uFill>
-                <a:hlinkClick r:id="rId10" invalidUrl="" action="" tgtFrame="" tooltip="" history="1" highlightClick="0" endSnd="0"/>
-              </a:rPr>
-              <a:t>slides</a:t>
-            </a:r>
-            <a:r>
-              <a:t>)</a:t>
+              <a:t>MODELS 2026 — Industry Day (slides &lt;== TODO)</a:t>
             </a:r>
           </a:p>
         </p:txBody>
       </p:sp>
       <p:pic>
         <p:nvPicPr>
-          <p:cNvPr id="359" name="Graphic 3" descr="Graphic 3"/>
+          <p:cNvPr id="360" name="Graphic 3" descr="Graphic 3"/>
           <p:cNvPicPr>
             <a:picLocks noChangeAspect="1"/>
           </p:cNvPicPr>
@@ -17921,7 +18130,7 @@
       </p:grpSpPr>
       <p:sp>
         <p:nvSpPr>
-          <p:cNvPr id="361" name="Title 1"/>
+          <p:cNvPr id="362" name="Title 1"/>
           <p:cNvSpPr txBox="1"/>
           <p:nvPr>
             <p:ph type="title"/>
@@ -17942,14 +18151,14 @@
           <a:p>
             <a:pPr/>
             <a:r>
-              <a:t>Other talks about LionWeb @ LangDev 25</a:t>
+              <a:t>Other talks about LionWeb @ LangDev’26</a:t>
             </a:r>
           </a:p>
         </p:txBody>
       </p:sp>
       <p:graphicFrame>
         <p:nvGraphicFramePr>
-          <p:cNvPr id="362" name="Table 13"/>
+          <p:cNvPr id="363" name="Table 13"/>
           <p:cNvGraphicFramePr/>
           <p:nvPr/>
         </p:nvGraphicFramePr>
@@ -18349,7 +18558,7 @@
       </p:grpSpPr>
       <p:sp>
         <p:nvSpPr>
-          <p:cNvPr id="364" name="Title 2"/>
+          <p:cNvPr id="365" name="Title 2"/>
           <p:cNvSpPr txBox="1"/>
           <p:nvPr>
             <p:ph type="title"/>
@@ -18373,7 +18582,7 @@
       </p:sp>
       <p:sp>
         <p:nvSpPr>
-          <p:cNvPr id="365" name="Text Placeholder 4"/>
+          <p:cNvPr id="366" name="Text Placeholder 4"/>
           <p:cNvSpPr txBox="1"/>
           <p:nvPr>
             <p:ph type="body" sz="quarter" idx="1"/>
@@ -18394,7 +18603,7 @@
       </p:sp>
       <p:pic>
         <p:nvPicPr>
-          <p:cNvPr id="366" name="Graphic 5" descr="Graphic 5"/>
+          <p:cNvPr id="367" name="Graphic 5" descr="Graphic 5"/>
           <p:cNvPicPr>
             <a:picLocks noChangeAspect="1"/>
           </p:cNvPicPr>
@@ -18449,7 +18658,7 @@
       </p:grpSpPr>
       <p:sp>
         <p:nvSpPr>
-          <p:cNvPr id="368" name="Title 1"/>
+          <p:cNvPr id="369" name="Title 1"/>
           <p:cNvSpPr txBox="1"/>
           <p:nvPr>
             <p:ph type="title"/>
@@ -18477,7 +18686,7 @@
       </p:sp>
       <p:sp>
         <p:nvSpPr>
-          <p:cNvPr id="369" name="Content Placeholder 2"/>
+          <p:cNvPr id="370" name="Content Placeholder 2"/>
           <p:cNvSpPr txBox="1"/>
           <p:nvPr>
             <p:ph type="body" idx="1"/>
@@ -18513,6 +18722,7 @@
             <a:r>
               <a:t>Sergey Zverlov (F1RE)</a:t>
             </a:r>
+            <a:br/>
           </a:p>
           <a:p>
             <a:pPr marL="342900" indent="-342900"/>
@@ -18535,6 +18745,98 @@
             </a:pPr>
             <a:r>
               <a:t>Once a month (every second Friday) — successful!</a:t>
+            </a:r>
+            <a:br/>
+          </a:p>
+          <a:p>
+            <a:pPr marL="342900" indent="-342900"/>
+            <a:r>
+              <a:t>Progress</a:t>
+            </a:r>
+          </a:p>
+          <a:p>
+            <a:pPr lvl="1" marL="1028700" indent="-342900">
+              <a:spcBef>
+                <a:spcPts val="500"/>
+              </a:spcBef>
+              <a:buFont typeface="Arial"/>
+              <a:defRPr sz="2000">
+                <a:latin typeface="Lato Regular"/>
+                <a:ea typeface="Lato Regular"/>
+                <a:cs typeface="Lato Regular"/>
+                <a:sym typeface="Lato Regular"/>
+              </a:defRPr>
+            </a:pPr>
+            <a:r>
+              <a:t>Released 2026.1 (now!)</a:t>
+            </a:r>
+          </a:p>
+          <a:p>
+            <a:pPr lvl="2" marL="1257300" indent="-342900">
+              <a:spcBef>
+                <a:spcPts val="500"/>
+              </a:spcBef>
+              <a:buFont typeface="Arial"/>
+              <a:defRPr sz="2000">
+                <a:latin typeface="Lato Regular"/>
+                <a:ea typeface="Lato Regular"/>
+                <a:cs typeface="Lato Regular"/>
+                <a:sym typeface="Lato Regular"/>
+              </a:defRPr>
+            </a:pPr>
+            <a:r>
+              <a:t>Main feature: Delta Protocol (</a:t>
+            </a:r>
+            <a:r>
+              <a:rPr u="sng">
+                <a:solidFill>
+                  <a:srgbClr val="0563C1"/>
+                </a:solidFill>
+                <a:uFill>
+                  <a:solidFill>
+                    <a:srgbClr val="0563C1"/>
+                  </a:solidFill>
+                </a:uFill>
+                <a:hlinkClick r:id="rId2" invalidUrl="" action="" tgtFrame="" tooltip="" history="1" highlightClick="0" endSnd="0"/>
+              </a:rPr>
+              <a:t>specification</a:t>
+            </a:r>
+            <a:r>
+              <a:t>)</a:t>
+            </a:r>
+          </a:p>
+          <a:p>
+            <a:pPr lvl="1" marL="1028700" indent="-342900">
+              <a:spcBef>
+                <a:spcPts val="500"/>
+              </a:spcBef>
+              <a:buFont typeface="Arial"/>
+              <a:defRPr sz="2000">
+                <a:latin typeface="Lato Regular"/>
+                <a:ea typeface="Lato Regular"/>
+                <a:cs typeface="Lato Regular"/>
+                <a:sym typeface="Lato Regular"/>
+              </a:defRPr>
+            </a:pPr>
+            <a:r>
+              <a:t>Implementation of Delta Protocol in C#, TypeScript, JVM, and server</a:t>
+            </a:r>
+          </a:p>
+          <a:p>
+            <a:pPr lvl="1" marL="1028700" indent="-342900">
+              <a:spcBef>
+                <a:spcPts val="500"/>
+              </a:spcBef>
+              <a:buFont typeface="Arial"/>
+              <a:defRPr sz="2000">
+                <a:latin typeface="Lato Regular"/>
+                <a:ea typeface="Lato Regular"/>
+                <a:cs typeface="Lato Regular"/>
+                <a:sym typeface="Lato Regular"/>
+              </a:defRPr>
+            </a:pPr>
+            <a:r>
+              <a:t>OpenAPI spec. for Bulk API</a:t>
             </a:r>
           </a:p>
         </p:txBody>
@@ -18567,7 +18869,7 @@
       </p:grpSpPr>
       <p:sp>
         <p:nvSpPr>
-          <p:cNvPr id="371" name="Title 1"/>
+          <p:cNvPr id="372" name="Title 1"/>
           <p:cNvSpPr txBox="1"/>
           <p:nvPr>
             <p:ph type="title"/>
@@ -18588,20 +18890,24 @@
           <a:p>
             <a:pPr/>
             <a:r>
-              <a:t>2026.1 version</a:t>
+              <a:t>Progress</a:t>
             </a:r>
           </a:p>
         </p:txBody>
       </p:sp>
       <p:sp>
         <p:nvSpPr>
-          <p:cNvPr id="372" name="Content Placeholder 2"/>
+          <p:cNvPr id="373" name="Content Placeholder 2"/>
           <p:cNvSpPr txBox="1"/>
           <p:nvPr>
             <p:ph type="body" idx="1"/>
           </p:nvPr>
         </p:nvSpPr>
         <p:spPr>
+          <a:xfrm>
+            <a:off x="614358" y="1483360"/>
+            <a:ext cx="10515601" cy="4867745"/>
+          </a:xfrm>
           <a:prstGeom prst="rect">
             <a:avLst/>
           </a:prstGeom>
@@ -18610,15 +18916,21 @@
           <a:bodyPr/>
           <a:lstStyle/>
           <a:p>
-            <a:pPr/>
+            <a:pPr lvl="1" marL="0" indent="228600">
+              <a:buSzTx/>
+              <a:buNone/>
+            </a:pPr>
             <a:r>
-              <a:t>Released: as of now</a:t>
+              <a:t>Released 2026.1 (now!)</a:t>
             </a:r>
           </a:p>
           <a:p>
-            <a:pPr/>
+            <a:pPr lvl="2" marL="0" indent="457200">
+              <a:buSzTx/>
+              <a:buNone/>
+            </a:pPr>
             <a:r>
-              <a:t>Main feature: delta protocol (</a:t>
+              <a:t>Main feature: Delta Protocol(</a:t>
             </a:r>
             <a:r>
               <a:rPr u="sng">
@@ -18636,6 +18948,24 @@
             </a:r>
             <a:r>
               <a:t>)</a:t>
+            </a:r>
+          </a:p>
+          <a:p>
+            <a:pPr lvl="1" marL="0" indent="228600">
+              <a:buSzTx/>
+              <a:buNone/>
+            </a:pPr>
+            <a:r>
+              <a:t>Implementation of Delta Protocol in C#, TypeScript, JVM, and server</a:t>
+            </a:r>
+          </a:p>
+          <a:p>
+            <a:pPr lvl="1" marL="0" indent="228600">
+              <a:buSzTx/>
+              <a:buNone/>
+            </a:pPr>
+            <a:r>
+              <a:t>OpenAPI spec. for Bulk API</a:t>
             </a:r>
           </a:p>
         </p:txBody>

</xml_diff>

<commit_message>
more updates on slides
</commit_message>
<xml_diff>
--- a/conference-talks/LangDev/2026/LangDev 2026 Talk.pptx
+++ b/conference-talks/LangDev/2026/LangDev 2026 Talk.pptx
@@ -27,6 +27,7 @@
     <p:sldId id="272" r:id="rId24"/>
     <p:sldId id="273" r:id="rId25"/>
     <p:sldId id="274" r:id="rId26"/>
+    <p:sldId id="275" r:id="rId27"/>
   </p:sldIdLst>
   <p:sldSz cx="12192000" cy="6858000"/>
   <p:notesSz cx="6858000" cy="9144000"/>
@@ -7370,7 +7371,7 @@
               </a:defRPr>
             </a:pPr>
             <a:r>
-              <a:t>Separate talk, today @ 17:15:</a:t>
+              <a:t>Separate talk, today (Thursday) @ 17:15:</a:t>
             </a:r>
             <a:br/>
             <a:r>
@@ -7435,6 +7436,35 @@
           </a:ln>
         </p:spPr>
       </p:pic>
+      <p:pic>
+        <p:nvPicPr>
+          <p:cNvPr id="387" name="LogoLateralSquare_trasparente.png" descr="LogoLateralSquare_trasparente.png"/>
+          <p:cNvPicPr>
+            <a:picLocks noChangeAspect="1"/>
+          </p:cNvPicPr>
+          <p:nvPr/>
+        </p:nvPicPr>
+        <p:blipFill>
+          <a:blip r:embed="rId4">
+            <a:extLst/>
+          </a:blip>
+          <a:stretch>
+            <a:fillRect/>
+          </a:stretch>
+        </p:blipFill>
+        <p:spPr>
+          <a:xfrm>
+            <a:off x="113760" y="68261"/>
+            <a:ext cx="1518617" cy="1127725"/>
+          </a:xfrm>
+          <a:prstGeom prst="rect">
+            <a:avLst/>
+          </a:prstGeom>
+          <a:ln w="12700">
+            <a:miter lim="400000"/>
+          </a:ln>
+        </p:spPr>
+      </p:pic>
     </p:spTree>
   </p:cSld>
   <p:clrMapOvr>
@@ -7463,7 +7493,7 @@
       </p:grpSpPr>
       <p:sp>
         <p:nvSpPr>
-          <p:cNvPr id="388" name="Title 1"/>
+          <p:cNvPr id="389" name="Title 1"/>
           <p:cNvSpPr txBox="1"/>
           <p:nvPr>
             <p:ph type="title"/>
@@ -7491,7 +7521,7 @@
       </p:sp>
       <p:sp>
         <p:nvSpPr>
-          <p:cNvPr id="389" name="Content Placeholder 2"/>
+          <p:cNvPr id="390" name="Content Placeholder 2"/>
           <p:cNvSpPr txBox="1"/>
           <p:nvPr>
             <p:ph type="body" idx="1"/>
@@ -7530,7 +7560,11 @@
               </a:defRPr>
             </a:pPr>
             <a:r>
-              <a:t>Save each partition as a separate ZIPped file in a custom Protobuf variant of the LionWeb serialization format</a:t>
+              <a:t>Save each partition as a separate file</a:t>
+            </a:r>
+            <a:br/>
+            <a:r>
+              <a:t>in a custom Protobuf variant of the LionWeb serialization format</a:t>
             </a:r>
           </a:p>
           <a:p>
@@ -7543,7 +7577,7 @@
               </a:defRPr>
             </a:pPr>
             <a:r>
-              <a:t>Intermediate results are stored as annotations ⇒ avoids recomputation</a:t>
+              <a:t>Intermediate results are stored as annotations: avoids recomputation</a:t>
             </a:r>
           </a:p>
           <a:p>
@@ -7576,7 +7610,7 @@
               </a:defRPr>
             </a:pPr>
             <a:r>
-              <a:t>Plenty of “old-fashioned Java optimization” brought to </a:t>
+              <a:t>Plenty of “old-fashioned Java optimizations” brought to </a:t>
             </a:r>
             <a:r>
               <a:rPr>
@@ -7609,6 +7643,35 @@
           </a:p>
         </p:txBody>
       </p:sp>
+      <p:pic>
+        <p:nvPicPr>
+          <p:cNvPr id="391" name="LogoLateralSquare_trasparente.png" descr="LogoLateralSquare_trasparente.png"/>
+          <p:cNvPicPr>
+            <a:picLocks noChangeAspect="1"/>
+          </p:cNvPicPr>
+          <p:nvPr/>
+        </p:nvPicPr>
+        <p:blipFill>
+          <a:blip r:embed="rId2">
+            <a:extLst/>
+          </a:blip>
+          <a:stretch>
+            <a:fillRect/>
+          </a:stretch>
+        </p:blipFill>
+        <p:spPr>
+          <a:xfrm>
+            <a:off x="113760" y="68261"/>
+            <a:ext cx="1518617" cy="1127725"/>
+          </a:xfrm>
+          <a:prstGeom prst="rect">
+            <a:avLst/>
+          </a:prstGeom>
+          <a:ln w="12700">
+            <a:miter lim="400000"/>
+          </a:ln>
+        </p:spPr>
+      </p:pic>
     </p:spTree>
   </p:cSld>
   <p:clrMapOvr>
@@ -7637,7 +7700,7 @@
       </p:grpSpPr>
       <p:sp>
         <p:nvSpPr>
-          <p:cNvPr id="391" name="Title 1"/>
+          <p:cNvPr id="393" name="Title 1"/>
           <p:cNvSpPr txBox="1"/>
           <p:nvPr>
             <p:ph type="title"/>
@@ -7665,7 +7728,7 @@
       </p:sp>
       <p:sp>
         <p:nvSpPr>
-          <p:cNvPr id="392" name="Content Placeholder 2"/>
+          <p:cNvPr id="394" name="Content Placeholder 2"/>
           <p:cNvSpPr txBox="1"/>
           <p:nvPr>
             <p:ph type="body" idx="1"/>
@@ -7680,8 +7743,11 @@
           <a:bodyPr/>
           <a:lstStyle/>
           <a:p>
-            <a:pPr>
-              <a:defRPr>
+            <a:pPr defTabSz="841247">
+              <a:spcBef>
+                <a:spcPts val="700"/>
+              </a:spcBef>
+              <a:defRPr sz="2208">
                 <a:latin typeface="Lato Regular"/>
                 <a:ea typeface="Lato Regular"/>
                 <a:cs typeface="Lato Regular"/>
@@ -7689,7 +7755,7 @@
               </a:defRPr>
             </a:pPr>
             <a:r>
-              <a:t>Separate talk, tomorrow @ 8:30:</a:t>
+              <a:t>Separate talk, tomorrow (Friday) @ 8:30:</a:t>
             </a:r>
             <a:br/>
             <a:r>
@@ -7708,8 +7774,11 @@
             </a:r>
           </a:p>
           <a:p>
-            <a:pPr>
-              <a:defRPr>
+            <a:pPr defTabSz="841247">
+              <a:spcBef>
+                <a:spcPts val="700"/>
+              </a:spcBef>
+              <a:defRPr sz="2208">
                 <a:latin typeface="Lato Regular"/>
                 <a:ea typeface="Lato Regular"/>
                 <a:cs typeface="Lato Regular"/>
@@ -7718,8 +7787,11 @@
             </a:pPr>
           </a:p>
           <a:p>
-            <a:pPr>
-              <a:defRPr>
+            <a:pPr defTabSz="841247">
+              <a:spcBef>
+                <a:spcPts val="700"/>
+              </a:spcBef>
+              <a:defRPr sz="2208">
                 <a:latin typeface="Lato Regular"/>
                 <a:ea typeface="Lato Regular"/>
                 <a:cs typeface="Lato Regular"/>
@@ -7727,12 +7799,28 @@
               </a:defRPr>
             </a:pPr>
             <a:r>
-              <a:t>Highlights:</a:t>
+              <a:t>Use case: a laser CAM system with its application data held as a LionWeb model that’s replicated across multiple components</a:t>
             </a:r>
           </a:p>
           <a:p>
-            <a:pPr lvl="1" marL="621631" indent="-240631">
-              <a:defRPr>
+            <a:pPr defTabSz="841247">
+              <a:spcBef>
+                <a:spcPts val="700"/>
+              </a:spcBef>
+              <a:defRPr sz="2208">
+                <a:latin typeface="Lato Regular"/>
+                <a:ea typeface="Lato Regular"/>
+                <a:cs typeface="Lato Regular"/>
+                <a:sym typeface="Lato Regular"/>
+              </a:defRPr>
+            </a:pPr>
+          </a:p>
+          <a:p>
+            <a:pPr defTabSz="841247">
+              <a:spcBef>
+                <a:spcPts val="700"/>
+              </a:spcBef>
+              <a:defRPr sz="2208">
                 <a:latin typeface="Lato Regular"/>
                 <a:ea typeface="Lato Regular"/>
                 <a:cs typeface="Lato Regular"/>
@@ -7740,11 +7828,92 @@
               </a:defRPr>
             </a:pPr>
             <a:r>
-              <a:t>Niko?</a:t>
+              <a:t>Key takeaways:</a:t>
+            </a:r>
+          </a:p>
+          <a:p>
+            <a:pPr lvl="1" marL="571901" indent="-221381" defTabSz="841247">
+              <a:spcBef>
+                <a:spcPts val="700"/>
+              </a:spcBef>
+              <a:defRPr sz="2208">
+                <a:latin typeface="Lato Regular"/>
+                <a:ea typeface="Lato Regular"/>
+                <a:cs typeface="Lato Regular"/>
+                <a:sym typeface="Lato Regular"/>
+              </a:defRPr>
+            </a:pPr>
+            <a:r>
+              <a:t>The project turned out to need most of LionWeb’s capabilities (Delta, Bulk, etc.)</a:t>
+            </a:r>
+          </a:p>
+          <a:p>
+            <a:pPr lvl="1" marL="571901" indent="-221381" defTabSz="841247">
+              <a:spcBef>
+                <a:spcPts val="700"/>
+              </a:spcBef>
+              <a:defRPr sz="2208">
+                <a:latin typeface="Lato Regular"/>
+                <a:ea typeface="Lato Regular"/>
+                <a:cs typeface="Lato Regular"/>
+                <a:sym typeface="Lato Regular"/>
+              </a:defRPr>
+            </a:pPr>
+            <a:r>
+              <a:t>Delta protocol is used as a mechanism to sync a replicated model</a:t>
+            </a:r>
+          </a:p>
+          <a:p>
+            <a:pPr lvl="1" marL="571901" indent="-221381" defTabSz="841247">
+              <a:spcBef>
+                <a:spcPts val="700"/>
+              </a:spcBef>
+              <a:defRPr sz="2208">
+                <a:latin typeface="Lato Regular"/>
+                <a:ea typeface="Lato Regular"/>
+                <a:cs typeface="Lato Regular"/>
+                <a:sym typeface="Lato Regular"/>
+              </a:defRPr>
+            </a:pPr>
+            <a:r>
+              <a:t>TRUMPF funded the LionWeb open source work</a:t>
+            </a:r>
+            <a:br/>
+            <a:r>
+              <a:t>— especially the C# and TypeScript implementations</a:t>
             </a:r>
           </a:p>
         </p:txBody>
       </p:sp>
+      <p:pic>
+        <p:nvPicPr>
+          <p:cNvPr id="395" name="Logo_Trumpf.svg" descr="Logo_Trumpf.svg"/>
+          <p:cNvPicPr>
+            <a:picLocks noChangeAspect="1"/>
+          </p:cNvPicPr>
+          <p:nvPr/>
+        </p:nvPicPr>
+        <p:blipFill>
+          <a:blip r:embed="rId3">
+            <a:extLst/>
+          </a:blip>
+          <a:stretch>
+            <a:fillRect/>
+          </a:stretch>
+        </p:blipFill>
+        <p:spPr>
+          <a:xfrm>
+            <a:off x="175980" y="117455"/>
+            <a:ext cx="1031451" cy="1029337"/>
+          </a:xfrm>
+          <a:prstGeom prst="rect">
+            <a:avLst/>
+          </a:prstGeom>
+          <a:ln w="12700">
+            <a:miter lim="400000"/>
+          </a:ln>
+        </p:spPr>
+      </p:pic>
     </p:spTree>
   </p:cSld>
   <p:clrMapOvr>
@@ -7773,7 +7942,7 @@
       </p:grpSpPr>
       <p:sp>
         <p:nvSpPr>
-          <p:cNvPr id="394" name="Title 1"/>
+          <p:cNvPr id="397" name="Title 1"/>
           <p:cNvSpPr txBox="1"/>
           <p:nvPr>
             <p:ph type="title"/>
@@ -7801,95 +7970,140 @@
       </p:sp>
       <p:sp>
         <p:nvSpPr>
-          <p:cNvPr id="395" name="Content Placeholder 2"/>
+          <p:cNvPr id="398" name="Content Placeholder 2"/>
           <p:cNvSpPr txBox="1"/>
           <p:nvPr>
             <p:ph type="body" idx="1"/>
           </p:nvPr>
         </p:nvSpPr>
         <p:spPr>
+          <a:xfrm>
+            <a:off x="838200" y="1483360"/>
+            <a:ext cx="10515600" cy="5032825"/>
+          </a:xfrm>
           <a:prstGeom prst="rect">
             <a:avLst/>
           </a:prstGeom>
         </p:spPr>
         <p:txBody>
           <a:bodyPr/>
-          <a:lstStyle>
-            <a:lvl1pPr>
+          <a:lstStyle/>
+          <a:p>
+            <a:pPr>
               <a:defRPr>
                 <a:latin typeface="Lato Regular"/>
                 <a:ea typeface="Lato Regular"/>
                 <a:cs typeface="Lato Regular"/>
                 <a:sym typeface="Lato Regular"/>
               </a:defRPr>
-            </a:lvl1pPr>
-          </a:lstStyle>
+            </a:pPr>
+            <a:r>
+              <a:t>Atanas Marchev (F1RE) built a LionWeb MCP server:</a:t>
+            </a:r>
+          </a:p>
           <a:p>
-            <a:pPr/>
+            <a:pPr lvl="1" marL="621631" indent="-240631">
+              <a:defRPr>
+                <a:latin typeface="Lato Regular"/>
+                <a:ea typeface="Lato Regular"/>
+                <a:cs typeface="Lato Regular"/>
+                <a:sym typeface="Lato Regular"/>
+              </a:defRPr>
+            </a:pPr>
             <a:r>
-              <a:t>Atanas Marchev (F1RE) built a MCP server that exposes LionWeb repositories through MCP tools that are LionWeb-specific (but aspecific to LionWeb languages)</a:t>
+              <a:t>Exposes models in MPS as LionWeb repositories through MCP tools</a:t>
+            </a:r>
+            <a:br/>
+          </a:p>
+          <a:p>
+            <a:pPr lvl="1" marL="621631" indent="-240631">
+              <a:defRPr>
+                <a:latin typeface="Lato Regular"/>
+                <a:ea typeface="Lato Regular"/>
+                <a:cs typeface="Lato Regular"/>
+                <a:sym typeface="Lato Regular"/>
+              </a:defRPr>
+            </a:pPr>
+            <a:r>
+              <a:t>These MCP tools are LionWeb-specific,</a:t>
+            </a:r>
+            <a:br/>
+            <a:r>
+              <a:t>but </a:t>
+            </a:r>
+            <a:r>
+              <a:rPr>
+                <a:latin typeface="Lato Bold"/>
+                <a:ea typeface="Lato Bold"/>
+                <a:cs typeface="Lato Bold"/>
+                <a:sym typeface="Lato Bold"/>
+              </a:rPr>
+              <a:t>a</a:t>
+            </a:r>
+            <a:r>
+              <a:t>specific to specific LionWeb languages.</a:t>
+            </a:r>
+            <a:br/>
+            <a:r>
+              <a:t>    Examples:</a:t>
+            </a:r>
+          </a:p>
+          <a:p>
+            <a:pPr lvl="3" marL="1383631" indent="-240631">
+              <a:defRPr>
+                <a:latin typeface="Inconsolata"/>
+                <a:ea typeface="Inconsolata"/>
+                <a:cs typeface="Inconsolata"/>
+                <a:sym typeface="Inconsolata"/>
+              </a:defRPr>
+            </a:pPr>
+            <a:r>
+              <a:t>findNodeByName</a:t>
+            </a:r>
+          </a:p>
+          <a:p>
+            <a:pPr lvl="3" marL="1383631" indent="-240631">
+              <a:defRPr>
+                <a:latin typeface="Inconsolata"/>
+                <a:ea typeface="Inconsolata"/>
+                <a:cs typeface="Inconsolata"/>
+                <a:sym typeface="Inconsolata"/>
+              </a:defRPr>
+            </a:pPr>
+            <a:r>
+              <a:t>changePropertyValue</a:t>
+            </a:r>
+            <a:br/>
+          </a:p>
+          <a:p>
+            <a:pPr lvl="1" marL="621631" indent="-240631">
+              <a:defRPr>
+                <a:latin typeface="Lato Regular"/>
+                <a:ea typeface="Lato Regular"/>
+                <a:cs typeface="Lato Regular"/>
+                <a:sym typeface="Lato Regular"/>
+              </a:defRPr>
+            </a:pPr>
+            <a:r>
+              <a:t>Uses a LLM-powered chatbot to interact with the repositories</a:t>
+            </a:r>
+            <a:br/>
+          </a:p>
+          <a:p>
+            <a:pPr lvl="1" marL="621631" indent="-240631">
+              <a:defRPr>
+                <a:latin typeface="Lato Regular"/>
+                <a:ea typeface="Lato Regular"/>
+                <a:cs typeface="Lato Regular"/>
+                <a:sym typeface="Lato Regular"/>
+              </a:defRPr>
+            </a:pPr>
+            <a:r>
+              <a:t>Demoed: interrogate and manipulate RegelSpraak model in ALEF</a:t>
             </a:r>
           </a:p>
         </p:txBody>
       </p:sp>
-      <p:pic>
-        <p:nvPicPr>
-          <p:cNvPr id="396" name="Screenshot 2026-09-25 at 11.05.43.png" descr="Screenshot 2026-09-25 at 11.05.43.png"/>
-          <p:cNvPicPr>
-            <a:picLocks noChangeAspect="1"/>
-          </p:cNvPicPr>
-          <p:nvPr/>
-        </p:nvPicPr>
-        <p:blipFill>
-          <a:blip r:embed="rId2">
-            <a:extLst/>
-          </a:blip>
-          <a:stretch>
-            <a:fillRect/>
-          </a:stretch>
-        </p:blipFill>
-        <p:spPr>
-          <a:xfrm>
-            <a:off x="273937" y="2990425"/>
-            <a:ext cx="6713839" cy="3646033"/>
-          </a:xfrm>
-          <a:prstGeom prst="rect">
-            <a:avLst/>
-          </a:prstGeom>
-          <a:ln w="12700">
-            <a:miter lim="400000"/>
-          </a:ln>
-        </p:spPr>
-      </p:pic>
-      <p:pic>
-        <p:nvPicPr>
-          <p:cNvPr id="397" name="Screenshot 2026-09-25 at 11.05.25.png" descr="Screenshot 2026-09-25 at 11.05.25.png"/>
-          <p:cNvPicPr>
-            <a:picLocks noChangeAspect="1"/>
-          </p:cNvPicPr>
-          <p:nvPr/>
-        </p:nvPicPr>
-        <p:blipFill>
-          <a:blip r:embed="rId3">
-            <a:extLst/>
-          </a:blip>
-          <a:stretch>
-            <a:fillRect/>
-          </a:stretch>
-        </p:blipFill>
-        <p:spPr>
-          <a:xfrm>
-            <a:off x="6187135" y="2718950"/>
-            <a:ext cx="5734913" cy="1870407"/>
-          </a:xfrm>
-          <a:prstGeom prst="rect">
-            <a:avLst/>
-          </a:prstGeom>
-          <a:ln w="12700">
-            <a:miter lim="400000"/>
-          </a:ln>
-        </p:spPr>
-      </p:pic>
     </p:spTree>
   </p:cSld>
   <p:clrMapOvr>
@@ -7918,7 +8132,7 @@
       </p:grpSpPr>
       <p:sp>
         <p:nvSpPr>
-          <p:cNvPr id="399" name="Title 1"/>
+          <p:cNvPr id="400" name="Title 1"/>
           <p:cNvSpPr txBox="1"/>
           <p:nvPr>
             <p:ph type="title"/>
@@ -7939,44 +8153,69 @@
           <a:p>
             <a:pPr/>
             <a:r>
-              <a:t>LionWeb-driven integration platform</a:t>
+              <a:t>LionWeb MCP</a:t>
             </a:r>
           </a:p>
         </p:txBody>
       </p:sp>
-      <p:sp>
-        <p:nvSpPr>
-          <p:cNvPr id="400" name="Content Placeholder 2"/>
-          <p:cNvSpPr txBox="1"/>
-          <p:nvPr>
-            <p:ph type="body" idx="1"/>
-          </p:nvPr>
-        </p:nvSpPr>
+      <p:pic>
+        <p:nvPicPr>
+          <p:cNvPr id="401" name="Screenshot 2026-09-25 at 11.05.43.png" descr="Screenshot 2026-09-25 at 11.05.43.png"/>
+          <p:cNvPicPr>
+            <a:picLocks noChangeAspect="1"/>
+          </p:cNvPicPr>
+          <p:nvPr/>
+        </p:nvPicPr>
+        <p:blipFill>
+          <a:blip r:embed="rId2">
+            <a:extLst/>
+          </a:blip>
+          <a:stretch>
+            <a:fillRect/>
+          </a:stretch>
+        </p:blipFill>
         <p:spPr>
+          <a:xfrm>
+            <a:off x="318407" y="1330238"/>
+            <a:ext cx="9461972" cy="5138440"/>
+          </a:xfrm>
           <a:prstGeom prst="rect">
             <a:avLst/>
           </a:prstGeom>
+          <a:ln w="12700">
+            <a:miter lim="400000"/>
+          </a:ln>
         </p:spPr>
-        <p:txBody>
-          <a:bodyPr/>
-          <a:lstStyle>
-            <a:lvl1pPr>
-              <a:defRPr>
-                <a:latin typeface="Lato Regular"/>
-                <a:ea typeface="Lato Regular"/>
-                <a:cs typeface="Lato Regular"/>
-                <a:sym typeface="Lato Regular"/>
-              </a:defRPr>
-            </a:lvl1pPr>
-          </a:lstStyle>
-          <a:p>
-            <a:pPr/>
-            <a:r>
-              <a:t>Niko?</a:t>
-            </a:r>
-          </a:p>
-        </p:txBody>
-      </p:sp>
+      </p:pic>
+      <p:pic>
+        <p:nvPicPr>
+          <p:cNvPr id="402" name="Screenshot 2026-09-25 at 11.05.25.png" descr="Screenshot 2026-09-25 at 11.05.25.png"/>
+          <p:cNvPicPr>
+            <a:picLocks noChangeAspect="1"/>
+          </p:cNvPicPr>
+          <p:nvPr/>
+        </p:nvPicPr>
+        <p:blipFill>
+          <a:blip r:embed="rId3">
+            <a:extLst/>
+          </a:blip>
+          <a:stretch>
+            <a:fillRect/>
+          </a:stretch>
+        </p:blipFill>
+        <p:spPr>
+          <a:xfrm>
+            <a:off x="6372424" y="1451575"/>
+            <a:ext cx="5734913" cy="1870407"/>
+          </a:xfrm>
+          <a:prstGeom prst="rect">
+            <a:avLst/>
+          </a:prstGeom>
+          <a:ln w="12700">
+            <a:miter lim="400000"/>
+          </a:ln>
+        </p:spPr>
+      </p:pic>
     </p:spTree>
   </p:cSld>
   <p:clrMapOvr>
@@ -8005,7 +8244,7 @@
       </p:grpSpPr>
       <p:sp>
         <p:nvSpPr>
-          <p:cNvPr id="402" name="Title 1"/>
+          <p:cNvPr id="404" name="Title 1"/>
           <p:cNvSpPr txBox="1"/>
           <p:nvPr>
             <p:ph type="title"/>
@@ -8026,14 +8265,14 @@
           <a:p>
             <a:pPr/>
             <a:r>
-              <a:t>LionWeb-driven LWB</a:t>
+              <a:t>LionWeb-driven integration platform</a:t>
             </a:r>
           </a:p>
         </p:txBody>
       </p:sp>
       <p:sp>
         <p:nvSpPr>
-          <p:cNvPr id="403" name="Content Placeholder 2"/>
+          <p:cNvPr id="405" name="Content Placeholder 2"/>
           <p:cNvSpPr txBox="1"/>
           <p:nvPr>
             <p:ph type="body" idx="1"/>
@@ -8090,9 +8329,196 @@
           <a:chExt cx="0" cy="0"/>
         </a:xfrm>
       </p:grpSpPr>
+      <p:sp>
+        <p:nvSpPr>
+          <p:cNvPr id="407" name="Title 1"/>
+          <p:cNvSpPr txBox="1"/>
+          <p:nvPr>
+            <p:ph type="title"/>
+          </p:nvPr>
+        </p:nvSpPr>
+        <p:spPr>
+          <a:xfrm>
+            <a:off x="0" y="0"/>
+            <a:ext cx="12192000" cy="1264249"/>
+          </a:xfrm>
+          <a:prstGeom prst="rect">
+            <a:avLst/>
+          </a:prstGeom>
+        </p:spPr>
+        <p:txBody>
+          <a:bodyPr/>
+          <a:lstStyle/>
+          <a:p>
+            <a:pPr/>
+            <a:r>
+              <a:t>LionWeb-driven LWB</a:t>
+            </a:r>
+          </a:p>
+        </p:txBody>
+      </p:sp>
+      <p:sp>
+        <p:nvSpPr>
+          <p:cNvPr id="408" name="Content Placeholder 2"/>
+          <p:cNvSpPr txBox="1"/>
+          <p:nvPr>
+            <p:ph type="body" idx="1"/>
+          </p:nvPr>
+        </p:nvSpPr>
+        <p:spPr>
+          <a:prstGeom prst="rect">
+            <a:avLst/>
+          </a:prstGeom>
+        </p:spPr>
+        <p:txBody>
+          <a:bodyPr/>
+          <a:lstStyle>
+            <a:lvl1pPr>
+              <a:defRPr>
+                <a:latin typeface="Lato Regular"/>
+                <a:ea typeface="Lato Regular"/>
+                <a:cs typeface="Lato Regular"/>
+                <a:sym typeface="Lato Regular"/>
+              </a:defRPr>
+            </a:lvl1pPr>
+          </a:lstStyle>
+          <a:p>
+            <a:pPr/>
+            <a:r>
+              <a:t>Niko?</a:t>
+            </a:r>
+          </a:p>
+        </p:txBody>
+      </p:sp>
+    </p:spTree>
+  </p:cSld>
+  <p:clrMapOvr>
+    <a:masterClrMapping/>
+  </p:clrMapOvr>
+  <p:transition xmlns:p14="http://schemas.microsoft.com/office/powerpoint/2010/main" spd="med" advClick="1"/>
+</p:sld>
+</file>
+
+<file path=ppt/slides/slide2.xml><?xml version="1.0" encoding="utf-8"?>
+<p:sld xmlns:a="http://schemas.openxmlformats.org/drawingml/2006/main" xmlns:r="http://schemas.openxmlformats.org/officeDocument/2006/relationships" xmlns:p="http://schemas.openxmlformats.org/presentationml/2006/main" xmlns:m="http://schemas.openxmlformats.org/officeDocument/2006/math" xmlns:a14="http://schemas.microsoft.com/office/drawing/2010/main" showMasterSp="1" showMasterPhAnim="1">
+  <p:cSld>
+    <p:spTree>
+      <p:nvGrpSpPr>
+        <p:cNvPr id="1" name=""/>
+        <p:cNvGrpSpPr/>
+        <p:nvPr/>
+      </p:nvGrpSpPr>
+      <p:grpSpPr>
+        <a:xfrm>
+          <a:off x="0" y="0"/>
+          <a:ext cx="0" cy="0"/>
+          <a:chOff x="0" y="0"/>
+          <a:chExt cx="0" cy="0"/>
+        </a:xfrm>
+      </p:grpSpPr>
+      <p:sp>
+        <p:nvSpPr>
+          <p:cNvPr id="166" name="Title 2"/>
+          <p:cNvSpPr txBox="1"/>
+          <p:nvPr>
+            <p:ph type="title"/>
+          </p:nvPr>
+        </p:nvSpPr>
+        <p:spPr>
+          <a:prstGeom prst="rect">
+            <a:avLst/>
+          </a:prstGeom>
+        </p:spPr>
+        <p:txBody>
+          <a:bodyPr/>
+          <a:lstStyle/>
+          <a:p>
+            <a:pPr/>
+            <a:r>
+              <a:t>Short introduction</a:t>
+            </a:r>
+          </a:p>
+        </p:txBody>
+      </p:sp>
+      <p:sp>
+        <p:nvSpPr>
+          <p:cNvPr id="167" name="Text Placeholder 4"/>
+          <p:cNvSpPr txBox="1"/>
+          <p:nvPr>
+            <p:ph type="body" sz="quarter" idx="1"/>
+          </p:nvPr>
+        </p:nvSpPr>
+        <p:spPr>
+          <a:prstGeom prst="rect">
+            <a:avLst/>
+          </a:prstGeom>
+        </p:spPr>
+        <p:txBody>
+          <a:bodyPr/>
+          <a:lstStyle/>
+          <a:p>
+            <a:pPr/>
+          </a:p>
+        </p:txBody>
+      </p:sp>
+      <p:pic>
+        <p:nvPicPr>
+          <p:cNvPr id="168" name="Graphic 5" descr="Graphic 5"/>
+          <p:cNvPicPr>
+            <a:picLocks noChangeAspect="1"/>
+          </p:cNvPicPr>
+          <p:nvPr/>
+        </p:nvPicPr>
+        <p:blipFill>
+          <a:blip r:embed="rId2">
+            <a:extLst/>
+          </a:blip>
+          <a:stretch>
+            <a:fillRect/>
+          </a:stretch>
+        </p:blipFill>
+        <p:spPr>
+          <a:xfrm>
+            <a:off x="5535121" y="3394947"/>
+            <a:ext cx="1121758" cy="1127725"/>
+          </a:xfrm>
+          <a:prstGeom prst="rect">
+            <a:avLst/>
+          </a:prstGeom>
+          <a:ln w="12700">
+            <a:miter lim="400000"/>
+          </a:ln>
+        </p:spPr>
+      </p:pic>
+    </p:spTree>
+  </p:cSld>
+  <p:clrMapOvr>
+    <a:masterClrMapping/>
+  </p:clrMapOvr>
+  <p:transition xmlns:p14="http://schemas.microsoft.com/office/powerpoint/2010/main" spd="med" advClick="1"/>
+</p:sld>
+</file>
+
+<file path=ppt/slides/slide20.xml><?xml version="1.0" encoding="utf-8"?>
+<p:sld xmlns:a="http://schemas.openxmlformats.org/drawingml/2006/main" xmlns:r="http://schemas.openxmlformats.org/officeDocument/2006/relationships" xmlns:p="http://schemas.openxmlformats.org/presentationml/2006/main" xmlns:m="http://schemas.openxmlformats.org/officeDocument/2006/math" xmlns:a14="http://schemas.microsoft.com/office/drawing/2010/main" showMasterSp="1" showMasterPhAnim="1">
+  <p:cSld>
+    <p:spTree>
+      <p:nvGrpSpPr>
+        <p:cNvPr id="1" name=""/>
+        <p:cNvGrpSpPr/>
+        <p:nvPr/>
+      </p:nvGrpSpPr>
+      <p:grpSpPr>
+        <a:xfrm>
+          <a:off x="0" y="0"/>
+          <a:ext cx="0" cy="0"/>
+          <a:chOff x="0" y="0"/>
+          <a:chExt cx="0" cy="0"/>
+        </a:xfrm>
+      </p:grpSpPr>
       <p:grpSp>
         <p:nvGrpSpPr>
-          <p:cNvPr id="407" name="TextBox 7"/>
+          <p:cNvPr id="412" name="TextBox 7"/>
           <p:cNvGrpSpPr/>
           <p:nvPr/>
         </p:nvGrpSpPr>
@@ -8106,7 +8532,7 @@
         </p:grpSpPr>
         <p:sp>
           <p:nvSpPr>
-            <p:cNvPr id="405" name="Rectangle"/>
+            <p:cNvPr id="410" name="Rectangle"/>
             <p:cNvSpPr/>
             <p:nvPr/>
           </p:nvSpPr>
@@ -8150,7 +8576,7 @@
         </p:sp>
         <p:sp>
           <p:nvSpPr>
-            <p:cNvPr id="406" name="Meinte Boersma DSL Consultancy…"/>
+            <p:cNvPr id="411" name="Meinte Boersma DSL Consultancy…"/>
             <p:cNvSpPr txBox="1"/>
             <p:nvPr/>
           </p:nvSpPr>
@@ -8402,7 +8828,7 @@
       </p:grpSp>
       <p:sp>
         <p:nvSpPr>
-          <p:cNvPr id="408" name="PlaceHolder 1"/>
+          <p:cNvPr id="413" name="PlaceHolder 1"/>
           <p:cNvSpPr txBox="1"/>
           <p:nvPr>
             <p:ph type="title"/>
@@ -8430,7 +8856,7 @@
       </p:sp>
       <p:grpSp>
         <p:nvGrpSpPr>
-          <p:cNvPr id="411" name="Title 1"/>
+          <p:cNvPr id="416" name="Title 1"/>
           <p:cNvGrpSpPr/>
           <p:nvPr/>
         </p:nvGrpSpPr>
@@ -8444,7 +8870,7 @@
         </p:grpSpPr>
         <p:sp>
           <p:nvSpPr>
-            <p:cNvPr id="409" name="Rectangle"/>
+            <p:cNvPr id="414" name="Rectangle"/>
             <p:cNvSpPr/>
             <p:nvPr/>
           </p:nvSpPr>
@@ -8486,7 +8912,7 @@
         </p:sp>
         <p:sp>
           <p:nvSpPr>
-            <p:cNvPr id="410" name="Team"/>
+            <p:cNvPr id="415" name="Team"/>
             <p:cNvSpPr txBox="1"/>
             <p:nvPr/>
           </p:nvSpPr>
@@ -8548,7 +8974,7 @@
       </p:grpSp>
       <p:grpSp>
         <p:nvGrpSpPr>
-          <p:cNvPr id="414" name="TextBox 14"/>
+          <p:cNvPr id="419" name="TextBox 14"/>
           <p:cNvGrpSpPr/>
           <p:nvPr/>
         </p:nvGrpSpPr>
@@ -8562,7 +8988,7 @@
         </p:grpSpPr>
         <p:sp>
           <p:nvSpPr>
-            <p:cNvPr id="412" name="Rectangle"/>
+            <p:cNvPr id="417" name="Rectangle"/>
             <p:cNvSpPr/>
             <p:nvPr/>
           </p:nvSpPr>
@@ -8603,7 +9029,7 @@
         </p:sp>
         <p:sp>
           <p:nvSpPr>
-            <p:cNvPr id="413" name="Want to work with us: GitHub: Web:…"/>
+            <p:cNvPr id="418" name="Want to work with us: GitHub: Web:…"/>
             <p:cNvSpPr txBox="1"/>
             <p:nvPr/>
           </p:nvSpPr>
@@ -8816,7 +9242,7 @@
       </p:grpSp>
       <p:grpSp>
         <p:nvGrpSpPr>
-          <p:cNvPr id="417" name="Title 1"/>
+          <p:cNvPr id="422" name="Title 1"/>
           <p:cNvGrpSpPr/>
           <p:nvPr/>
         </p:nvGrpSpPr>
@@ -8830,7 +9256,7 @@
         </p:grpSpPr>
         <p:sp>
           <p:nvSpPr>
-            <p:cNvPr id="415" name="Rectangle"/>
+            <p:cNvPr id="420" name="Rectangle"/>
             <p:cNvSpPr/>
             <p:nvPr/>
           </p:nvSpPr>
@@ -8872,7 +9298,7 @@
         </p:sp>
         <p:sp>
           <p:nvSpPr>
-            <p:cNvPr id="416" name="Contact"/>
+            <p:cNvPr id="421" name="Contact"/>
             <p:cNvSpPr txBox="1"/>
             <p:nvPr/>
           </p:nvSpPr>
@@ -8934,7 +9360,7 @@
       </p:grpSp>
       <p:grpSp>
         <p:nvGrpSpPr>
-          <p:cNvPr id="420" name="TextBox 15"/>
+          <p:cNvPr id="425" name="TextBox 15"/>
           <p:cNvGrpSpPr/>
           <p:nvPr/>
         </p:nvGrpSpPr>
@@ -8948,7 +9374,7 @@
         </p:grpSpPr>
         <p:sp>
           <p:nvSpPr>
-            <p:cNvPr id="418" name="Rectangle"/>
+            <p:cNvPr id="423" name="Rectangle"/>
             <p:cNvSpPr/>
             <p:nvPr/>
           </p:nvSpPr>
@@ -8992,7 +9418,7 @@
         </p:sp>
         <p:sp>
           <p:nvSpPr>
-            <p:cNvPr id="419" name="Alex Shatalin JetBrains (MPS)…"/>
+            <p:cNvPr id="424" name="Alex Shatalin JetBrains (MPS)…"/>
             <p:cNvSpPr txBox="1"/>
             <p:nvPr/>
           </p:nvSpPr>
@@ -9248,7 +9674,7 @@
       </p:grpSp>
       <p:pic>
         <p:nvPicPr>
-          <p:cNvPr id="421" name="Picture 3" descr="Picture 3"/>
+          <p:cNvPr id="426" name="Picture 3" descr="Picture 3"/>
           <p:cNvPicPr>
             <a:picLocks noChangeAspect="1"/>
           </p:cNvPicPr>
@@ -9277,7 +9703,7 @@
       </p:pic>
       <p:pic>
         <p:nvPicPr>
-          <p:cNvPr id="422" name="Graphic 6" descr="Graphic 6"/>
+          <p:cNvPr id="427" name="Graphic 6" descr="Graphic 6"/>
           <p:cNvPicPr>
             <a:picLocks noChangeAspect="1"/>
           </p:cNvPicPr>
@@ -9295,106 +9721,6 @@
           <a:xfrm>
             <a:off x="10931400" y="68399"/>
             <a:ext cx="1121401" cy="1127522"/>
-          </a:xfrm>
-          <a:prstGeom prst="rect">
-            <a:avLst/>
-          </a:prstGeom>
-          <a:ln w="12700">
-            <a:miter lim="400000"/>
-          </a:ln>
-        </p:spPr>
-      </p:pic>
-    </p:spTree>
-  </p:cSld>
-  <p:clrMapOvr>
-    <a:masterClrMapping/>
-  </p:clrMapOvr>
-  <p:transition xmlns:p14="http://schemas.microsoft.com/office/powerpoint/2010/main" spd="med" advClick="1"/>
-</p:sld>
-</file>
-
-<file path=ppt/slides/slide2.xml><?xml version="1.0" encoding="utf-8"?>
-<p:sld xmlns:a="http://schemas.openxmlformats.org/drawingml/2006/main" xmlns:r="http://schemas.openxmlformats.org/officeDocument/2006/relationships" xmlns:p="http://schemas.openxmlformats.org/presentationml/2006/main" xmlns:m="http://schemas.openxmlformats.org/officeDocument/2006/math" xmlns:a14="http://schemas.microsoft.com/office/drawing/2010/main" showMasterSp="1" showMasterPhAnim="1">
-  <p:cSld>
-    <p:spTree>
-      <p:nvGrpSpPr>
-        <p:cNvPr id="1" name=""/>
-        <p:cNvGrpSpPr/>
-        <p:nvPr/>
-      </p:nvGrpSpPr>
-      <p:grpSpPr>
-        <a:xfrm>
-          <a:off x="0" y="0"/>
-          <a:ext cx="0" cy="0"/>
-          <a:chOff x="0" y="0"/>
-          <a:chExt cx="0" cy="0"/>
-        </a:xfrm>
-      </p:grpSpPr>
-      <p:sp>
-        <p:nvSpPr>
-          <p:cNvPr id="166" name="Title 2"/>
-          <p:cNvSpPr txBox="1"/>
-          <p:nvPr>
-            <p:ph type="title"/>
-          </p:nvPr>
-        </p:nvSpPr>
-        <p:spPr>
-          <a:prstGeom prst="rect">
-            <a:avLst/>
-          </a:prstGeom>
-        </p:spPr>
-        <p:txBody>
-          <a:bodyPr/>
-          <a:lstStyle/>
-          <a:p>
-            <a:pPr/>
-            <a:r>
-              <a:t>Short introduction</a:t>
-            </a:r>
-          </a:p>
-        </p:txBody>
-      </p:sp>
-      <p:sp>
-        <p:nvSpPr>
-          <p:cNvPr id="167" name="Text Placeholder 4"/>
-          <p:cNvSpPr txBox="1"/>
-          <p:nvPr>
-            <p:ph type="body" sz="quarter" idx="1"/>
-          </p:nvPr>
-        </p:nvSpPr>
-        <p:spPr>
-          <a:prstGeom prst="rect">
-            <a:avLst/>
-          </a:prstGeom>
-        </p:spPr>
-        <p:txBody>
-          <a:bodyPr/>
-          <a:lstStyle/>
-          <a:p>
-            <a:pPr/>
-          </a:p>
-        </p:txBody>
-      </p:sp>
-      <p:pic>
-        <p:nvPicPr>
-          <p:cNvPr id="168" name="Graphic 5" descr="Graphic 5"/>
-          <p:cNvPicPr>
-            <a:picLocks noChangeAspect="1"/>
-          </p:cNvPicPr>
-          <p:nvPr/>
-        </p:nvPicPr>
-        <p:blipFill>
-          <a:blip r:embed="rId2">
-            <a:extLst/>
-          </a:blip>
-          <a:stretch>
-            <a:fillRect/>
-          </a:stretch>
-        </p:blipFill>
-        <p:spPr>
-          <a:xfrm>
-            <a:off x="5535121" y="3394947"/>
-            <a:ext cx="1121758" cy="1127725"/>
           </a:xfrm>
           <a:prstGeom prst="rect">
             <a:avLst/>
@@ -19620,7 +19946,7 @@
               </a:defRPr>
             </a:pPr>
             <a:r>
-              <a:t>— Spec and implementations turn out to be a very good fit</a:t>
+              <a:t>— Spec and implementations turned out to be a very good fit</a:t>
             </a:r>
           </a:p>
           <a:p>

</xml_diff>

<commit_message>
update slides for MODELS links
  - remove .pps version
</commit_message>
<xml_diff>
--- a/conference-talks/LangDev/2026/LangDev 2026 Talk.pptx
+++ b/conference-talks/LangDev/2026/LangDev 2026 Talk.pptx
@@ -7512,7 +7512,7 @@
               </a:defRPr>
             </a:pPr>
             <a:r>
-              <a:t>How to implement an LWB with LionWeb</a:t>
+              <a:t>How to implement a Language WorkBench with LionWeb</a:t>
             </a:r>
           </a:p>
           <a:p>
@@ -15033,56 +15033,56 @@
       </p:par>
     </p:tnLst>
     <p:bldLst>
+      <p:bldP build="whole" bldLvl="1" animBg="1" rev="0" advAuto="0" spid="476" grpId="5"/>
+      <p:bldP build="whole" bldLvl="1" animBg="1" rev="0" advAuto="0" spid="426" grpId="8"/>
+      <p:bldP build="whole" bldLvl="1" animBg="1" rev="0" advAuto="0" spid="518" grpId="21"/>
+      <p:bldP build="whole" bldLvl="1" animBg="1" rev="0" advAuto="0" spid="417" grpId="1"/>
+      <p:bldP build="whole" bldLvl="1" animBg="1" rev="0" advAuto="0" spid="510" grpId="4"/>
+      <p:bldP build="whole" bldLvl="1" animBg="1" rev="0" advAuto="0" spid="470" grpId="40"/>
+      <p:bldP build="whole" bldLvl="1" animBg="1" rev="0" advAuto="0" spid="469" grpId="28"/>
+      <p:bldP build="whole" bldLvl="1" animBg="1" rev="0" advAuto="0" spid="467" grpId="17"/>
       <p:bldP build="whole" bldLvl="1" animBg="1" rev="0" advAuto="0" spid="455" grpId="16"/>
+      <p:bldP build="whole" bldLvl="1" animBg="1" rev="0" advAuto="0" spid="516" grpId="41"/>
+      <p:bldP build="whole" bldLvl="1" animBg="1" rev="0" advAuto="0" spid="518" grpId="30"/>
+      <p:bldP build="whole" bldLvl="1" animBg="1" rev="0" advAuto="0" spid="490" grpId="50"/>
       <p:bldP build="whole" bldLvl="1" animBg="1" rev="0" advAuto="0" spid="509" grpId="29"/>
-      <p:bldP build="whole" bldLvl="1" animBg="1" rev="0" advAuto="0" spid="466" grpId="27"/>
-      <p:bldP build="whole" bldLvl="1" animBg="1" rev="0" advAuto="0" spid="517" grpId="22"/>
-      <p:bldP build="whole" bldLvl="1" animBg="1" rev="0" advAuto="0" spid="417" grpId="1"/>
-      <p:bldP build="whole" bldLvl="1" animBg="1" rev="0" advAuto="0" spid="509" grpId="32"/>
-      <p:bldP build="whole" bldLvl="1" animBg="1" rev="0" advAuto="0" spid="515" grpId="34"/>
-      <p:bldP build="whole" bldLvl="1" animBg="1" rev="0" advAuto="0" spid="517" grpId="31"/>
-      <p:bldP build="whole" bldLvl="1" animBg="1" rev="0" advAuto="0" spid="513" grpId="44"/>
-      <p:bldP build="whole" bldLvl="1" animBg="1" rev="0" advAuto="0" spid="444" grpId="25"/>
-      <p:bldP build="whole" bldLvl="1" animBg="1" rev="0" advAuto="0" spid="513" grpId="46"/>
-      <p:bldP build="whole" bldLvl="1" animBg="1" rev="0" advAuto="0" spid="454" grpId="26"/>
-      <p:bldP build="whole" bldLvl="1" animBg="1" rev="0" advAuto="0" spid="471" grpId="18"/>
-      <p:bldP build="whole" bldLvl="1" animBg="1" rev="0" advAuto="0" spid="447" grpId="35"/>
-      <p:bldP build="whole" bldLvl="1" animBg="1" rev="0" advAuto="0" spid="515" grpId="42"/>
       <p:bldP build="whole" bldLvl="1" animBg="1" rev="0" advAuto="0" spid="520" grpId="7"/>
       <p:bldP build="whole" bldLvl="1" animBg="1" rev="0" advAuto="0" spid="429" grpId="9"/>
+      <p:bldP build="whole" bldLvl="1" animBg="1" rev="0" advAuto="0" spid="509" grpId="32"/>
+      <p:bldP build="whole" bldLvl="1" animBg="1" rev="0" advAuto="0" spid="454" grpId="26"/>
+      <p:bldP build="whole" bldLvl="1" animBg="1" rev="0" advAuto="0" spid="472" grpId="12"/>
       <p:bldP build="whole" bldLvl="1" animBg="1" rev="0" advAuto="0" spid="420" grpId="2"/>
       <p:bldP build="whole" bldLvl="1" animBg="1" rev="0" advAuto="0" spid="520" grpId="13"/>
-      <p:bldP build="whole" bldLvl="1" animBg="1" rev="0" advAuto="0" spid="518" grpId="21"/>
-      <p:bldP build="whole" bldLvl="1" animBg="1" rev="0" advAuto="0" spid="467" grpId="17"/>
-      <p:bldP build="whole" bldLvl="1" animBg="1" rev="0" advAuto="0" spid="516" grpId="33"/>
-      <p:bldP build="whole" bldLvl="1" animBg="1" rev="0" advAuto="0" spid="453" grpId="37"/>
-      <p:bldP build="whole" bldLvl="1" animBg="1" rev="0" advAuto="0" spid="485" grpId="43"/>
-      <p:bldP build="whole" bldLvl="1" animBg="1" rev="0" advAuto="0" spid="510" grpId="4"/>
+      <p:bldP build="whole" bldLvl="1" animBg="1" rev="0" advAuto="0" spid="438" grpId="23"/>
+      <p:bldP build="whole" bldLvl="1" animBg="1" rev="0" advAuto="0" spid="447" grpId="35"/>
       <p:bldP build="whole" bldLvl="1" animBg="1" rev="0" advAuto="0" spid="519" grpId="19"/>
       <p:bldP build="whole" bldLvl="1" animBg="1" rev="0" advAuto="0" spid="519" grpId="20"/>
+      <p:bldP build="whole" bldLvl="1" animBg="1" rev="0" advAuto="0" spid="450" grpId="36"/>
+      <p:bldP build="whole" bldLvl="1" animBg="1" rev="0" advAuto="0" spid="513" grpId="44"/>
+      <p:bldP build="whole" bldLvl="1" animBg="1" rev="0" advAuto="0" spid="464" grpId="10"/>
+      <p:bldP build="whole" bldLvl="1" animBg="1" rev="0" advAuto="0" spid="453" grpId="37"/>
+      <p:bldP build="whole" bldLvl="1" animBg="1" rev="0" advAuto="0" spid="466" grpId="27"/>
+      <p:bldP build="whole" bldLvl="1" animBg="1" rev="0" advAuto="0" spid="513" grpId="46"/>
+      <p:bldP build="whole" bldLvl="1" animBg="1" rev="0" advAuto="0" spid="485" grpId="43"/>
+      <p:bldP build="whole" bldLvl="1" animBg="1" rev="0" advAuto="0" spid="495" grpId="48"/>
+      <p:bldP build="whole" bldLvl="1" animBg="1" rev="0" advAuto="0" spid="515" grpId="34"/>
+      <p:bldP build="whole" bldLvl="1" animBg="1" rev="0" advAuto="0" spid="514" grpId="45"/>
+      <p:bldP build="whole" bldLvl="1" animBg="1" rev="0" advAuto="0" spid="441" grpId="24"/>
+      <p:bldP build="whole" bldLvl="1" animBg="1" rev="0" advAuto="0" spid="432" grpId="14"/>
+      <p:bldP build="whole" bldLvl="1" animBg="1" rev="0" advAuto="0" spid="423" grpId="3"/>
+      <p:bldP build="whole" bldLvl="1" animBg="1" rev="0" advAuto="0" spid="514" grpId="47"/>
       <p:bldP build="whole" bldLvl="1" animBg="1" rev="0" advAuto="0" spid="480" grpId="6"/>
-      <p:bldP build="whole" bldLvl="1" animBg="1" rev="0" advAuto="0" spid="518" grpId="30"/>
-      <p:bldP build="whole" bldLvl="1" animBg="1" rev="0" advAuto="0" spid="450" grpId="36"/>
-      <p:bldP build="whole" bldLvl="1" animBg="1" rev="0" advAuto="0" spid="516" grpId="41"/>
-      <p:bldP build="whole" bldLvl="1" animBg="1" rev="0" advAuto="0" spid="490" grpId="50"/>
-      <p:bldP build="whole" bldLvl="1" animBg="1" rev="0" advAuto="0" spid="495" grpId="48"/>
-      <p:bldP build="whole" bldLvl="1" animBg="1" rev="0" advAuto="0" spid="472" grpId="12"/>
-      <p:bldP build="whole" bldLvl="1" animBg="1" rev="0" advAuto="0" spid="514" grpId="45"/>
+      <p:bldP build="whole" bldLvl="1" animBg="1" rev="0" advAuto="0" spid="515" grpId="42"/>
+      <p:bldP build="whole" bldLvl="1" animBg="1" rev="0" advAuto="0" spid="500" grpId="49"/>
+      <p:bldP build="whole" bldLvl="1" animBg="1" rev="0" advAuto="0" spid="517" grpId="22"/>
+      <p:bldP build="whole" bldLvl="1" animBg="1" rev="0" advAuto="0" spid="456" grpId="38"/>
+      <p:bldP build="whole" bldLvl="1" animBg="1" rev="0" advAuto="0" spid="468" grpId="11"/>
+      <p:bldP build="whole" bldLvl="1" animBg="1" rev="0" advAuto="0" spid="471" grpId="18"/>
+      <p:bldP build="whole" bldLvl="1" animBg="1" rev="0" advAuto="0" spid="444" grpId="25"/>
+      <p:bldP build="whole" bldLvl="1" animBg="1" rev="0" advAuto="0" spid="517" grpId="31"/>
       <p:bldP build="whole" bldLvl="1" animBg="1" rev="0" advAuto="0" spid="435" grpId="15"/>
-      <p:bldP build="whole" bldLvl="1" animBg="1" rev="0" advAuto="0" spid="423" grpId="3"/>
-      <p:bldP build="whole" bldLvl="1" animBg="1" rev="0" advAuto="0" spid="468" grpId="11"/>
-      <p:bldP build="whole" bldLvl="1" animBg="1" rev="0" advAuto="0" spid="432" grpId="14"/>
-      <p:bldP build="whole" bldLvl="1" animBg="1" rev="0" advAuto="0" spid="514" grpId="47"/>
-      <p:bldP build="whole" bldLvl="1" animBg="1" rev="0" advAuto="0" spid="500" grpId="49"/>
-      <p:bldP build="whole" bldLvl="1" animBg="1" rev="0" advAuto="0" spid="464" grpId="10"/>
       <p:bldP build="whole" bldLvl="1" animBg="1" rev="0" advAuto="0" spid="465" grpId="39"/>
-      <p:bldP build="whole" bldLvl="1" animBg="1" rev="0" advAuto="0" spid="426" grpId="8"/>
-      <p:bldP build="whole" bldLvl="1" animBg="1" rev="0" advAuto="0" spid="438" grpId="23"/>
-      <p:bldP build="whole" bldLvl="1" animBg="1" rev="0" advAuto="0" spid="441" grpId="24"/>
-      <p:bldP build="whole" bldLvl="1" animBg="1" rev="0" advAuto="0" spid="476" grpId="5"/>
-      <p:bldP build="whole" bldLvl="1" animBg="1" rev="0" advAuto="0" spid="456" grpId="38"/>
-      <p:bldP build="whole" bldLvl="1" animBg="1" rev="0" advAuto="0" spid="470" grpId="40"/>
-      <p:bldP build="whole" bldLvl="1" animBg="1" rev="0" advAuto="0" spid="469" grpId="28"/>
+      <p:bldP build="whole" bldLvl="1" animBg="1" rev="0" advAuto="0" spid="516" grpId="33"/>
     </p:bldLst>
   </p:timing>
 </p:sld>
@@ -15690,11 +15690,11 @@
       </p:par>
     </p:tnLst>
     <p:bldLst>
+      <p:bldP build="whole" bldLvl="1" animBg="1" rev="0" advAuto="0" spid="523" grpId="1"/>
       <p:bldP build="whole" bldLvl="1" animBg="1" rev="0" advAuto="0" spid="527" grpId="4"/>
+      <p:bldP build="whole" bldLvl="1" animBg="1" rev="0" advAuto="0" spid="528" grpId="3"/>
+      <p:bldP build="whole" bldLvl="1" animBg="1" rev="0" advAuto="0" spid="531" grpId="5"/>
       <p:bldP build="whole" bldLvl="1" animBg="1" rev="0" advAuto="0" spid="526" grpId="2"/>
-      <p:bldP build="whole" bldLvl="1" animBg="1" rev="0" advAuto="0" spid="531" grpId="5"/>
-      <p:bldP build="whole" bldLvl="1" animBg="1" rev="0" advAuto="0" spid="523" grpId="1"/>
-      <p:bldP build="whole" bldLvl="1" animBg="1" rev="0" advAuto="0" spid="528" grpId="3"/>
     </p:bldLst>
   </p:timing>
 </p:sld>
@@ -20730,35 +20730,35 @@
       </p:par>
     </p:tnLst>
     <p:bldLst>
+      <p:bldP build="whole" bldLvl="1" animBg="1" rev="0" advAuto="0" spid="563" grpId="20"/>
+      <p:bldP build="whole" bldLvl="1" animBg="1" rev="0" advAuto="0" spid="598" grpId="24"/>
+      <p:bldP build="whole" bldLvl="1" animBg="1" rev="0" advAuto="0" spid="599" grpId="25"/>
+      <p:bldP build="whole" bldLvl="1" animBg="1" rev="0" advAuto="0" spid="602" grpId="26"/>
+      <p:bldP build="whole" bldLvl="1" animBg="1" rev="0" advAuto="0" spid="559" grpId="19"/>
+      <p:bldP build="whole" bldLvl="1" animBg="1" rev="0" advAuto="0" spid="607" grpId="29"/>
+      <p:bldP build="whole" bldLvl="1" animBg="1" rev="0" advAuto="0" spid="616" grpId="1"/>
+      <p:bldP build="whole" bldLvl="1" animBg="1" rev="0" advAuto="0" spid="579" grpId="6"/>
+      <p:bldP build="whole" bldLvl="1" animBg="1" rev="0" advAuto="0" spid="605" grpId="27"/>
+      <p:bldP build="whole" bldLvl="1" animBg="1" rev="0" advAuto="0" spid="556" grpId="2"/>
+      <p:bldP build="whole" bldLvl="1" animBg="1" rev="0" advAuto="0" spid="593" grpId="21"/>
+      <p:bldP build="whole" bldLvl="1" animBg="1" rev="0" advAuto="0" spid="584" grpId="9"/>
+      <p:bldP build="whole" bldLvl="1" animBg="1" rev="0" advAuto="0" spid="615" grpId="7"/>
+      <p:bldP build="whole" bldLvl="1" animBg="1" rev="0" advAuto="0" spid="610" grpId="16"/>
+      <p:bldP build="whole" bldLvl="1" animBg="1" rev="0" advAuto="0" spid="596" grpId="22"/>
+      <p:bldP build="whole" bldLvl="1" animBg="1" rev="0" advAuto="0" spid="597" grpId="23"/>
+      <p:bldP build="whole" bldLvl="1" animBg="1" rev="0" advAuto="0" spid="589" grpId="12"/>
+      <p:bldP build="whole" bldLvl="1" animBg="1" rev="0" advAuto="0" spid="587" grpId="10"/>
+      <p:bldP build="whole" bldLvl="1" animBg="1" rev="0" advAuto="0" spid="547" grpId="14"/>
       <p:bldP build="whole" bldLvl="1" animBg="1" rev="0" advAuto="0" spid="616" grpId="15"/>
-      <p:bldP build="whole" bldLvl="1" animBg="1" rev="0" advAuto="0" spid="579" grpId="6"/>
+      <p:bldP build="whole" bldLvl="1" animBg="1" rev="0" advAuto="0" spid="575" grpId="4"/>
+      <p:bldP build="whole" bldLvl="1" animBg="1" rev="0" advAuto="0" spid="546" grpId="13"/>
+      <p:bldP build="whole" bldLvl="1" animBg="1" rev="0" advAuto="0" spid="588" grpId="11"/>
+      <p:bldP build="whole" bldLvl="1" animBg="1" rev="0" advAuto="0" spid="578" grpId="5"/>
+      <p:bldP build="whole" bldLvl="1" animBg="1" rev="0" advAuto="0" spid="581" grpId="8"/>
+      <p:bldP build="whole" bldLvl="1" animBg="1" rev="0" advAuto="0" spid="618" grpId="18"/>
       <p:bldP build="whole" bldLvl="1" animBg="1" rev="0" advAuto="0" spid="562" grpId="3"/>
-      <p:bldP build="whole" bldLvl="1" animBg="1" rev="0" advAuto="0" spid="581" grpId="8"/>
-      <p:bldP build="whole" bldLvl="1" animBg="1" rev="0" advAuto="0" spid="588" grpId="11"/>
-      <p:bldP build="whole" bldLvl="1" animBg="1" rev="0" advAuto="0" spid="615" grpId="7"/>
-      <p:bldP build="whole" bldLvl="1" animBg="1" rev="0" advAuto="0" spid="602" grpId="26"/>
-      <p:bldP build="whole" bldLvl="1" animBg="1" rev="0" advAuto="0" spid="563" grpId="20"/>
-      <p:bldP build="whole" bldLvl="1" animBg="1" rev="0" advAuto="0" spid="597" grpId="23"/>
-      <p:bldP build="whole" bldLvl="1" animBg="1" rev="0" advAuto="0" spid="605" grpId="27"/>
-      <p:bldP build="whole" bldLvl="1" animBg="1" rev="0" advAuto="0" spid="593" grpId="21"/>
-      <p:bldP build="whole" bldLvl="1" animBg="1" rev="0" advAuto="0" spid="559" grpId="19"/>
-      <p:bldP build="whole" bldLvl="1" animBg="1" rev="0" advAuto="0" spid="584" grpId="9"/>
-      <p:bldP build="whole" bldLvl="1" animBg="1" rev="0" advAuto="0" spid="610" grpId="16"/>
-      <p:bldP build="whole" bldLvl="1" animBg="1" rev="0" advAuto="0" spid="556" grpId="2"/>
-      <p:bldP build="whole" bldLvl="1" animBg="1" rev="0" advAuto="0" spid="575" grpId="4"/>
-      <p:bldP build="whole" bldLvl="1" animBg="1" rev="0" advAuto="0" spid="587" grpId="10"/>
-      <p:bldP build="whole" bldLvl="1" animBg="1" rev="0" advAuto="0" spid="596" grpId="22"/>
-      <p:bldP build="whole" bldLvl="1" animBg="1" rev="0" advAuto="0" spid="616" grpId="1"/>
-      <p:bldP build="whole" bldLvl="1" animBg="1" rev="0" advAuto="0" spid="618" grpId="18"/>
+      <p:bldP build="whole" bldLvl="1" animBg="1" rev="0" advAuto="0" spid="617" grpId="28"/>
       <p:bldP build="whole" bldLvl="1" animBg="1" rev="0" advAuto="0" spid="611" grpId="17"/>
-      <p:bldP build="whole" bldLvl="1" animBg="1" rev="0" advAuto="0" spid="578" grpId="5"/>
-      <p:bldP build="whole" bldLvl="1" animBg="1" rev="0" advAuto="0" spid="589" grpId="12"/>
-      <p:bldP build="whole" bldLvl="1" animBg="1" rev="0" advAuto="0" spid="598" grpId="24"/>
-      <p:bldP build="whole" bldLvl="1" animBg="1" rev="0" advAuto="0" spid="617" grpId="28"/>
-      <p:bldP build="whole" bldLvl="1" animBg="1" rev="0" advAuto="0" spid="607" grpId="29"/>
-      <p:bldP build="whole" bldLvl="1" animBg="1" rev="0" advAuto="0" spid="547" grpId="14"/>
-      <p:bldP build="whole" bldLvl="1" animBg="1" rev="0" advAuto="0" spid="546" grpId="13"/>
-      <p:bldP build="whole" bldLvl="1" animBg="1" rev="0" advAuto="0" spid="599" grpId="25"/>
     </p:bldLst>
   </p:timing>
 </p:sld>
@@ -31291,7 +31291,7 @@
               </a:defRPr>
             </a:pPr>
             <a:r>
-              <a:t>MBSE 2025 (slides, </a:t>
+              <a:t>MBSE 2025 (</a:t>
             </a:r>
             <a:r>
               <a:rPr u="sng">
@@ -31304,6 +31304,23 @@
                   </a:solidFill>
                 </a:uFill>
                 <a:hlinkClick r:id="rId10" invalidUrl="" action="" tgtFrame="" tooltip="" history="1" highlightClick="0" endSnd="0"/>
+              </a:rPr>
+              <a:t>slides</a:t>
+            </a:r>
+            <a:r>
+              <a:t>, </a:t>
+            </a:r>
+            <a:r>
+              <a:rPr u="sng">
+                <a:solidFill>
+                  <a:srgbClr val="0563C1"/>
+                </a:solidFill>
+                <a:uFill>
+                  <a:solidFill>
+                    <a:srgbClr val="0563C1"/>
+                  </a:solidFill>
+                </a:uFill>
+                <a:hlinkClick r:id="rId11" invalidUrl="" action="" tgtFrame="" tooltip="" history="1" highlightClick="0" endSnd="0"/>
               </a:rPr>
               <a:t>conference</a:t>
             </a:r>
@@ -31325,7 +31342,41 @@
               </a:defRPr>
             </a:pPr>
             <a:r>
-              <a:t>MODELS 2026 — Industry Day (slides &lt;== TODO)</a:t>
+              <a:t>MODELS 2026 — Industry Day (</a:t>
+            </a:r>
+            <a:r>
+              <a:rPr u="sng">
+                <a:solidFill>
+                  <a:srgbClr val="0563C1"/>
+                </a:solidFill>
+                <a:uFill>
+                  <a:solidFill>
+                    <a:srgbClr val="0563C1"/>
+                  </a:solidFill>
+                </a:uFill>
+                <a:hlinkClick r:id="rId12" invalidUrl="" action="" tgtFrame="" tooltip="" history="1" highlightClick="0" endSnd="0"/>
+              </a:rPr>
+              <a:t>slides</a:t>
+            </a:r>
+            <a:r>
+              <a:t>, </a:t>
+            </a:r>
+            <a:r>
+              <a:rPr u="sng">
+                <a:solidFill>
+                  <a:srgbClr val="0563C1"/>
+                </a:solidFill>
+                <a:uFill>
+                  <a:solidFill>
+                    <a:srgbClr val="0563C1"/>
+                  </a:solidFill>
+                </a:uFill>
+                <a:hlinkClick r:id="rId13" invalidUrl="" action="" tgtFrame="" tooltip="" history="1" highlightClick="0" endSnd="0"/>
+              </a:rPr>
+              <a:t>conference</a:t>
+            </a:r>
+            <a:r>
+              <a:t>)</a:t>
             </a:r>
           </a:p>
         </p:txBody>
@@ -31339,7 +31390,7 @@
           <p:nvPr/>
         </p:nvPicPr>
         <p:blipFill>
-          <a:blip r:embed="rId11">
+          <a:blip r:embed="rId14">
             <a:extLst/>
           </a:blip>
           <a:stretch>
@@ -31984,7 +32035,7 @@
           <a:p>
             <a:pPr marL="342900" indent="-342900"/>
             <a:r>
-              <a:t>Office hours (for outreach)</a:t>
+              <a:t>Office Hours (for outreach)</a:t>
             </a:r>
           </a:p>
           <a:p>

</xml_diff>

<commit_message>
modify de-animated, for publication
</commit_message>
<xml_diff>
--- a/conference-talks/LangDev/2026/LangDev 2026 Talk.pptx
+++ b/conference-talks/LangDev/2026/LangDev 2026 Talk.pptx
@@ -28,7 +28,6 @@
     <p:sldId id="273" r:id="rId25"/>
     <p:sldId id="274" r:id="rId26"/>
     <p:sldId id="275" r:id="rId27"/>
-    <p:sldId id="276" r:id="rId28"/>
   </p:sldIdLst>
   <p:sldSz cx="12192000" cy="6858000"/>
   <p:notesSz cx="6858000" cy="9144000"/>
@@ -3770,7 +3769,7 @@
               <a:defRPr sz="1600"/>
             </a:pPr>
             <a:r>
-              <a:t>Meinte Boersma, Niko Stotz</a:t>
+              <a:t>Meinte Boersma (DSL Consultancy), Niko Stotz (F1RE)</a:t>
             </a:r>
           </a:p>
         </p:txBody>
@@ -7216,7 +7215,7 @@
 </file>
 
 <file path=ppt/slides/slide10.xml><?xml version="1.0" encoding="utf-8"?>
-<p:sld xmlns:a="http://schemas.openxmlformats.org/drawingml/2006/main" xmlns:r="http://schemas.openxmlformats.org/officeDocument/2006/relationships" xmlns:p="http://schemas.openxmlformats.org/presentationml/2006/main" xmlns:m="http://schemas.openxmlformats.org/officeDocument/2006/math" xmlns:a14="http://schemas.microsoft.com/office/drawing/2010/main" show="0" showMasterSp="1" showMasterPhAnim="1">
+<p:sld xmlns:a="http://schemas.openxmlformats.org/drawingml/2006/main" xmlns:r="http://schemas.openxmlformats.org/officeDocument/2006/relationships" xmlns:p="http://schemas.openxmlformats.org/presentationml/2006/main" xmlns:m="http://schemas.openxmlformats.org/officeDocument/2006/math" xmlns:a14="http://schemas.microsoft.com/office/drawing/2010/main" showMasterSp="1" showMasterPhAnim="1">
   <p:cSld>
     <p:spTree>
       <p:nvGrpSpPr>
@@ -7241,10 +7240,6 @@
           </p:nvPr>
         </p:nvSpPr>
         <p:spPr>
-          <a:xfrm>
-            <a:off x="0" y="0"/>
-            <a:ext cx="12192000" cy="1264249"/>
-          </a:xfrm>
           <a:prstGeom prst="rect">
             <a:avLst/>
           </a:prstGeom>
@@ -7255,14 +7250,35 @@
           <a:p>
             <a:pPr/>
             <a:r>
-              <a:t>Award time!</a:t>
+              <a:t>Use cases</a:t>
             </a:r>
+          </a:p>
+        </p:txBody>
+      </p:sp>
+      <p:sp>
+        <p:nvSpPr>
+          <p:cNvPr id="386" name="Text Placeholder 4"/>
+          <p:cNvSpPr txBox="1"/>
+          <p:nvPr>
+            <p:ph type="body" sz="quarter" idx="1"/>
+          </p:nvPr>
+        </p:nvSpPr>
+        <p:spPr>
+          <a:prstGeom prst="rect">
+            <a:avLst/>
+          </a:prstGeom>
+        </p:spPr>
+        <p:txBody>
+          <a:bodyPr/>
+          <a:lstStyle/>
+          <a:p>
+            <a:pPr algn="ctr"/>
           </a:p>
         </p:txBody>
       </p:sp>
       <p:pic>
         <p:nvPicPr>
-          <p:cNvPr id="386" name="Gouden Delta API.png" descr="Gouden Delta API.png"/>
+          <p:cNvPr id="387" name="Graphic 5" descr="Graphic 5"/>
           <p:cNvPicPr>
             <a:picLocks noChangeAspect="1"/>
           </p:cNvPicPr>
@@ -7278,8 +7294,8 @@
         </p:blipFill>
         <p:spPr>
           <a:xfrm>
-            <a:off x="4256560" y="1342608"/>
-            <a:ext cx="3678879" cy="5352531"/>
+            <a:off x="5535121" y="3394947"/>
+            <a:ext cx="1121758" cy="1127725"/>
           </a:xfrm>
           <a:prstGeom prst="rect">
             <a:avLst/>
@@ -7317,107 +7333,7 @@
       </p:grpSpPr>
       <p:sp>
         <p:nvSpPr>
-          <p:cNvPr id="388" name="Title 1"/>
-          <p:cNvSpPr txBox="1"/>
-          <p:nvPr>
-            <p:ph type="title"/>
-          </p:nvPr>
-        </p:nvSpPr>
-        <p:spPr>
-          <a:prstGeom prst="rect">
-            <a:avLst/>
-          </a:prstGeom>
-        </p:spPr>
-        <p:txBody>
-          <a:bodyPr/>
-          <a:lstStyle/>
-          <a:p>
-            <a:pPr/>
-            <a:r>
-              <a:t>Use cases</a:t>
-            </a:r>
-          </a:p>
-        </p:txBody>
-      </p:sp>
-      <p:sp>
-        <p:nvSpPr>
-          <p:cNvPr id="389" name="Text Placeholder 4"/>
-          <p:cNvSpPr txBox="1"/>
-          <p:nvPr>
-            <p:ph type="body" sz="quarter" idx="1"/>
-          </p:nvPr>
-        </p:nvSpPr>
-        <p:spPr>
-          <a:prstGeom prst="rect">
-            <a:avLst/>
-          </a:prstGeom>
-        </p:spPr>
-        <p:txBody>
-          <a:bodyPr/>
-          <a:lstStyle/>
-          <a:p>
-            <a:pPr algn="ctr"/>
-          </a:p>
-        </p:txBody>
-      </p:sp>
-      <p:pic>
-        <p:nvPicPr>
-          <p:cNvPr id="390" name="Graphic 5" descr="Graphic 5"/>
-          <p:cNvPicPr>
-            <a:picLocks noChangeAspect="1"/>
-          </p:cNvPicPr>
-          <p:nvPr/>
-        </p:nvPicPr>
-        <p:blipFill>
-          <a:blip r:embed="rId2">
-            <a:extLst/>
-          </a:blip>
-          <a:stretch>
-            <a:fillRect/>
-          </a:stretch>
-        </p:blipFill>
-        <p:spPr>
-          <a:xfrm>
-            <a:off x="5535121" y="3394947"/>
-            <a:ext cx="1121758" cy="1127725"/>
-          </a:xfrm>
-          <a:prstGeom prst="rect">
-            <a:avLst/>
-          </a:prstGeom>
-          <a:ln w="12700">
-            <a:miter lim="400000"/>
-          </a:ln>
-        </p:spPr>
-      </p:pic>
-    </p:spTree>
-  </p:cSld>
-  <p:clrMapOvr>
-    <a:masterClrMapping/>
-  </p:clrMapOvr>
-  <p:transition xmlns:p14="http://schemas.microsoft.com/office/powerpoint/2010/main" spd="med" advClick="1"/>
-</p:sld>
-</file>
-
-<file path=ppt/slides/slide12.xml><?xml version="1.0" encoding="utf-8"?>
-<p:sld xmlns:a="http://schemas.openxmlformats.org/drawingml/2006/main" xmlns:r="http://schemas.openxmlformats.org/officeDocument/2006/relationships" xmlns:p="http://schemas.openxmlformats.org/presentationml/2006/main" xmlns:m="http://schemas.openxmlformats.org/officeDocument/2006/math" xmlns:a14="http://schemas.microsoft.com/office/drawing/2010/main" showMasterSp="1" showMasterPhAnim="1">
-  <p:cSld>
-    <p:spTree>
-      <p:nvGrpSpPr>
-        <p:cNvPr id="1" name=""/>
-        <p:cNvGrpSpPr/>
-        <p:nvPr/>
-      </p:nvGrpSpPr>
-      <p:grpSpPr>
-        <a:xfrm>
-          <a:off x="0" y="0"/>
-          <a:ext cx="0" cy="0"/>
-          <a:chOff x="0" y="0"/>
-          <a:chExt cx="0" cy="0"/>
-        </a:xfrm>
-      </p:grpSpPr>
-      <p:sp>
-        <p:nvSpPr>
-          <p:cNvPr id="392" name="Title 1"/>
+          <p:cNvPr id="389" name="Title 1"/>
           <p:cNvSpPr txBox="1"/>
           <p:nvPr>
             <p:ph type="title"/>
@@ -7445,7 +7361,7 @@
       </p:sp>
       <p:sp>
         <p:nvSpPr>
-          <p:cNvPr id="393" name="Content Placeholder 2"/>
+          <p:cNvPr id="390" name="Content Placeholder 2"/>
           <p:cNvSpPr txBox="1"/>
           <p:nvPr>
             <p:ph type="body" idx="1"/>
@@ -7540,7 +7456,7 @@
 </p:sld>
 </file>
 
-<file path=ppt/slides/slide13.xml><?xml version="1.0" encoding="utf-8"?>
+<file path=ppt/slides/slide12.xml><?xml version="1.0" encoding="utf-8"?>
 <p:sld xmlns:a="http://schemas.openxmlformats.org/drawingml/2006/main" xmlns:r="http://schemas.openxmlformats.org/officeDocument/2006/relationships" xmlns:p="http://schemas.openxmlformats.org/presentationml/2006/main" xmlns:m="http://schemas.openxmlformats.org/officeDocument/2006/math" xmlns:a14="http://schemas.microsoft.com/office/drawing/2010/main" showMasterSp="1" showMasterPhAnim="1">
   <p:cSld>
     <p:spTree>
@@ -7559,7 +7475,7 @@
       </p:grpSpPr>
       <p:sp>
         <p:nvSpPr>
-          <p:cNvPr id="395" name="Title 1"/>
+          <p:cNvPr id="392" name="Title 1"/>
           <p:cNvSpPr txBox="1"/>
           <p:nvPr>
             <p:ph type="title"/>
@@ -7587,7 +7503,7 @@
       </p:sp>
       <p:sp>
         <p:nvSpPr>
-          <p:cNvPr id="396" name="Content Placeholder 2"/>
+          <p:cNvPr id="393" name="Content Placeholder 2"/>
           <p:cNvSpPr txBox="1"/>
           <p:nvPr>
             <p:ph type="body" idx="1"/>
@@ -7651,7 +7567,7 @@
       </p:sp>
       <p:pic>
         <p:nvPicPr>
-          <p:cNvPr id="397" name="LogoLateralSquare_trasparente.png" descr="LogoLateralSquare_trasparente.png"/>
+          <p:cNvPr id="394" name="LogoLateralSquare_trasparente.png" descr="LogoLateralSquare_trasparente.png"/>
           <p:cNvPicPr>
             <a:picLocks noChangeAspect="1"/>
           </p:cNvPicPr>
@@ -7680,7 +7596,7 @@
       </p:pic>
       <p:pic>
         <p:nvPicPr>
-          <p:cNvPr id="398" name="Strumenta-pipeline.png" descr="Strumenta-pipeline.png"/>
+          <p:cNvPr id="395" name="Strumenta-pipeline.png" descr="Strumenta-pipeline.png"/>
           <p:cNvPicPr>
             <a:picLocks noChangeAspect="1"/>
           </p:cNvPicPr>
@@ -7716,7 +7632,7 @@
 </p:sld>
 </file>
 
-<file path=ppt/slides/slide14.xml><?xml version="1.0" encoding="utf-8"?>
+<file path=ppt/slides/slide13.xml><?xml version="1.0" encoding="utf-8"?>
 <p:sld xmlns:a="http://schemas.openxmlformats.org/drawingml/2006/main" xmlns:r="http://schemas.openxmlformats.org/officeDocument/2006/relationships" xmlns:p="http://schemas.openxmlformats.org/presentationml/2006/main" xmlns:m="http://schemas.openxmlformats.org/officeDocument/2006/math" xmlns:a14="http://schemas.microsoft.com/office/drawing/2010/main" showMasterSp="1" showMasterPhAnim="1">
   <p:cSld>
     <p:spTree>
@@ -7735,7 +7651,7 @@
       </p:grpSpPr>
       <p:sp>
         <p:nvSpPr>
-          <p:cNvPr id="400" name="Title 1"/>
+          <p:cNvPr id="397" name="Title 1"/>
           <p:cNvSpPr txBox="1"/>
           <p:nvPr>
             <p:ph type="title"/>
@@ -7763,7 +7679,7 @@
       </p:sp>
       <p:sp>
         <p:nvSpPr>
-          <p:cNvPr id="401" name="Content Placeholder 2"/>
+          <p:cNvPr id="398" name="Content Placeholder 2"/>
           <p:cNvSpPr txBox="1"/>
           <p:nvPr>
             <p:ph type="body" idx="1"/>
@@ -7883,7 +7799,7 @@
       </p:sp>
       <p:pic>
         <p:nvPicPr>
-          <p:cNvPr id="402" name="LogoLateralSquare_trasparente.png" descr="LogoLateralSquare_trasparente.png"/>
+          <p:cNvPr id="399" name="LogoLateralSquare_trasparente.png" descr="LogoLateralSquare_trasparente.png"/>
           <p:cNvPicPr>
             <a:picLocks noChangeAspect="1"/>
           </p:cNvPicPr>
@@ -7919,7 +7835,7 @@
 </p:sld>
 </file>
 
-<file path=ppt/slides/slide15.xml><?xml version="1.0" encoding="utf-8"?>
+<file path=ppt/slides/slide14.xml><?xml version="1.0" encoding="utf-8"?>
 <p:sld xmlns:a="http://schemas.openxmlformats.org/drawingml/2006/main" xmlns:r="http://schemas.openxmlformats.org/officeDocument/2006/relationships" xmlns:p="http://schemas.openxmlformats.org/presentationml/2006/main" xmlns:m="http://schemas.openxmlformats.org/officeDocument/2006/math" xmlns:a14="http://schemas.microsoft.com/office/drawing/2010/main" showMasterSp="1" showMasterPhAnim="1">
   <p:cSld>
     <p:spTree>
@@ -7938,7 +7854,7 @@
       </p:grpSpPr>
       <p:sp>
         <p:nvSpPr>
-          <p:cNvPr id="404" name="Title 1"/>
+          <p:cNvPr id="401" name="Title 1"/>
           <p:cNvSpPr txBox="1"/>
           <p:nvPr>
             <p:ph type="title"/>
@@ -7966,7 +7882,7 @@
       </p:sp>
       <p:sp>
         <p:nvSpPr>
-          <p:cNvPr id="405" name="Content Placeholder 2"/>
+          <p:cNvPr id="402" name="Content Placeholder 2"/>
           <p:cNvSpPr txBox="1"/>
           <p:nvPr>
             <p:ph type="body" idx="1"/>
@@ -8125,7 +8041,7 @@
       </p:sp>
       <p:pic>
         <p:nvPicPr>
-          <p:cNvPr id="406" name="Logo_Trumpf.svg" descr="Logo_Trumpf.svg"/>
+          <p:cNvPr id="403" name="Logo_Trumpf.svg" descr="Logo_Trumpf.svg"/>
           <p:cNvPicPr>
             <a:picLocks noChangeAspect="1"/>
           </p:cNvPicPr>
@@ -8161,7 +8077,7 @@
 </p:sld>
 </file>
 
-<file path=ppt/slides/slide16.xml><?xml version="1.0" encoding="utf-8"?>
+<file path=ppt/slides/slide15.xml><?xml version="1.0" encoding="utf-8"?>
 <p:sld xmlns:a="http://schemas.openxmlformats.org/drawingml/2006/main" xmlns:r="http://schemas.openxmlformats.org/officeDocument/2006/relationships" xmlns:p="http://schemas.openxmlformats.org/presentationml/2006/main" xmlns:m="http://schemas.openxmlformats.org/officeDocument/2006/math" xmlns:a14="http://schemas.microsoft.com/office/drawing/2010/main" showMasterSp="1" showMasterPhAnim="1">
   <p:cSld>
     <p:spTree>
@@ -8180,7 +8096,7 @@
       </p:grpSpPr>
       <p:sp>
         <p:nvSpPr>
-          <p:cNvPr id="408" name="Title 1"/>
+          <p:cNvPr id="405" name="Title 1"/>
           <p:cNvSpPr txBox="1"/>
           <p:nvPr>
             <p:ph type="title"/>
@@ -8208,7 +8124,7 @@
       </p:sp>
       <p:sp>
         <p:nvSpPr>
-          <p:cNvPr id="409" name="Content Placeholder 2"/>
+          <p:cNvPr id="406" name="Content Placeholder 2"/>
           <p:cNvSpPr txBox="1"/>
           <p:nvPr>
             <p:ph type="body" idx="1"/>
@@ -8351,7 +8267,7 @@
 </p:sld>
 </file>
 
-<file path=ppt/slides/slide17.xml><?xml version="1.0" encoding="utf-8"?>
+<file path=ppt/slides/slide16.xml><?xml version="1.0" encoding="utf-8"?>
 <p:sld xmlns:a="http://schemas.openxmlformats.org/drawingml/2006/main" xmlns:r="http://schemas.openxmlformats.org/officeDocument/2006/relationships" xmlns:p="http://schemas.openxmlformats.org/presentationml/2006/main" xmlns:m="http://schemas.openxmlformats.org/officeDocument/2006/math" xmlns:a14="http://schemas.microsoft.com/office/drawing/2010/main" showMasterSp="1" showMasterPhAnim="1">
   <p:cSld>
     <p:spTree>
@@ -8370,7 +8286,7 @@
       </p:grpSpPr>
       <p:sp>
         <p:nvSpPr>
-          <p:cNvPr id="411" name="Title 1"/>
+          <p:cNvPr id="408" name="Title 1"/>
           <p:cNvSpPr txBox="1"/>
           <p:nvPr>
             <p:ph type="title"/>
@@ -8398,7 +8314,7 @@
       </p:sp>
       <p:pic>
         <p:nvPicPr>
-          <p:cNvPr id="412" name="Screenshot 2026-09-25 at 11.05.43.png" descr="Screenshot 2026-09-25 at 11.05.43.png"/>
+          <p:cNvPr id="409" name="Screenshot 2026-09-25 at 11.05.43.png" descr="Screenshot 2026-09-25 at 11.05.43.png"/>
           <p:cNvPicPr>
             <a:picLocks noChangeAspect="1"/>
           </p:cNvPicPr>
@@ -8427,7 +8343,7 @@
       </p:pic>
       <p:pic>
         <p:nvPicPr>
-          <p:cNvPr id="413" name="Screenshot 2026-09-25 at 11.05.25.png" descr="Screenshot 2026-09-25 at 11.05.25.png"/>
+          <p:cNvPr id="410" name="Screenshot 2026-09-25 at 11.05.25.png" descr="Screenshot 2026-09-25 at 11.05.25.png"/>
           <p:cNvPicPr>
             <a:picLocks noChangeAspect="1"/>
           </p:cNvPicPr>
@@ -8463,7 +8379,7 @@
 </p:sld>
 </file>
 
-<file path=ppt/slides/slide18.xml><?xml version="1.0" encoding="utf-8"?>
+<file path=ppt/slides/slide17.xml><?xml version="1.0" encoding="utf-8"?>
 <p:sld xmlns:a="http://schemas.openxmlformats.org/drawingml/2006/main" xmlns:r="http://schemas.openxmlformats.org/officeDocument/2006/relationships" xmlns:p="http://schemas.openxmlformats.org/presentationml/2006/main" xmlns:m="http://schemas.openxmlformats.org/officeDocument/2006/math" xmlns:a14="http://schemas.microsoft.com/office/drawing/2010/main" showMasterSp="1" showMasterPhAnim="1">
   <p:cSld>
     <p:spTree>
@@ -8482,7 +8398,7 @@
       </p:grpSpPr>
       <p:grpSp>
         <p:nvGrpSpPr>
-          <p:cNvPr id="417" name="Rectangle1"/>
+          <p:cNvPr id="414" name="Rectangle1"/>
           <p:cNvGrpSpPr/>
           <p:nvPr/>
         </p:nvGrpSpPr>
@@ -8496,7 +8412,7 @@
         </p:grpSpPr>
         <p:sp>
           <p:nvSpPr>
-            <p:cNvPr id="415" name="Rectangle"/>
+            <p:cNvPr id="412" name="Rectangle"/>
             <p:cNvSpPr/>
             <p:nvPr/>
           </p:nvSpPr>
@@ -8552,7 +8468,7 @@
         </p:sp>
         <p:sp>
           <p:nvSpPr>
-            <p:cNvPr id="416" name="Original…"/>
+            <p:cNvPr id="413" name="Original…"/>
             <p:cNvSpPr txBox="1"/>
             <p:nvPr/>
           </p:nvSpPr>
@@ -8638,7 +8554,7 @@
       </p:grpSp>
       <p:grpSp>
         <p:nvGrpSpPr>
-          <p:cNvPr id="420" name="AutoShape1"/>
+          <p:cNvPr id="417" name="AutoShape1"/>
           <p:cNvGrpSpPr/>
           <p:nvPr/>
         </p:nvGrpSpPr>
@@ -8652,7 +8568,7 @@
         </p:grpSpPr>
         <p:sp>
           <p:nvSpPr>
-            <p:cNvPr id="418" name="Rounded Rectangle"/>
+            <p:cNvPr id="415" name="Rounded Rectangle"/>
             <p:cNvSpPr/>
             <p:nvPr/>
           </p:nvSpPr>
@@ -8710,7 +8626,7 @@
         </p:sp>
         <p:sp>
           <p:nvSpPr>
-            <p:cNvPr id="419" name="«Function»…"/>
+            <p:cNvPr id="416" name="«Function»…"/>
             <p:cNvSpPr txBox="1"/>
             <p:nvPr/>
           </p:nvSpPr>
@@ -8796,7 +8712,7 @@
       </p:grpSp>
       <p:grpSp>
         <p:nvGrpSpPr>
-          <p:cNvPr id="423" name="AutoShape2"/>
+          <p:cNvPr id="420" name="AutoShape2"/>
           <p:cNvGrpSpPr/>
           <p:nvPr/>
         </p:nvGrpSpPr>
@@ -8810,7 +8726,7 @@
         </p:grpSpPr>
         <p:sp>
           <p:nvSpPr>
-            <p:cNvPr id="421" name="Rounded Rectangle"/>
+            <p:cNvPr id="418" name="Rounded Rectangle"/>
             <p:cNvSpPr/>
             <p:nvPr/>
           </p:nvSpPr>
@@ -8868,7 +8784,7 @@
         </p:sp>
         <p:sp>
           <p:nvSpPr>
-            <p:cNvPr id="422" name="«Overrides»…"/>
+            <p:cNvPr id="419" name="«Overrides»…"/>
             <p:cNvSpPr txBox="1"/>
             <p:nvPr/>
           </p:nvSpPr>
@@ -8954,7 +8870,7 @@
       </p:grpSp>
       <p:grpSp>
         <p:nvGrpSpPr>
-          <p:cNvPr id="426" name="Rectangle2"/>
+          <p:cNvPr id="423" name="Rectangle2"/>
           <p:cNvGrpSpPr/>
           <p:nvPr/>
         </p:nvGrpSpPr>
@@ -8968,7 +8884,7 @@
         </p:grpSpPr>
         <p:sp>
           <p:nvSpPr>
-            <p:cNvPr id="424" name="Rectangle"/>
+            <p:cNvPr id="421" name="Rectangle"/>
             <p:cNvSpPr/>
             <p:nvPr/>
           </p:nvSpPr>
@@ -9024,7 +8940,7 @@
         </p:sp>
         <p:sp>
           <p:nvSpPr>
-            <p:cNvPr id="425" name="Derived…"/>
+            <p:cNvPr id="422" name="Derived…"/>
             <p:cNvSpPr txBox="1"/>
             <p:nvPr/>
           </p:nvSpPr>
@@ -9110,7 +9026,7 @@
       </p:grpSp>
       <p:grpSp>
         <p:nvGrpSpPr>
-          <p:cNvPr id="429" name="AutoShape3"/>
+          <p:cNvPr id="426" name="AutoShape3"/>
           <p:cNvGrpSpPr/>
           <p:nvPr/>
         </p:nvGrpSpPr>
@@ -9124,7 +9040,7 @@
         </p:grpSpPr>
         <p:sp>
           <p:nvSpPr>
-            <p:cNvPr id="427" name="Rounded Rectangle"/>
+            <p:cNvPr id="424" name="Rounded Rectangle"/>
             <p:cNvSpPr/>
             <p:nvPr/>
           </p:nvSpPr>
@@ -9182,7 +9098,7 @@
         </p:sp>
         <p:sp>
           <p:nvSpPr>
-            <p:cNvPr id="428" name="«Finding»…"/>
+            <p:cNvPr id="425" name="«Finding»…"/>
             <p:cNvSpPr txBox="1"/>
             <p:nvPr/>
           </p:nvSpPr>
@@ -9272,7 +9188,7 @@
       </p:grpSp>
       <p:grpSp>
         <p:nvGrpSpPr>
-          <p:cNvPr id="432" name="Rectangle3"/>
+          <p:cNvPr id="429" name="Rectangle3"/>
           <p:cNvGrpSpPr/>
           <p:nvPr/>
         </p:nvGrpSpPr>
@@ -9286,7 +9202,7 @@
         </p:grpSpPr>
         <p:sp>
           <p:nvSpPr>
-            <p:cNvPr id="430" name="Rectangle"/>
+            <p:cNvPr id="427" name="Rectangle"/>
             <p:cNvSpPr/>
             <p:nvPr/>
           </p:nvSpPr>
@@ -9342,7 +9258,7 @@
         </p:sp>
         <p:sp>
           <p:nvSpPr>
-            <p:cNvPr id="431" name="Derived…"/>
+            <p:cNvPr id="428" name="Derived…"/>
             <p:cNvSpPr txBox="1"/>
             <p:nvPr/>
           </p:nvSpPr>
@@ -9428,7 +9344,7 @@
       </p:grpSp>
       <p:grpSp>
         <p:nvGrpSpPr>
-          <p:cNvPr id="435" name="AutoShape4"/>
+          <p:cNvPr id="432" name="AutoShape4"/>
           <p:cNvGrpSpPr/>
           <p:nvPr/>
         </p:nvGrpSpPr>
@@ -9442,7 +9358,7 @@
         </p:grpSpPr>
         <p:sp>
           <p:nvSpPr>
-            <p:cNvPr id="433" name="Rounded Rectangle"/>
+            <p:cNvPr id="430" name="Rounded Rectangle"/>
             <p:cNvSpPr/>
             <p:nvPr/>
           </p:nvSpPr>
@@ -9500,7 +9416,7 @@
         </p:sp>
         <p:sp>
           <p:nvSpPr>
-            <p:cNvPr id="434" name="«PrimitiveType»…"/>
+            <p:cNvPr id="431" name="«PrimitiveType»…"/>
             <p:cNvSpPr txBox="1"/>
             <p:nvPr/>
           </p:nvSpPr>
@@ -9586,7 +9502,7 @@
       </p:grpSp>
       <p:grpSp>
         <p:nvGrpSpPr>
-          <p:cNvPr id="438" name="Rectangle4"/>
+          <p:cNvPr id="435" name="Rectangle4"/>
           <p:cNvGrpSpPr/>
           <p:nvPr/>
         </p:nvGrpSpPr>
@@ -9600,7 +9516,7 @@
         </p:grpSpPr>
         <p:sp>
           <p:nvSpPr>
-            <p:cNvPr id="436" name="Rectangle"/>
+            <p:cNvPr id="433" name="Rectangle"/>
             <p:cNvSpPr/>
             <p:nvPr/>
           </p:nvSpPr>
@@ -9656,7 +9572,7 @@
         </p:sp>
         <p:sp>
           <p:nvSpPr>
-            <p:cNvPr id="437" name="Derived…"/>
+            <p:cNvPr id="434" name="Derived…"/>
             <p:cNvSpPr txBox="1"/>
             <p:nvPr/>
           </p:nvSpPr>
@@ -9742,28 +9658,28 @@
       </p:grpSp>
       <p:grpSp>
         <p:nvGrpSpPr>
-          <p:cNvPr id="441" name="AutoShape5"/>
+          <p:cNvPr id="438" name="AutoShape5"/>
           <p:cNvGrpSpPr/>
           <p:nvPr/>
         </p:nvGrpSpPr>
         <p:grpSpPr>
           <a:xfrm>
-            <a:off x="5453379" y="2045970"/>
-            <a:ext cx="1506221" cy="517526"/>
+            <a:off x="5216820" y="1964690"/>
+            <a:ext cx="1742780" cy="598806"/>
             <a:chOff x="0" y="0"/>
-            <a:chExt cx="1506219" cy="517525"/>
+            <a:chExt cx="1742779" cy="598804"/>
           </a:xfrm>
         </p:grpSpPr>
         <p:sp>
           <p:nvSpPr>
-            <p:cNvPr id="439" name="Rounded Rectangle"/>
+            <p:cNvPr id="436" name="Rounded Rectangle"/>
             <p:cNvSpPr/>
             <p:nvPr/>
           </p:nvSpPr>
           <p:spPr>
             <a:xfrm>
               <a:off x="0" y="0"/>
-              <a:ext cx="1506220" cy="517525"/>
+              <a:ext cx="1742780" cy="598805"/>
             </a:xfrm>
             <a:prstGeom prst="roundRect">
               <a:avLst>
@@ -9814,14 +9730,14 @@
         </p:sp>
         <p:sp>
           <p:nvSpPr>
-            <p:cNvPr id="440" name="«LocalScope»…"/>
+            <p:cNvPr id="437" name="«LocalScope»…"/>
             <p:cNvSpPr txBox="1"/>
             <p:nvPr/>
           </p:nvSpPr>
           <p:spPr>
             <a:xfrm>
-              <a:off x="30018" y="30018"/>
-              <a:ext cx="1446184" cy="457489"/>
+              <a:off x="34733" y="34733"/>
+              <a:ext cx="1673314" cy="529339"/>
             </a:xfrm>
             <a:prstGeom prst="rect">
               <a:avLst/>
@@ -9844,21 +9760,21 @@
             </a:bodyPr>
             <a:lstStyle/>
             <a:p>
-              <a:pPr algn="ctr" defTabSz="640079">
+              <a:pPr algn="ctr" defTabSz="795527">
                 <a:tabLst>
-                  <a:tab pos="635000" algn="l"/>
-                  <a:tab pos="1270000" algn="l"/>
-                  <a:tab pos="1917700" algn="l"/>
-                  <a:tab pos="2552700" algn="l"/>
-                  <a:tab pos="3187700" algn="l"/>
-                  <a:tab pos="3835400" algn="l"/>
-                  <a:tab pos="4470400" algn="l"/>
-                  <a:tab pos="5118100" algn="l"/>
-                  <a:tab pos="5753100" algn="l"/>
-                  <a:tab pos="6388100" algn="l"/>
-                  <a:tab pos="7035800" algn="l"/>
+                  <a:tab pos="787400" algn="l"/>
+                  <a:tab pos="1587500" algn="l"/>
+                  <a:tab pos="2374900" algn="l"/>
+                  <a:tab pos="3175000" algn="l"/>
+                  <a:tab pos="3975100" algn="l"/>
+                  <a:tab pos="4762500" algn="l"/>
+                  <a:tab pos="5562600" algn="l"/>
+                  <a:tab pos="6362700" algn="l"/>
+                  <a:tab pos="7150100" algn="l"/>
+                  <a:tab pos="7950200" algn="l"/>
+                  <a:tab pos="8750300" algn="l"/>
                 </a:tabLst>
-                <a:defRPr sz="1260">
+                <a:defRPr sz="1566">
                   <a:latin typeface="Lato Regular"/>
                   <a:ea typeface="Lato Regular"/>
                   <a:cs typeface="Lato Regular"/>
@@ -9870,21 +9786,21 @@
               </a:r>
             </a:p>
             <a:p>
-              <a:pPr algn="ctr" defTabSz="640079">
+              <a:pPr algn="ctr" defTabSz="795527">
                 <a:tabLst>
-                  <a:tab pos="635000" algn="l"/>
-                  <a:tab pos="1270000" algn="l"/>
-                  <a:tab pos="1917700" algn="l"/>
-                  <a:tab pos="2552700" algn="l"/>
-                  <a:tab pos="3187700" algn="l"/>
-                  <a:tab pos="3835400" algn="l"/>
-                  <a:tab pos="4470400" algn="l"/>
-                  <a:tab pos="5118100" algn="l"/>
-                  <a:tab pos="5753100" algn="l"/>
-                  <a:tab pos="6388100" algn="l"/>
-                  <a:tab pos="7035800" algn="l"/>
+                  <a:tab pos="787400" algn="l"/>
+                  <a:tab pos="1587500" algn="l"/>
+                  <a:tab pos="2374900" algn="l"/>
+                  <a:tab pos="3175000" algn="l"/>
+                  <a:tab pos="3975100" algn="l"/>
+                  <a:tab pos="4762500" algn="l"/>
+                  <a:tab pos="5562600" algn="l"/>
+                  <a:tab pos="6362700" algn="l"/>
+                  <a:tab pos="7150100" algn="l"/>
+                  <a:tab pos="7950200" algn="l"/>
+                  <a:tab pos="8750300" algn="l"/>
                 </a:tabLst>
-                <a:defRPr sz="1260">
+                <a:defRPr sz="1566">
                   <a:latin typeface="Lato Regular"/>
                   <a:ea typeface="Lato Regular"/>
                   <a:cs typeface="Lato Regular"/>
@@ -9900,28 +9816,28 @@
       </p:grpSp>
       <p:grpSp>
         <p:nvGrpSpPr>
-          <p:cNvPr id="444" name="AutoShape6"/>
+          <p:cNvPr id="441" name="AutoShape6"/>
           <p:cNvGrpSpPr/>
           <p:nvPr/>
         </p:nvGrpSpPr>
         <p:grpSpPr>
           <a:xfrm>
-            <a:off x="7086600" y="2057400"/>
-            <a:ext cx="1704975" cy="517525"/>
+            <a:off x="7086600" y="1976120"/>
+            <a:ext cx="1972750" cy="598806"/>
             <a:chOff x="0" y="0"/>
-            <a:chExt cx="1704975" cy="517525"/>
+            <a:chExt cx="1972749" cy="598804"/>
           </a:xfrm>
         </p:grpSpPr>
         <p:sp>
           <p:nvSpPr>
-            <p:cNvPr id="442" name="Rounded Rectangle"/>
+            <p:cNvPr id="439" name="Rounded Rectangle"/>
             <p:cNvSpPr/>
             <p:nvPr/>
           </p:nvSpPr>
           <p:spPr>
             <a:xfrm>
               <a:off x="0" y="0"/>
-              <a:ext cx="1704975" cy="517525"/>
+              <a:ext cx="1972750" cy="598805"/>
             </a:xfrm>
             <a:prstGeom prst="roundRect">
               <a:avLst>
@@ -9972,14 +9888,14 @@
         </p:sp>
         <p:sp>
           <p:nvSpPr>
-            <p:cNvPr id="443" name="«GlobalScope»…"/>
+            <p:cNvPr id="440" name="«GlobalScope»…"/>
             <p:cNvSpPr txBox="1"/>
             <p:nvPr/>
           </p:nvSpPr>
           <p:spPr>
             <a:xfrm>
-              <a:off x="30018" y="30018"/>
-              <a:ext cx="1644939" cy="457489"/>
+              <a:off x="34733" y="34733"/>
+              <a:ext cx="1903284" cy="529339"/>
             </a:xfrm>
             <a:prstGeom prst="rect">
               <a:avLst/>
@@ -10002,21 +9918,21 @@
             </a:bodyPr>
             <a:lstStyle/>
             <a:p>
-              <a:pPr algn="ctr" defTabSz="640079">
+              <a:pPr algn="ctr" defTabSz="795527">
                 <a:tabLst>
-                  <a:tab pos="635000" algn="l"/>
-                  <a:tab pos="1270000" algn="l"/>
-                  <a:tab pos="1917700" algn="l"/>
-                  <a:tab pos="2552700" algn="l"/>
-                  <a:tab pos="3187700" algn="l"/>
-                  <a:tab pos="3835400" algn="l"/>
-                  <a:tab pos="4470400" algn="l"/>
-                  <a:tab pos="5118100" algn="l"/>
-                  <a:tab pos="5753100" algn="l"/>
-                  <a:tab pos="6388100" algn="l"/>
-                  <a:tab pos="7035800" algn="l"/>
+                  <a:tab pos="787400" algn="l"/>
+                  <a:tab pos="1587500" algn="l"/>
+                  <a:tab pos="2374900" algn="l"/>
+                  <a:tab pos="3175000" algn="l"/>
+                  <a:tab pos="3975100" algn="l"/>
+                  <a:tab pos="4762500" algn="l"/>
+                  <a:tab pos="5562600" algn="l"/>
+                  <a:tab pos="6362700" algn="l"/>
+                  <a:tab pos="7150100" algn="l"/>
+                  <a:tab pos="7950200" algn="l"/>
+                  <a:tab pos="8750300" algn="l"/>
                 </a:tabLst>
-                <a:defRPr sz="1260">
+                <a:defRPr sz="1566">
                   <a:latin typeface="Lato Regular"/>
                   <a:ea typeface="Lato Regular"/>
                   <a:cs typeface="Lato Regular"/>
@@ -10028,21 +9944,21 @@
               </a:r>
             </a:p>
             <a:p>
-              <a:pPr algn="ctr" defTabSz="640079">
+              <a:pPr algn="ctr" defTabSz="795527">
                 <a:tabLst>
-                  <a:tab pos="635000" algn="l"/>
-                  <a:tab pos="1270000" algn="l"/>
-                  <a:tab pos="1917700" algn="l"/>
-                  <a:tab pos="2552700" algn="l"/>
-                  <a:tab pos="3187700" algn="l"/>
-                  <a:tab pos="3835400" algn="l"/>
-                  <a:tab pos="4470400" algn="l"/>
-                  <a:tab pos="5118100" algn="l"/>
-                  <a:tab pos="5753100" algn="l"/>
-                  <a:tab pos="6388100" algn="l"/>
-                  <a:tab pos="7035800" algn="l"/>
+                  <a:tab pos="787400" algn="l"/>
+                  <a:tab pos="1587500" algn="l"/>
+                  <a:tab pos="2374900" algn="l"/>
+                  <a:tab pos="3175000" algn="l"/>
+                  <a:tab pos="3975100" algn="l"/>
+                  <a:tab pos="4762500" algn="l"/>
+                  <a:tab pos="5562600" algn="l"/>
+                  <a:tab pos="6362700" algn="l"/>
+                  <a:tab pos="7150100" algn="l"/>
+                  <a:tab pos="7950200" algn="l"/>
+                  <a:tab pos="8750300" algn="l"/>
                 </a:tabLst>
-                <a:defRPr sz="1260">
+                <a:defRPr sz="1566">
                   <a:latin typeface="Lato Regular"/>
                   <a:ea typeface="Lato Regular"/>
                   <a:cs typeface="Lato Regular"/>
@@ -10058,7 +9974,7 @@
       </p:grpSp>
       <p:grpSp>
         <p:nvGrpSpPr>
-          <p:cNvPr id="447" name="Rectangle5"/>
+          <p:cNvPr id="444" name="Rectangle5"/>
           <p:cNvGrpSpPr/>
           <p:nvPr/>
         </p:nvGrpSpPr>
@@ -10072,7 +9988,7 @@
         </p:grpSpPr>
         <p:sp>
           <p:nvSpPr>
-            <p:cNvPr id="445" name="Rectangle"/>
+            <p:cNvPr id="442" name="Rectangle"/>
             <p:cNvSpPr/>
             <p:nvPr/>
           </p:nvSpPr>
@@ -10128,7 +10044,7 @@
         </p:sp>
         <p:sp>
           <p:nvSpPr>
-            <p:cNvPr id="446" name="Derived…"/>
+            <p:cNvPr id="443" name="Derived…"/>
             <p:cNvSpPr txBox="1"/>
             <p:nvPr/>
           </p:nvSpPr>
@@ -10214,7 +10130,7 @@
       </p:grpSp>
       <p:grpSp>
         <p:nvGrpSpPr>
-          <p:cNvPr id="450" name="AutoShape7"/>
+          <p:cNvPr id="447" name="AutoShape7"/>
           <p:cNvGrpSpPr/>
           <p:nvPr/>
         </p:nvGrpSpPr>
@@ -10228,7 +10144,7 @@
         </p:grpSpPr>
         <p:sp>
           <p:nvSpPr>
-            <p:cNvPr id="448" name="Rounded Rectangle"/>
+            <p:cNvPr id="445" name="Rounded Rectangle"/>
             <p:cNvSpPr/>
             <p:nvPr/>
           </p:nvSpPr>
@@ -10286,7 +10202,7 @@
         </p:sp>
         <p:sp>
           <p:nvSpPr>
-            <p:cNvPr id="449" name="«StringValue»…"/>
+            <p:cNvPr id="446" name="«StringValue»…"/>
             <p:cNvSpPr txBox="1"/>
             <p:nvPr/>
           </p:nvSpPr>
@@ -10398,7 +10314,7 @@
       </p:grpSp>
       <p:grpSp>
         <p:nvGrpSpPr>
-          <p:cNvPr id="453" name="AutoShape8"/>
+          <p:cNvPr id="450" name="AutoShape8"/>
           <p:cNvGrpSpPr/>
           <p:nvPr/>
         </p:nvGrpSpPr>
@@ -10412,7 +10328,7 @@
         </p:grpSpPr>
         <p:sp>
           <p:nvSpPr>
-            <p:cNvPr id="451" name="Rounded Rectangle"/>
+            <p:cNvPr id="448" name="Rounded Rectangle"/>
             <p:cNvSpPr/>
             <p:nvPr/>
           </p:nvSpPr>
@@ -10470,7 +10386,7 @@
         </p:sp>
         <p:sp>
           <p:nvSpPr>
-            <p:cNvPr id="452" name="«StringValue»…"/>
+            <p:cNvPr id="449" name="«StringValue»…"/>
             <p:cNvSpPr txBox="1"/>
             <p:nvPr/>
           </p:nvSpPr>
@@ -10582,7 +10498,7 @@
       </p:grpSp>
       <p:pic>
         <p:nvPicPr>
-          <p:cNvPr id="454" name="Picture2" descr="Picture2"/>
+          <p:cNvPr id="451" name="Picture2" descr="Picture2"/>
           <p:cNvPicPr>
             <a:picLocks noChangeAspect="1"/>
           </p:cNvPicPr>
@@ -10611,7 +10527,7 @@
       </p:pic>
       <p:pic>
         <p:nvPicPr>
-          <p:cNvPr id="455" name="Picture3" descr="Picture3"/>
+          <p:cNvPr id="452" name="Picture3" descr="Picture3"/>
           <p:cNvPicPr>
             <a:picLocks noChangeAspect="1"/>
           </p:cNvPicPr>
@@ -10641,7 +10557,7 @@
       </p:pic>
       <p:pic>
         <p:nvPicPr>
-          <p:cNvPr id="456" name="Grafik1" descr="Grafik1"/>
+          <p:cNvPr id="453" name="Grafik1" descr="Grafik1"/>
           <p:cNvPicPr>
             <a:picLocks noChangeAspect="1"/>
           </p:cNvPicPr>
@@ -10670,7 +10586,7 @@
       </p:pic>
       <p:sp>
         <p:nvSpPr>
-          <p:cNvPr id="515" name="Verbindung1"/>
+          <p:cNvPr id="512" name="Verbindung1"/>
           <p:cNvSpPr/>
           <p:nvPr/>
         </p:nvSpPr>
@@ -10725,7 +10641,7 @@
       </p:sp>
       <p:sp>
         <p:nvSpPr>
-          <p:cNvPr id="516" name="Verbindung2"/>
+          <p:cNvPr id="513" name="Verbindung2"/>
           <p:cNvSpPr/>
           <p:nvPr/>
         </p:nvSpPr>
@@ -10780,14 +10696,14 @@
       </p:sp>
       <p:sp>
         <p:nvSpPr>
-          <p:cNvPr id="517" name="Verbindung3"/>
+          <p:cNvPr id="514" name="Verbindung3"/>
           <p:cNvSpPr/>
           <p:nvPr/>
         </p:nvSpPr>
         <p:spPr>
           <a:xfrm>
-            <a:off x="6216893" y="2568257"/>
-            <a:ext cx="103186" cy="2613661"/>
+            <a:off x="6111193" y="2568257"/>
+            <a:ext cx="197498" cy="2613661"/>
           </a:xfrm>
           <a:custGeom>
             <a:avLst/>
@@ -10835,14 +10751,14 @@
       </p:sp>
       <p:sp>
         <p:nvSpPr>
-          <p:cNvPr id="518" name="Verbindung4"/>
+          <p:cNvPr id="515" name="Verbindung4"/>
           <p:cNvSpPr/>
           <p:nvPr/>
         </p:nvSpPr>
         <p:spPr>
           <a:xfrm>
-            <a:off x="6491909" y="2579687"/>
-            <a:ext cx="1314102" cy="2602231"/>
+            <a:off x="6503013" y="2579687"/>
+            <a:ext cx="1405660" cy="2602231"/>
           </a:xfrm>
           <a:custGeom>
             <a:avLst/>
@@ -10890,7 +10806,7 @@
       </p:sp>
       <p:sp>
         <p:nvSpPr>
-          <p:cNvPr id="519" name="Verbindung5"/>
+          <p:cNvPr id="516" name="Verbindung5"/>
           <p:cNvSpPr/>
           <p:nvPr/>
         </p:nvSpPr>
@@ -10945,7 +10861,7 @@
       </p:sp>
       <p:sp>
         <p:nvSpPr>
-          <p:cNvPr id="520" name="Verbindung6"/>
+          <p:cNvPr id="517" name="Verbindung6"/>
           <p:cNvSpPr/>
           <p:nvPr/>
         </p:nvSpPr>
@@ -11000,7 +10916,7 @@
       </p:sp>
       <p:sp>
         <p:nvSpPr>
-          <p:cNvPr id="463" name="SlideTitle1"/>
+          <p:cNvPr id="460" name="SlideTitle1"/>
           <p:cNvSpPr txBox="1"/>
           <p:nvPr>
             <p:ph type="title"/>
@@ -11050,7 +10966,7 @@
       </p:sp>
       <p:pic>
         <p:nvPicPr>
-          <p:cNvPr id="464" name="Grafik5" descr="Grafik5"/>
+          <p:cNvPr id="461" name="Grafik5" descr="Grafik5"/>
           <p:cNvPicPr>
             <a:picLocks noChangeAspect="1"/>
           </p:cNvPicPr>
@@ -11079,7 +10995,7 @@
       </p:pic>
       <p:sp>
         <p:nvSpPr>
-          <p:cNvPr id="465" name="Textbox1"/>
+          <p:cNvPr id="462" name="Textbox1"/>
           <p:cNvSpPr txBox="1"/>
           <p:nvPr/>
         </p:nvSpPr>
@@ -11137,7 +11053,7 @@
       </p:sp>
       <p:sp>
         <p:nvSpPr>
-          <p:cNvPr id="466" name="Textbox2"/>
+          <p:cNvPr id="463" name="Textbox2"/>
           <p:cNvSpPr txBox="1"/>
           <p:nvPr/>
         </p:nvSpPr>
@@ -11219,7 +11135,7 @@
       </p:sp>
       <p:sp>
         <p:nvSpPr>
-          <p:cNvPr id="467" name="Textbox3"/>
+          <p:cNvPr id="464" name="Textbox3"/>
           <p:cNvSpPr txBox="1"/>
           <p:nvPr/>
         </p:nvSpPr>
@@ -11277,7 +11193,7 @@
       </p:sp>
       <p:sp>
         <p:nvSpPr>
-          <p:cNvPr id="468" name="Textbox4"/>
+          <p:cNvPr id="465" name="Textbox4"/>
           <p:cNvSpPr txBox="1"/>
           <p:nvPr/>
         </p:nvSpPr>
@@ -11335,7 +11251,7 @@
       </p:sp>
       <p:pic>
         <p:nvPicPr>
-          <p:cNvPr id="469" name="Grafik9" descr="Grafik9"/>
+          <p:cNvPr id="466" name="Grafik9" descr="Grafik9"/>
           <p:cNvPicPr>
             <a:picLocks noChangeAspect="1"/>
           </p:cNvPicPr>
@@ -11364,7 +11280,7 @@
       </p:pic>
       <p:pic>
         <p:nvPicPr>
-          <p:cNvPr id="470" name="Grafik10" descr="Grafik10"/>
+          <p:cNvPr id="467" name="Grafik10" descr="Grafik10"/>
           <p:cNvPicPr>
             <a:picLocks noChangeAspect="1"/>
           </p:cNvPicPr>
@@ -11393,7 +11309,7 @@
       </p:pic>
       <p:pic>
         <p:nvPicPr>
-          <p:cNvPr id="471" name="Grafik11" descr="Grafik11"/>
+          <p:cNvPr id="468" name="Grafik11" descr="Grafik11"/>
           <p:cNvPicPr>
             <a:picLocks noChangeAspect="1"/>
           </p:cNvPicPr>
@@ -11422,7 +11338,7 @@
       </p:pic>
       <p:pic>
         <p:nvPicPr>
-          <p:cNvPr id="472" name="Grafik12" descr="Grafik12"/>
+          <p:cNvPr id="469" name="Grafik12" descr="Grafik12"/>
           <p:cNvPicPr>
             <a:picLocks noChangeAspect="1"/>
           </p:cNvPicPr>
@@ -11451,7 +11367,7 @@
       </p:pic>
       <p:grpSp>
         <p:nvGrpSpPr>
-          <p:cNvPr id="476" name="Group2"/>
+          <p:cNvPr id="473" name="Group2"/>
           <p:cNvGrpSpPr/>
           <p:nvPr/>
         </p:nvGrpSpPr>
@@ -11465,7 +11381,7 @@
         </p:grpSpPr>
         <p:pic>
           <p:nvPicPr>
-            <p:cNvPr id="473" name="Picture1" descr="Picture1"/>
+            <p:cNvPr id="470" name="Picture1" descr="Picture1"/>
             <p:cNvPicPr>
               <a:picLocks noChangeAspect="1"/>
             </p:cNvPicPr>
@@ -11497,7 +11413,7 @@
         </p:pic>
         <p:sp>
           <p:nvSpPr>
-            <p:cNvPr id="474" name="Textbox5"/>
+            <p:cNvPr id="471" name="Textbox5"/>
             <p:cNvSpPr txBox="1"/>
             <p:nvPr/>
           </p:nvSpPr>
@@ -11558,7 +11474,7 @@
         </p:sp>
         <p:pic>
           <p:nvPicPr>
-            <p:cNvPr id="475" name="Grafik13" descr="Grafik13"/>
+            <p:cNvPr id="472" name="Grafik13" descr="Grafik13"/>
             <p:cNvPicPr>
               <a:picLocks noChangeAspect="1"/>
             </p:cNvPicPr>
@@ -11590,7 +11506,7 @@
       </p:grpSp>
       <p:grpSp>
         <p:nvGrpSpPr>
-          <p:cNvPr id="480" name="Group1"/>
+          <p:cNvPr id="477" name="Group1"/>
           <p:cNvGrpSpPr/>
           <p:nvPr/>
         </p:nvGrpSpPr>
@@ -11604,7 +11520,7 @@
         </p:grpSpPr>
         <p:pic>
           <p:nvPicPr>
-            <p:cNvPr id="477" name="Grafik6" descr="Grafik6"/>
+            <p:cNvPr id="474" name="Grafik6" descr="Grafik6"/>
             <p:cNvPicPr>
               <a:picLocks noChangeAspect="1"/>
             </p:cNvPicPr>
@@ -11635,7 +11551,7 @@
         </p:pic>
         <p:sp>
           <p:nvSpPr>
-            <p:cNvPr id="478" name="Textbox6"/>
+            <p:cNvPr id="475" name="Textbox6"/>
             <p:cNvSpPr txBox="1"/>
             <p:nvPr/>
           </p:nvSpPr>
@@ -11720,7 +11636,7 @@
         </p:sp>
         <p:pic>
           <p:nvPicPr>
-            <p:cNvPr id="479" name="Grafik14" descr="Grafik14"/>
+            <p:cNvPr id="476" name="Grafik14" descr="Grafik14"/>
             <p:cNvPicPr>
               <a:picLocks noChangeAspect="1"/>
             </p:cNvPicPr>
@@ -11752,7 +11668,7 @@
       </p:grpSp>
       <p:grpSp>
         <p:nvGrpSpPr>
-          <p:cNvPr id="485" name="Group3"/>
+          <p:cNvPr id="482" name="Group3"/>
           <p:cNvGrpSpPr/>
           <p:nvPr/>
         </p:nvGrpSpPr>
@@ -11766,7 +11682,7 @@
         </p:grpSpPr>
         <p:pic>
           <p:nvPicPr>
-            <p:cNvPr id="481" name="Grafik3" descr="Grafik3"/>
+            <p:cNvPr id="478" name="Grafik3" descr="Grafik3"/>
             <p:cNvPicPr>
               <a:picLocks noChangeAspect="1"/>
             </p:cNvPicPr>
@@ -11797,7 +11713,7 @@
         </p:pic>
         <p:sp>
           <p:nvSpPr>
-            <p:cNvPr id="482" name="Textbox7"/>
+            <p:cNvPr id="479" name="Textbox7"/>
             <p:cNvSpPr txBox="1"/>
             <p:nvPr/>
           </p:nvSpPr>
@@ -11858,7 +11774,7 @@
         </p:sp>
         <p:pic>
           <p:nvPicPr>
-            <p:cNvPr id="483" name="Grafik8" descr="Grafik8"/>
+            <p:cNvPr id="480" name="Grafik8" descr="Grafik8"/>
             <p:cNvPicPr>
               <a:picLocks noChangeAspect="1"/>
             </p:cNvPicPr>
@@ -11889,7 +11805,7 @@
         </p:pic>
         <p:sp>
           <p:nvSpPr>
-            <p:cNvPr id="484" name="Linie1"/>
+            <p:cNvPr id="481" name="Linie1"/>
             <p:cNvSpPr/>
             <p:nvPr/>
           </p:nvSpPr>
@@ -11932,7 +11848,7 @@
       </p:grpSp>
       <p:grpSp>
         <p:nvGrpSpPr>
-          <p:cNvPr id="490" name="Group6"/>
+          <p:cNvPr id="487" name="Group6"/>
           <p:cNvGrpSpPr/>
           <p:nvPr/>
         </p:nvGrpSpPr>
@@ -11946,7 +11862,7 @@
         </p:grpSpPr>
         <p:pic>
           <p:nvPicPr>
-            <p:cNvPr id="486" name="Grafik7" descr="Grafik7"/>
+            <p:cNvPr id="483" name="Grafik7" descr="Grafik7"/>
             <p:cNvPicPr>
               <a:picLocks noChangeAspect="1"/>
             </p:cNvPicPr>
@@ -11977,7 +11893,7 @@
         </p:pic>
         <p:sp>
           <p:nvSpPr>
-            <p:cNvPr id="487" name="Textbox10"/>
+            <p:cNvPr id="484" name="Textbox10"/>
             <p:cNvSpPr txBox="1"/>
             <p:nvPr/>
           </p:nvSpPr>
@@ -12038,7 +11954,7 @@
         </p:sp>
         <p:pic>
           <p:nvPicPr>
-            <p:cNvPr id="488" name="Grafik17" descr="Grafik17"/>
+            <p:cNvPr id="485" name="Grafik17" descr="Grafik17"/>
             <p:cNvPicPr>
               <a:picLocks noChangeAspect="1"/>
             </p:cNvPicPr>
@@ -12069,7 +11985,7 @@
         </p:pic>
         <p:sp>
           <p:nvSpPr>
-            <p:cNvPr id="489" name="Ellipse1"/>
+            <p:cNvPr id="486" name="Ellipse1"/>
             <p:cNvSpPr/>
             <p:nvPr/>
           </p:nvSpPr>
@@ -12126,7 +12042,7 @@
       </p:grpSp>
       <p:grpSp>
         <p:nvGrpSpPr>
-          <p:cNvPr id="495" name="Group4"/>
+          <p:cNvPr id="492" name="Group4"/>
           <p:cNvGrpSpPr/>
           <p:nvPr/>
         </p:nvGrpSpPr>
@@ -12140,7 +12056,7 @@
         </p:grpSpPr>
         <p:pic>
           <p:nvPicPr>
-            <p:cNvPr id="491" name="Grafik4" descr="Grafik4"/>
+            <p:cNvPr id="488" name="Grafik4" descr="Grafik4"/>
             <p:cNvPicPr>
               <a:picLocks noChangeAspect="1"/>
             </p:cNvPicPr>
@@ -12171,7 +12087,7 @@
         </p:pic>
         <p:sp>
           <p:nvSpPr>
-            <p:cNvPr id="492" name="Textbox8"/>
+            <p:cNvPr id="489" name="Textbox8"/>
             <p:cNvSpPr txBox="1"/>
             <p:nvPr/>
           </p:nvSpPr>
@@ -12232,7 +12148,7 @@
         </p:sp>
         <p:pic>
           <p:nvPicPr>
-            <p:cNvPr id="493" name="Grafik16" descr="Grafik16"/>
+            <p:cNvPr id="490" name="Grafik16" descr="Grafik16"/>
             <p:cNvPicPr>
               <a:picLocks noChangeAspect="1"/>
             </p:cNvPicPr>
@@ -12263,7 +12179,7 @@
         </p:pic>
         <p:sp>
           <p:nvSpPr>
-            <p:cNvPr id="494" name="Linie2"/>
+            <p:cNvPr id="491" name="Linie2"/>
             <p:cNvSpPr/>
             <p:nvPr/>
           </p:nvSpPr>
@@ -12306,7 +12222,7 @@
       </p:grpSp>
       <p:grpSp>
         <p:nvGrpSpPr>
-          <p:cNvPr id="500" name="Group5"/>
+          <p:cNvPr id="497" name="Group5"/>
           <p:cNvGrpSpPr/>
           <p:nvPr/>
         </p:nvGrpSpPr>
@@ -12320,7 +12236,7 @@
         </p:grpSpPr>
         <p:pic>
           <p:nvPicPr>
-            <p:cNvPr id="496" name="Grafik2" descr="Grafik2"/>
+            <p:cNvPr id="493" name="Grafik2" descr="Grafik2"/>
             <p:cNvPicPr>
               <a:picLocks noChangeAspect="1"/>
             </p:cNvPicPr>
@@ -12351,7 +12267,7 @@
         </p:pic>
         <p:sp>
           <p:nvSpPr>
-            <p:cNvPr id="497" name="Textbox9"/>
+            <p:cNvPr id="494" name="Textbox9"/>
             <p:cNvSpPr txBox="1"/>
             <p:nvPr/>
           </p:nvSpPr>
@@ -12412,7 +12328,7 @@
         </p:sp>
         <p:pic>
           <p:nvPicPr>
-            <p:cNvPr id="498" name="Grafik15" descr="Grafik15"/>
+            <p:cNvPr id="495" name="Grafik15" descr="Grafik15"/>
             <p:cNvPicPr>
               <a:picLocks noChangeAspect="1"/>
             </p:cNvPicPr>
@@ -12443,7 +12359,7 @@
         </p:pic>
         <p:sp>
           <p:nvSpPr>
-            <p:cNvPr id="499" name="Linie3"/>
+            <p:cNvPr id="496" name="Linie3"/>
             <p:cNvSpPr/>
             <p:nvPr/>
           </p:nvSpPr>
@@ -12486,7 +12402,7 @@
       </p:grpSp>
       <p:pic>
         <p:nvPicPr>
-          <p:cNvPr id="501" name="Grafik18" descr="Grafik18"/>
+          <p:cNvPr id="498" name="Grafik18" descr="Grafik18"/>
           <p:cNvPicPr>
             <a:picLocks noChangeAspect="1"/>
           </p:cNvPicPr>
@@ -12515,7 +12431,7 @@
       </p:pic>
       <p:pic>
         <p:nvPicPr>
-          <p:cNvPr id="502" name="Grafik19" descr="Grafik19"/>
+          <p:cNvPr id="499" name="Grafik19" descr="Grafik19"/>
           <p:cNvPicPr>
             <a:picLocks noChangeAspect="1"/>
           </p:cNvPicPr>
@@ -12544,7 +12460,7 @@
       </p:pic>
       <p:sp>
         <p:nvSpPr>
-          <p:cNvPr id="503" name="Textbox11"/>
+          <p:cNvPr id="500" name="Textbox11"/>
           <p:cNvSpPr txBox="1"/>
           <p:nvPr/>
         </p:nvSpPr>
@@ -12602,7 +12518,7 @@
       </p:sp>
       <p:sp>
         <p:nvSpPr>
-          <p:cNvPr id="504" name="Textbox12"/>
+          <p:cNvPr id="501" name="Textbox12"/>
           <p:cNvSpPr txBox="1"/>
           <p:nvPr/>
         </p:nvSpPr>
@@ -12660,7 +12576,7 @@
       </p:sp>
       <p:grpSp>
         <p:nvGrpSpPr>
-          <p:cNvPr id="507" name="AutoForm1"/>
+          <p:cNvPr id="504" name="AutoForm1"/>
           <p:cNvGrpSpPr/>
           <p:nvPr/>
         </p:nvGrpSpPr>
@@ -12674,7 +12590,7 @@
         </p:grpSpPr>
         <p:sp>
           <p:nvSpPr>
-            <p:cNvPr id="505" name="Rounded Rectangle"/>
+            <p:cNvPr id="502" name="Rounded Rectangle"/>
             <p:cNvSpPr/>
             <p:nvPr/>
           </p:nvSpPr>
@@ -12732,7 +12648,7 @@
         </p:sp>
         <p:sp>
           <p:nvSpPr>
-            <p:cNvPr id="506" name="«Concept»…"/>
+            <p:cNvPr id="503" name="«Concept»…"/>
             <p:cNvSpPr txBox="1"/>
             <p:nvPr/>
           </p:nvSpPr>
@@ -12818,7 +12734,7 @@
       </p:grpSp>
       <p:sp>
         <p:nvSpPr>
-          <p:cNvPr id="508" name="Rechteck1"/>
+          <p:cNvPr id="505" name="Rechteck1"/>
           <p:cNvSpPr/>
           <p:nvPr/>
         </p:nvSpPr>
@@ -12856,7 +12772,7 @@
       </p:sp>
       <p:sp>
         <p:nvSpPr>
-          <p:cNvPr id="509" name="Connector1"/>
+          <p:cNvPr id="506" name="Connector1"/>
           <p:cNvSpPr/>
           <p:nvPr/>
         </p:nvSpPr>
@@ -12893,7 +12809,7 @@
       </p:sp>
       <p:sp>
         <p:nvSpPr>
-          <p:cNvPr id="510" name="Connector2"/>
+          <p:cNvPr id="507" name="Connector2"/>
           <p:cNvSpPr/>
           <p:nvPr/>
         </p:nvSpPr>
@@ -12929,7 +12845,7 @@
       </p:sp>
       <p:grpSp>
         <p:nvGrpSpPr>
-          <p:cNvPr id="513" name="AutoShape9"/>
+          <p:cNvPr id="510" name="AutoShape9"/>
           <p:cNvGrpSpPr/>
           <p:nvPr/>
         </p:nvGrpSpPr>
@@ -12943,7 +12859,7 @@
         </p:grpSpPr>
         <p:sp>
           <p:nvSpPr>
-            <p:cNvPr id="511" name="Rounded Rectangle"/>
+            <p:cNvPr id="508" name="Rounded Rectangle"/>
             <p:cNvSpPr/>
             <p:nvPr/>
           </p:nvSpPr>
@@ -13001,7 +12917,7 @@
         </p:sp>
         <p:sp>
           <p:nvSpPr>
-            <p:cNvPr id="512" name="«SourceAnnotation»…"/>
+            <p:cNvPr id="509" name="«SourceAnnotation»…"/>
             <p:cNvSpPr txBox="1"/>
             <p:nvPr/>
           </p:nvSpPr>
@@ -13087,7 +13003,7 @@
       </p:grpSp>
       <p:sp>
         <p:nvSpPr>
-          <p:cNvPr id="514" name="Connector3"/>
+          <p:cNvPr id="511" name="Connector3"/>
           <p:cNvSpPr/>
           <p:nvPr/>
         </p:nvSpPr>
@@ -13160,7 +13076,7 @@
                                       <p:cBhvr>
                                         <p:cTn id="6" fill="hold"/>
                                         <p:tgtEl>
-                                          <p:spTgt spid="417"/>
+                                          <p:spTgt spid="414"/>
                                         </p:tgtEl>
                                         <p:attrNameLst>
                                           <p:attrName>style.visibility</p:attrName>
@@ -13195,7 +13111,7 @@
                                       <p:cBhvr>
                                         <p:cTn id="9" fill="hold"/>
                                         <p:tgtEl>
-                                          <p:spTgt spid="420"/>
+                                          <p:spTgt spid="417"/>
                                         </p:tgtEl>
                                         <p:attrNameLst>
                                           <p:attrName>style.visibility</p:attrName>
@@ -13230,7 +13146,7 @@
                                       <p:cBhvr>
                                         <p:cTn id="12" fill="hold"/>
                                         <p:tgtEl>
-                                          <p:spTgt spid="423"/>
+                                          <p:spTgt spid="420"/>
                                         </p:tgtEl>
                                         <p:attrNameLst>
                                           <p:attrName>style.visibility</p:attrName>
@@ -13265,7 +13181,7 @@
                                       <p:cBhvr>
                                         <p:cTn id="15" fill="hold"/>
                                         <p:tgtEl>
-                                          <p:spTgt spid="510"/>
+                                          <p:spTgt spid="507"/>
                                         </p:tgtEl>
                                         <p:attrNameLst>
                                           <p:attrName>style.visibility</p:attrName>
@@ -13309,7 +13225,7 @@
                                       <p:cBhvr>
                                         <p:cTn id="19" fill="hold"/>
                                         <p:tgtEl>
-                                          <p:spTgt spid="476"/>
+                                          <p:spTgt spid="473"/>
                                         </p:tgtEl>
                                         <p:attrNameLst>
                                           <p:attrName>style.visibility</p:attrName>
@@ -13344,7 +13260,7 @@
                                       <p:cBhvr>
                                         <p:cTn id="22" fill="hold"/>
                                         <p:tgtEl>
-                                          <p:spTgt spid="480"/>
+                                          <p:spTgt spid="477"/>
                                         </p:tgtEl>
                                         <p:attrNameLst>
                                           <p:attrName>style.visibility</p:attrName>
@@ -13388,7 +13304,7 @@
                                       <p:cBhvr>
                                         <p:cTn id="26" fill="hold"/>
                                         <p:tgtEl>
-                                          <p:spTgt spid="520"/>
+                                          <p:spTgt spid="517"/>
                                         </p:tgtEl>
                                         <p:attrNameLst>
                                           <p:attrName>style.visibility</p:attrName>
@@ -13423,7 +13339,7 @@
                                       <p:cBhvr>
                                         <p:cTn id="29" fill="hold"/>
                                         <p:tgtEl>
-                                          <p:spTgt spid="426"/>
+                                          <p:spTgt spid="423"/>
                                         </p:tgtEl>
                                         <p:attrNameLst>
                                           <p:attrName>style.visibility</p:attrName>
@@ -13458,7 +13374,7 @@
                                       <p:cBhvr>
                                         <p:cTn id="32" fill="hold"/>
                                         <p:tgtEl>
-                                          <p:spTgt spid="429"/>
+                                          <p:spTgt spid="426"/>
                                         </p:tgtEl>
                                         <p:attrNameLst>
                                           <p:attrName>style.visibility</p:attrName>
@@ -13493,7 +13409,7 @@
                                       <p:cBhvr>
                                         <p:cTn id="35" fill="hold"/>
                                         <p:tgtEl>
-                                          <p:spTgt spid="464"/>
+                                          <p:spTgt spid="461"/>
                                         </p:tgtEl>
                                         <p:attrNameLst>
                                           <p:attrName>style.visibility</p:attrName>
@@ -13528,7 +13444,7 @@
                                       <p:cBhvr>
                                         <p:cTn id="38" fill="hold"/>
                                         <p:tgtEl>
-                                          <p:spTgt spid="468"/>
+                                          <p:spTgt spid="465"/>
                                         </p:tgtEl>
                                         <p:attrNameLst>
                                           <p:attrName>style.visibility</p:attrName>
@@ -13563,7 +13479,7 @@
                                       <p:cBhvr>
                                         <p:cTn id="41" fill="hold"/>
                                         <p:tgtEl>
-                                          <p:spTgt spid="472"/>
+                                          <p:spTgt spid="469"/>
                                         </p:tgtEl>
                                         <p:attrNameLst>
                                           <p:attrName>style.visibility</p:attrName>
@@ -13611,7 +13527,7 @@
                                           </p:stCondLst>
                                         </p:cTn>
                                         <p:tgtEl>
-                                          <p:spTgt spid="520"/>
+                                          <p:spTgt spid="517"/>
                                         </p:tgtEl>
                                         <p:attrNameLst>
                                           <p:attrName>style.visibility</p:attrName>
@@ -13646,7 +13562,7 @@
                                       <p:cBhvr>
                                         <p:cTn id="48" fill="hold"/>
                                         <p:tgtEl>
-                                          <p:spTgt spid="432"/>
+                                          <p:spTgt spid="429"/>
                                         </p:tgtEl>
                                         <p:attrNameLst>
                                           <p:attrName>style.visibility</p:attrName>
@@ -13681,7 +13597,7 @@
                                       <p:cBhvr>
                                         <p:cTn id="51" fill="hold"/>
                                         <p:tgtEl>
-                                          <p:spTgt spid="435"/>
+                                          <p:spTgt spid="432"/>
                                         </p:tgtEl>
                                         <p:attrNameLst>
                                           <p:attrName>style.visibility</p:attrName>
@@ -13716,7 +13632,7 @@
                                       <p:cBhvr>
                                         <p:cTn id="54" fill="hold"/>
                                         <p:tgtEl>
-                                          <p:spTgt spid="455"/>
+                                          <p:spTgt spid="452"/>
                                         </p:tgtEl>
                                         <p:attrNameLst>
                                           <p:attrName>style.visibility</p:attrName>
@@ -13751,7 +13667,7 @@
                                       <p:cBhvr>
                                         <p:cTn id="57" fill="hold"/>
                                         <p:tgtEl>
-                                          <p:spTgt spid="467"/>
+                                          <p:spTgt spid="464"/>
                                         </p:tgtEl>
                                         <p:attrNameLst>
                                           <p:attrName>style.visibility</p:attrName>
@@ -13786,7 +13702,7 @@
                                       <p:cBhvr>
                                         <p:cTn id="60" fill="hold"/>
                                         <p:tgtEl>
-                                          <p:spTgt spid="471"/>
+                                          <p:spTgt spid="468"/>
                                         </p:tgtEl>
                                         <p:attrNameLst>
                                           <p:attrName>style.visibility</p:attrName>
@@ -13821,7 +13737,7 @@
                                       <p:cBhvr>
                                         <p:cTn id="63" fill="hold"/>
                                         <p:tgtEl>
-                                          <p:spTgt spid="519"/>
+                                          <p:spTgt spid="516"/>
                                         </p:tgtEl>
                                         <p:attrNameLst>
                                           <p:attrName>style.visibility</p:attrName>
@@ -13869,7 +13785,7 @@
                                           </p:stCondLst>
                                         </p:cTn>
                                         <p:tgtEl>
-                                          <p:spTgt spid="519"/>
+                                          <p:spTgt spid="516"/>
                                         </p:tgtEl>
                                         <p:attrNameLst>
                                           <p:attrName>style.visibility</p:attrName>
@@ -13904,7 +13820,7 @@
                                       <p:cBhvr>
                                         <p:cTn id="70" fill="hold"/>
                                         <p:tgtEl>
-                                          <p:spTgt spid="518"/>
+                                          <p:spTgt spid="515"/>
                                         </p:tgtEl>
                                         <p:attrNameLst>
                                           <p:attrName>style.visibility</p:attrName>
@@ -13939,7 +13855,7 @@
                                       <p:cBhvr>
                                         <p:cTn id="73" fill="hold"/>
                                         <p:tgtEl>
-                                          <p:spTgt spid="517"/>
+                                          <p:spTgt spid="514"/>
                                         </p:tgtEl>
                                         <p:attrNameLst>
                                           <p:attrName>style.visibility</p:attrName>
@@ -13974,7 +13890,7 @@
                                       <p:cBhvr>
                                         <p:cTn id="76" fill="hold"/>
                                         <p:tgtEl>
-                                          <p:spTgt spid="438"/>
+                                          <p:spTgt spid="435"/>
                                         </p:tgtEl>
                                         <p:attrNameLst>
                                           <p:attrName>style.visibility</p:attrName>
@@ -14009,7 +13925,7 @@
                                       <p:cBhvr>
                                         <p:cTn id="79" fill="hold"/>
                                         <p:tgtEl>
-                                          <p:spTgt spid="441"/>
+                                          <p:spTgt spid="438"/>
                                         </p:tgtEl>
                                         <p:attrNameLst>
                                           <p:attrName>style.visibility</p:attrName>
@@ -14044,7 +13960,7 @@
                                       <p:cBhvr>
                                         <p:cTn id="82" fill="hold"/>
                                         <p:tgtEl>
-                                          <p:spTgt spid="444"/>
+                                          <p:spTgt spid="441"/>
                                         </p:tgtEl>
                                         <p:attrNameLst>
                                           <p:attrName>style.visibility</p:attrName>
@@ -14079,7 +13995,7 @@
                                       <p:cBhvr>
                                         <p:cTn id="85" fill="hold"/>
                                         <p:tgtEl>
-                                          <p:spTgt spid="454"/>
+                                          <p:spTgt spid="451"/>
                                         </p:tgtEl>
                                         <p:attrNameLst>
                                           <p:attrName>style.visibility</p:attrName>
@@ -14114,7 +14030,7 @@
                                       <p:cBhvr>
                                         <p:cTn id="88" fill="hold"/>
                                         <p:tgtEl>
-                                          <p:spTgt spid="466"/>
+                                          <p:spTgt spid="463"/>
                                         </p:tgtEl>
                                         <p:attrNameLst>
                                           <p:attrName>style.visibility</p:attrName>
@@ -14149,7 +14065,7 @@
                                       <p:cBhvr>
                                         <p:cTn id="91" fill="hold"/>
                                         <p:tgtEl>
-                                          <p:spTgt spid="469"/>
+                                          <p:spTgt spid="466"/>
                                         </p:tgtEl>
                                         <p:attrNameLst>
                                           <p:attrName>style.visibility</p:attrName>
@@ -14184,7 +14100,7 @@
                                       <p:cBhvr>
                                         <p:cTn id="94" fill="hold"/>
                                         <p:tgtEl>
-                                          <p:spTgt spid="509"/>
+                                          <p:spTgt spid="506"/>
                                         </p:tgtEl>
                                         <p:attrNameLst>
                                           <p:attrName>style.visibility</p:attrName>
@@ -14232,7 +14148,7 @@
                                           </p:stCondLst>
                                         </p:cTn>
                                         <p:tgtEl>
-                                          <p:spTgt spid="518"/>
+                                          <p:spTgt spid="515"/>
                                         </p:tgtEl>
                                         <p:attrNameLst>
                                           <p:attrName>style.visibility</p:attrName>
@@ -14271,7 +14187,7 @@
                                           </p:stCondLst>
                                         </p:cTn>
                                         <p:tgtEl>
-                                          <p:spTgt spid="517"/>
+                                          <p:spTgt spid="514"/>
                                         </p:tgtEl>
                                         <p:attrNameLst>
                                           <p:attrName>style.visibility</p:attrName>
@@ -14310,7 +14226,7 @@
                                           </p:stCondLst>
                                         </p:cTn>
                                         <p:tgtEl>
-                                          <p:spTgt spid="509"/>
+                                          <p:spTgt spid="506"/>
                                         </p:tgtEl>
                                         <p:attrNameLst>
                                           <p:attrName>style.visibility</p:attrName>
@@ -14345,7 +14261,7 @@
                                       <p:cBhvr>
                                         <p:cTn id="107" fill="hold"/>
                                         <p:tgtEl>
-                                          <p:spTgt spid="516"/>
+                                          <p:spTgt spid="513"/>
                                         </p:tgtEl>
                                         <p:attrNameLst>
                                           <p:attrName>style.visibility</p:attrName>
@@ -14380,7 +14296,7 @@
                                       <p:cBhvr>
                                         <p:cTn id="110" fill="hold"/>
                                         <p:tgtEl>
-                                          <p:spTgt spid="515"/>
+                                          <p:spTgt spid="512"/>
                                         </p:tgtEl>
                                         <p:attrNameLst>
                                           <p:attrName>style.visibility</p:attrName>
@@ -14415,7 +14331,7 @@
                                       <p:cBhvr>
                                         <p:cTn id="113" fill="hold"/>
                                         <p:tgtEl>
-                                          <p:spTgt spid="447"/>
+                                          <p:spTgt spid="444"/>
                                         </p:tgtEl>
                                         <p:attrNameLst>
                                           <p:attrName>style.visibility</p:attrName>
@@ -14450,7 +14366,7 @@
                                       <p:cBhvr>
                                         <p:cTn id="116" fill="hold"/>
                                         <p:tgtEl>
-                                          <p:spTgt spid="450"/>
+                                          <p:spTgt spid="447"/>
                                         </p:tgtEl>
                                         <p:attrNameLst>
                                           <p:attrName>style.visibility</p:attrName>
@@ -14485,7 +14401,7 @@
                                       <p:cBhvr>
                                         <p:cTn id="119" fill="hold"/>
                                         <p:tgtEl>
-                                          <p:spTgt spid="453"/>
+                                          <p:spTgt spid="450"/>
                                         </p:tgtEl>
                                         <p:attrNameLst>
                                           <p:attrName>style.visibility</p:attrName>
@@ -14520,7 +14436,7 @@
                                       <p:cBhvr>
                                         <p:cTn id="122" fill="hold"/>
                                         <p:tgtEl>
-                                          <p:spTgt spid="456"/>
+                                          <p:spTgt spid="453"/>
                                         </p:tgtEl>
                                         <p:attrNameLst>
                                           <p:attrName>style.visibility</p:attrName>
@@ -14555,7 +14471,7 @@
                                       <p:cBhvr>
                                         <p:cTn id="125" fill="hold"/>
                                         <p:tgtEl>
-                                          <p:spTgt spid="465"/>
+                                          <p:spTgt spid="462"/>
                                         </p:tgtEl>
                                         <p:attrNameLst>
                                           <p:attrName>style.visibility</p:attrName>
@@ -14590,7 +14506,7 @@
                                       <p:cBhvr>
                                         <p:cTn id="128" fill="hold"/>
                                         <p:tgtEl>
-                                          <p:spTgt spid="470"/>
+                                          <p:spTgt spid="467"/>
                                         </p:tgtEl>
                                         <p:attrNameLst>
                                           <p:attrName>style.visibility</p:attrName>
@@ -14638,7 +14554,7 @@
                                           </p:stCondLst>
                                         </p:cTn>
                                         <p:tgtEl>
-                                          <p:spTgt spid="516"/>
+                                          <p:spTgt spid="513"/>
                                         </p:tgtEl>
                                         <p:attrNameLst>
                                           <p:attrName>style.visibility</p:attrName>
@@ -14677,7 +14593,7 @@
                                           </p:stCondLst>
                                         </p:cTn>
                                         <p:tgtEl>
-                                          <p:spTgt spid="515"/>
+                                          <p:spTgt spid="512"/>
                                         </p:tgtEl>
                                         <p:attrNameLst>
                                           <p:attrName>style.visibility</p:attrName>
@@ -14721,7 +14637,7 @@
                                       <p:cBhvr>
                                         <p:cTn id="139" fill="hold"/>
                                         <p:tgtEl>
-                                          <p:spTgt spid="485"/>
+                                          <p:spTgt spid="482"/>
                                         </p:tgtEl>
                                         <p:attrNameLst>
                                           <p:attrName>style.visibility</p:attrName>
@@ -14756,7 +14672,7 @@
                                       <p:cBhvr>
                                         <p:cTn id="142" fill="hold"/>
                                         <p:tgtEl>
-                                          <p:spTgt spid="513"/>
+                                          <p:spTgt spid="510"/>
                                         </p:tgtEl>
                                         <p:attrNameLst>
                                           <p:attrName>style.visibility</p:attrName>
@@ -14791,7 +14707,7 @@
                                       <p:cBhvr>
                                         <p:cTn id="145" fill="hold"/>
                                         <p:tgtEl>
-                                          <p:spTgt spid="514"/>
+                                          <p:spTgt spid="511"/>
                                         </p:tgtEl>
                                         <p:attrNameLst>
                                           <p:attrName>style.visibility</p:attrName>
@@ -14839,7 +14755,7 @@
                                           </p:stCondLst>
                                         </p:cTn>
                                         <p:tgtEl>
-                                          <p:spTgt spid="513"/>
+                                          <p:spTgt spid="510"/>
                                         </p:tgtEl>
                                         <p:attrNameLst>
                                           <p:attrName>style.visibility</p:attrName>
@@ -14878,7 +14794,7 @@
                                           </p:stCondLst>
                                         </p:cTn>
                                         <p:tgtEl>
-                                          <p:spTgt spid="514"/>
+                                          <p:spTgt spid="511"/>
                                         </p:tgtEl>
                                         <p:attrNameLst>
                                           <p:attrName>style.visibility</p:attrName>
@@ -14913,7 +14829,7 @@
                                       <p:cBhvr>
                                         <p:cTn id="155" fill="hold"/>
                                         <p:tgtEl>
-                                          <p:spTgt spid="495"/>
+                                          <p:spTgt spid="492"/>
                                         </p:tgtEl>
                                         <p:attrNameLst>
                                           <p:attrName>style.visibility</p:attrName>
@@ -14948,7 +14864,7 @@
                                       <p:cBhvr>
                                         <p:cTn id="158" fill="hold"/>
                                         <p:tgtEl>
-                                          <p:spTgt spid="500"/>
+                                          <p:spTgt spid="497"/>
                                         </p:tgtEl>
                                         <p:attrNameLst>
                                           <p:attrName>style.visibility</p:attrName>
@@ -14992,7 +14908,7 @@
                                       <p:cBhvr>
                                         <p:cTn id="162" fill="hold"/>
                                         <p:tgtEl>
-                                          <p:spTgt spid="490"/>
+                                          <p:spTgt spid="487"/>
                                         </p:tgtEl>
                                         <p:attrNameLst>
                                           <p:attrName>style.visibility</p:attrName>
@@ -15033,62 +14949,62 @@
       </p:par>
     </p:tnLst>
     <p:bldLst>
-      <p:bldP build="whole" bldLvl="1" animBg="1" rev="0" advAuto="0" spid="476" grpId="5"/>
-      <p:bldP build="whole" bldLvl="1" animBg="1" rev="0" advAuto="0" spid="426" grpId="8"/>
-      <p:bldP build="whole" bldLvl="1" animBg="1" rev="0" advAuto="0" spid="518" grpId="21"/>
-      <p:bldP build="whole" bldLvl="1" animBg="1" rev="0" advAuto="0" spid="417" grpId="1"/>
-      <p:bldP build="whole" bldLvl="1" animBg="1" rev="0" advAuto="0" spid="510" grpId="4"/>
-      <p:bldP build="whole" bldLvl="1" animBg="1" rev="0" advAuto="0" spid="470" grpId="40"/>
-      <p:bldP build="whole" bldLvl="1" animBg="1" rev="0" advAuto="0" spid="469" grpId="28"/>
-      <p:bldP build="whole" bldLvl="1" animBg="1" rev="0" advAuto="0" spid="467" grpId="17"/>
-      <p:bldP build="whole" bldLvl="1" animBg="1" rev="0" advAuto="0" spid="455" grpId="16"/>
-      <p:bldP build="whole" bldLvl="1" animBg="1" rev="0" advAuto="0" spid="516" grpId="41"/>
-      <p:bldP build="whole" bldLvl="1" animBg="1" rev="0" advAuto="0" spid="518" grpId="30"/>
-      <p:bldP build="whole" bldLvl="1" animBg="1" rev="0" advAuto="0" spid="490" grpId="50"/>
-      <p:bldP build="whole" bldLvl="1" animBg="1" rev="0" advAuto="0" spid="509" grpId="29"/>
-      <p:bldP build="whole" bldLvl="1" animBg="1" rev="0" advAuto="0" spid="520" grpId="7"/>
-      <p:bldP build="whole" bldLvl="1" animBg="1" rev="0" advAuto="0" spid="429" grpId="9"/>
-      <p:bldP build="whole" bldLvl="1" animBg="1" rev="0" advAuto="0" spid="509" grpId="32"/>
-      <p:bldP build="whole" bldLvl="1" animBg="1" rev="0" advAuto="0" spid="454" grpId="26"/>
-      <p:bldP build="whole" bldLvl="1" animBg="1" rev="0" advAuto="0" spid="472" grpId="12"/>
-      <p:bldP build="whole" bldLvl="1" animBg="1" rev="0" advAuto="0" spid="420" grpId="2"/>
-      <p:bldP build="whole" bldLvl="1" animBg="1" rev="0" advAuto="0" spid="520" grpId="13"/>
-      <p:bldP build="whole" bldLvl="1" animBg="1" rev="0" advAuto="0" spid="438" grpId="23"/>
-      <p:bldP build="whole" bldLvl="1" animBg="1" rev="0" advAuto="0" spid="447" grpId="35"/>
-      <p:bldP build="whole" bldLvl="1" animBg="1" rev="0" advAuto="0" spid="519" grpId="19"/>
-      <p:bldP build="whole" bldLvl="1" animBg="1" rev="0" advAuto="0" spid="519" grpId="20"/>
-      <p:bldP build="whole" bldLvl="1" animBg="1" rev="0" advAuto="0" spid="450" grpId="36"/>
-      <p:bldP build="whole" bldLvl="1" animBg="1" rev="0" advAuto="0" spid="513" grpId="44"/>
-      <p:bldP build="whole" bldLvl="1" animBg="1" rev="0" advAuto="0" spid="464" grpId="10"/>
-      <p:bldP build="whole" bldLvl="1" animBg="1" rev="0" advAuto="0" spid="453" grpId="37"/>
-      <p:bldP build="whole" bldLvl="1" animBg="1" rev="0" advAuto="0" spid="466" grpId="27"/>
-      <p:bldP build="whole" bldLvl="1" animBg="1" rev="0" advAuto="0" spid="513" grpId="46"/>
-      <p:bldP build="whole" bldLvl="1" animBg="1" rev="0" advAuto="0" spid="485" grpId="43"/>
-      <p:bldP build="whole" bldLvl="1" animBg="1" rev="0" advAuto="0" spid="495" grpId="48"/>
-      <p:bldP build="whole" bldLvl="1" animBg="1" rev="0" advAuto="0" spid="515" grpId="34"/>
-      <p:bldP build="whole" bldLvl="1" animBg="1" rev="0" advAuto="0" spid="514" grpId="45"/>
-      <p:bldP build="whole" bldLvl="1" animBg="1" rev="0" advAuto="0" spid="441" grpId="24"/>
-      <p:bldP build="whole" bldLvl="1" animBg="1" rev="0" advAuto="0" spid="432" grpId="14"/>
-      <p:bldP build="whole" bldLvl="1" animBg="1" rev="0" advAuto="0" spid="423" grpId="3"/>
-      <p:bldP build="whole" bldLvl="1" animBg="1" rev="0" advAuto="0" spid="514" grpId="47"/>
-      <p:bldP build="whole" bldLvl="1" animBg="1" rev="0" advAuto="0" spid="480" grpId="6"/>
-      <p:bldP build="whole" bldLvl="1" animBg="1" rev="0" advAuto="0" spid="515" grpId="42"/>
-      <p:bldP build="whole" bldLvl="1" animBg="1" rev="0" advAuto="0" spid="500" grpId="49"/>
-      <p:bldP build="whole" bldLvl="1" animBg="1" rev="0" advAuto="0" spid="517" grpId="22"/>
-      <p:bldP build="whole" bldLvl="1" animBg="1" rev="0" advAuto="0" spid="456" grpId="38"/>
-      <p:bldP build="whole" bldLvl="1" animBg="1" rev="0" advAuto="0" spid="468" grpId="11"/>
-      <p:bldP build="whole" bldLvl="1" animBg="1" rev="0" advAuto="0" spid="471" grpId="18"/>
-      <p:bldP build="whole" bldLvl="1" animBg="1" rev="0" advAuto="0" spid="444" grpId="25"/>
-      <p:bldP build="whole" bldLvl="1" animBg="1" rev="0" advAuto="0" spid="517" grpId="31"/>
-      <p:bldP build="whole" bldLvl="1" animBg="1" rev="0" advAuto="0" spid="435" grpId="15"/>
-      <p:bldP build="whole" bldLvl="1" animBg="1" rev="0" advAuto="0" spid="465" grpId="39"/>
-      <p:bldP build="whole" bldLvl="1" animBg="1" rev="0" advAuto="0" spid="516" grpId="33"/>
+      <p:bldP build="whole" bldLvl="1" animBg="1" rev="0" advAuto="0" spid="512" grpId="42"/>
+      <p:bldP build="whole" bldLvl="1" animBg="1" rev="0" advAuto="0" spid="513" grpId="33"/>
+      <p:bldP build="whole" bldLvl="1" animBg="1" rev="0" advAuto="0" spid="420" grpId="3"/>
+      <p:bldP build="whole" bldLvl="1" animBg="1" rev="0" advAuto="0" spid="514" grpId="31"/>
+      <p:bldP build="whole" bldLvl="1" animBg="1" rev="0" advAuto="0" spid="517" grpId="7"/>
+      <p:bldP build="whole" bldLvl="1" animBg="1" rev="0" advAuto="0" spid="464" grpId="17"/>
+      <p:bldP build="whole" bldLvl="1" animBg="1" rev="0" advAuto="0" spid="429" grpId="14"/>
+      <p:bldP build="whole" bldLvl="1" animBg="1" rev="0" advAuto="0" spid="497" grpId="49"/>
+      <p:bldP build="whole" bldLvl="1" animBg="1" rev="0" advAuto="0" spid="487" grpId="50"/>
+      <p:bldP build="whole" bldLvl="1" animBg="1" rev="0" advAuto="0" spid="513" grpId="41"/>
+      <p:bldP build="whole" bldLvl="1" animBg="1" rev="0" advAuto="0" spid="517" grpId="13"/>
+      <p:bldP build="whole" bldLvl="1" animBg="1" rev="0" advAuto="0" spid="507" grpId="4"/>
+      <p:bldP build="whole" bldLvl="1" animBg="1" rev="0" advAuto="0" spid="516" grpId="19"/>
+      <p:bldP build="whole" bldLvl="1" animBg="1" rev="0" advAuto="0" spid="515" grpId="21"/>
+      <p:bldP build="whole" bldLvl="1" animBg="1" rev="0" advAuto="0" spid="506" grpId="29"/>
+      <p:bldP build="whole" bldLvl="1" animBg="1" rev="0" advAuto="0" spid="516" grpId="20"/>
+      <p:bldP build="whole" bldLvl="1" animBg="1" rev="0" advAuto="0" spid="506" grpId="32"/>
+      <p:bldP build="whole" bldLvl="1" animBg="1" rev="0" advAuto="0" spid="441" grpId="25"/>
+      <p:bldP build="whole" bldLvl="1" animBg="1" rev="0" advAuto="0" spid="466" grpId="28"/>
+      <p:bldP build="whole" bldLvl="1" animBg="1" rev="0" advAuto="0" spid="452" grpId="16"/>
+      <p:bldP build="whole" bldLvl="1" animBg="1" rev="0" advAuto="0" spid="467" grpId="40"/>
+      <p:bldP build="whole" bldLvl="1" animBg="1" rev="0" advAuto="0" spid="482" grpId="43"/>
+      <p:bldP build="whole" bldLvl="1" animBg="1" rev="0" advAuto="0" spid="515" grpId="30"/>
+      <p:bldP build="whole" bldLvl="1" animBg="1" rev="0" advAuto="0" spid="432" grpId="15"/>
+      <p:bldP build="whole" bldLvl="1" animBg="1" rev="0" advAuto="0" spid="423" grpId="8"/>
+      <p:bldP build="whole" bldLvl="1" animBg="1" rev="0" advAuto="0" spid="468" grpId="18"/>
+      <p:bldP build="whole" bldLvl="1" animBg="1" rev="0" advAuto="0" spid="473" grpId="5"/>
+      <p:bldP build="whole" bldLvl="1" animBg="1" rev="0" advAuto="0" spid="414" grpId="1"/>
+      <p:bldP build="whole" bldLvl="1" animBg="1" rev="0" advAuto="0" spid="511" grpId="45"/>
+      <p:bldP build="whole" bldLvl="1" animBg="1" rev="0" advAuto="0" spid="511" grpId="47"/>
+      <p:bldP build="whole" bldLvl="1" animBg="1" rev="0" advAuto="0" spid="469" grpId="12"/>
+      <p:bldP build="whole" bldLvl="1" animBg="1" rev="0" advAuto="0" spid="510" grpId="44"/>
+      <p:bldP build="whole" bldLvl="1" animBg="1" rev="0" advAuto="0" spid="453" grpId="38"/>
+      <p:bldP build="whole" bldLvl="1" animBg="1" rev="0" advAuto="0" spid="435" grpId="23"/>
+      <p:bldP build="whole" bldLvl="1" animBg="1" rev="0" advAuto="0" spid="461" grpId="10"/>
+      <p:bldP build="whole" bldLvl="1" animBg="1" rev="0" advAuto="0" spid="444" grpId="35"/>
+      <p:bldP build="whole" bldLvl="1" animBg="1" rev="0" advAuto="0" spid="510" grpId="46"/>
+      <p:bldP build="whole" bldLvl="1" animBg="1" rev="0" advAuto="0" spid="447" grpId="36"/>
+      <p:bldP build="whole" bldLvl="1" animBg="1" rev="0" advAuto="0" spid="417" grpId="2"/>
+      <p:bldP build="whole" bldLvl="1" animBg="1" rev="0" advAuto="0" spid="426" grpId="9"/>
+      <p:bldP build="whole" bldLvl="1" animBg="1" rev="0" advAuto="0" spid="450" grpId="37"/>
+      <p:bldP build="whole" bldLvl="1" animBg="1" rev="0" advAuto="0" spid="492" grpId="48"/>
+      <p:bldP build="whole" bldLvl="1" animBg="1" rev="0" advAuto="0" spid="512" grpId="34"/>
+      <p:bldP build="whole" bldLvl="1" animBg="1" rev="0" advAuto="0" spid="514" grpId="22"/>
+      <p:bldP build="whole" bldLvl="1" animBg="1" rev="0" advAuto="0" spid="451" grpId="26"/>
+      <p:bldP build="whole" bldLvl="1" animBg="1" rev="0" advAuto="0" spid="463" grpId="27"/>
+      <p:bldP build="whole" bldLvl="1" animBg="1" rev="0" advAuto="0" spid="438" grpId="24"/>
+      <p:bldP build="whole" bldLvl="1" animBg="1" rev="0" advAuto="0" spid="465" grpId="11"/>
+      <p:bldP build="whole" bldLvl="1" animBg="1" rev="0" advAuto="0" spid="477" grpId="6"/>
+      <p:bldP build="whole" bldLvl="1" animBg="1" rev="0" advAuto="0" spid="462" grpId="39"/>
     </p:bldLst>
   </p:timing>
 </p:sld>
 </file>
 
-<file path=ppt/slides/slide19.xml><?xml version="1.0" encoding="utf-8"?>
+<file path=ppt/slides/slide18.xml><?xml version="1.0" encoding="utf-8"?>
 <p:sld xmlns:a="http://schemas.openxmlformats.org/drawingml/2006/main" xmlns:r="http://schemas.openxmlformats.org/officeDocument/2006/relationships" xmlns:p="http://schemas.openxmlformats.org/presentationml/2006/main" xmlns:m="http://schemas.openxmlformats.org/officeDocument/2006/math" xmlns:a14="http://schemas.microsoft.com/office/drawing/2010/main" showMasterSp="1" showMasterPhAnim="1">
   <p:cSld>
     <p:spTree>
@@ -15107,7 +15023,7 @@
       </p:grpSpPr>
       <p:sp>
         <p:nvSpPr>
-          <p:cNvPr id="522" name="SlideTitle1"/>
+          <p:cNvPr id="519" name="SlideTitle1"/>
           <p:cNvSpPr txBox="1"/>
           <p:nvPr>
             <p:ph type="title"/>
@@ -15157,7 +15073,7 @@
       </p:sp>
       <p:pic>
         <p:nvPicPr>
-          <p:cNvPr id="523" name="Picture1" descr="Picture1"/>
+          <p:cNvPr id="520" name="Picture1" descr="Picture1"/>
           <p:cNvPicPr>
             <a:picLocks noChangeAspect="1"/>
           </p:cNvPicPr>
@@ -15186,7 +15102,7 @@
       </p:pic>
       <p:pic>
         <p:nvPicPr>
-          <p:cNvPr id="524" name="Picture2" descr="Picture2"/>
+          <p:cNvPr id="521" name="Picture2" descr="Picture2"/>
           <p:cNvPicPr>
             <a:picLocks noChangeAspect="1"/>
           </p:cNvPicPr>
@@ -15215,7 +15131,7 @@
       </p:pic>
       <p:sp>
         <p:nvSpPr>
-          <p:cNvPr id="525" name="Textbox1"/>
+          <p:cNvPr id="522" name="Textbox1"/>
           <p:cNvSpPr txBox="1"/>
           <p:nvPr/>
         </p:nvSpPr>
@@ -15263,7 +15179,7 @@
       </p:sp>
       <p:sp>
         <p:nvSpPr>
-          <p:cNvPr id="526" name="Textbox2"/>
+          <p:cNvPr id="523" name="Textbox2"/>
           <p:cNvSpPr txBox="1"/>
           <p:nvPr/>
         </p:nvSpPr>
@@ -15311,7 +15227,7 @@
       </p:sp>
       <p:sp>
         <p:nvSpPr>
-          <p:cNvPr id="527" name="Textbox3"/>
+          <p:cNvPr id="524" name="Textbox3"/>
           <p:cNvSpPr txBox="1"/>
           <p:nvPr/>
         </p:nvSpPr>
@@ -15359,7 +15275,7 @@
       </p:sp>
       <p:sp>
         <p:nvSpPr>
-          <p:cNvPr id="528" name="Ellipse2"/>
+          <p:cNvPr id="525" name="Ellipse2"/>
           <p:cNvSpPr/>
           <p:nvPr/>
         </p:nvSpPr>
@@ -15387,7 +15303,7 @@
       </p:sp>
       <p:sp>
         <p:nvSpPr>
-          <p:cNvPr id="529" name="Ellipse1"/>
+          <p:cNvPr id="526" name="Ellipse1"/>
           <p:cNvSpPr/>
           <p:nvPr/>
         </p:nvSpPr>
@@ -15415,7 +15331,7 @@
       </p:sp>
       <p:pic>
         <p:nvPicPr>
-          <p:cNvPr id="530" name="Picture4" descr="Picture4"/>
+          <p:cNvPr id="527" name="Picture4" descr="Picture4"/>
           <p:cNvPicPr>
             <a:picLocks noChangeAspect="1"/>
           </p:cNvPicPr>
@@ -15444,7 +15360,7 @@
       </p:pic>
       <p:sp>
         <p:nvSpPr>
-          <p:cNvPr id="531" name="Ellipse3"/>
+          <p:cNvPr id="528" name="Ellipse3"/>
           <p:cNvSpPr/>
           <p:nvPr/>
         </p:nvSpPr>
@@ -15509,7 +15425,7 @@
                                       <p:cBhvr>
                                         <p:cTn id="6" fill="hold"/>
                                         <p:tgtEl>
-                                          <p:spTgt spid="523"/>
+                                          <p:spTgt spid="520"/>
                                         </p:tgtEl>
                                         <p:attrNameLst>
                                           <p:attrName>style.visibility</p:attrName>
@@ -15544,7 +15460,7 @@
                                       <p:cBhvr>
                                         <p:cTn id="9" fill="hold"/>
                                         <p:tgtEl>
-                                          <p:spTgt spid="526"/>
+                                          <p:spTgt spid="523"/>
                                         </p:tgtEl>
                                         <p:attrNameLst>
                                           <p:attrName>style.visibility</p:attrName>
@@ -15579,7 +15495,7 @@
                                       <p:cBhvr>
                                         <p:cTn id="12" fill="hold"/>
                                         <p:tgtEl>
-                                          <p:spTgt spid="528"/>
+                                          <p:spTgt spid="525"/>
                                         </p:tgtEl>
                                         <p:attrNameLst>
                                           <p:attrName>style.visibility</p:attrName>
@@ -15614,7 +15530,7 @@
                                       <p:cBhvr>
                                         <p:cTn id="15" fill="hold"/>
                                         <p:tgtEl>
-                                          <p:spTgt spid="527"/>
+                                          <p:spTgt spid="524"/>
                                         </p:tgtEl>
                                         <p:attrNameLst>
                                           <p:attrName>style.visibility</p:attrName>
@@ -15649,7 +15565,7 @@
                                       <p:cBhvr>
                                         <p:cTn id="18" fill="hold"/>
                                         <p:tgtEl>
-                                          <p:spTgt spid="531"/>
+                                          <p:spTgt spid="528"/>
                                         </p:tgtEl>
                                         <p:attrNameLst>
                                           <p:attrName>style.visibility</p:attrName>
@@ -15690,17 +15606,17 @@
       </p:par>
     </p:tnLst>
     <p:bldLst>
-      <p:bldP build="whole" bldLvl="1" animBg="1" rev="0" advAuto="0" spid="523" grpId="1"/>
-      <p:bldP build="whole" bldLvl="1" animBg="1" rev="0" advAuto="0" spid="527" grpId="4"/>
-      <p:bldP build="whole" bldLvl="1" animBg="1" rev="0" advAuto="0" spid="528" grpId="3"/>
-      <p:bldP build="whole" bldLvl="1" animBg="1" rev="0" advAuto="0" spid="531" grpId="5"/>
-      <p:bldP build="whole" bldLvl="1" animBg="1" rev="0" advAuto="0" spid="526" grpId="2"/>
+      <p:bldP build="whole" bldLvl="1" animBg="1" rev="0" advAuto="0" spid="525" grpId="3"/>
+      <p:bldP build="whole" bldLvl="1" animBg="1" rev="0" advAuto="0" spid="520" grpId="1"/>
+      <p:bldP build="whole" bldLvl="1" animBg="1" rev="0" advAuto="0" spid="523" grpId="2"/>
+      <p:bldP build="whole" bldLvl="1" animBg="1" rev="0" advAuto="0" spid="524" grpId="4"/>
+      <p:bldP build="whole" bldLvl="1" animBg="1" rev="0" advAuto="0" spid="528" grpId="5"/>
     </p:bldLst>
   </p:timing>
 </p:sld>
 </file>
 
-<file path=ppt/slides/slide2.xml><?xml version="1.0" encoding="utf-8"?>
+<file path=ppt/slides/slide19.xml><?xml version="1.0" encoding="utf-8"?>
 <p:sld xmlns:a="http://schemas.openxmlformats.org/drawingml/2006/main" xmlns:r="http://schemas.openxmlformats.org/officeDocument/2006/relationships" xmlns:p="http://schemas.openxmlformats.org/presentationml/2006/main" xmlns:m="http://schemas.openxmlformats.org/officeDocument/2006/math" xmlns:a14="http://schemas.microsoft.com/office/drawing/2010/main" showMasterSp="1" showMasterPhAnim="1">
   <p:cSld>
     <p:spTree>
@@ -15719,107 +15635,7 @@
       </p:grpSpPr>
       <p:sp>
         <p:nvSpPr>
-          <p:cNvPr id="177" name="Title 2"/>
-          <p:cNvSpPr txBox="1"/>
-          <p:nvPr>
-            <p:ph type="title"/>
-          </p:nvPr>
-        </p:nvSpPr>
-        <p:spPr>
-          <a:prstGeom prst="rect">
-            <a:avLst/>
-          </a:prstGeom>
-        </p:spPr>
-        <p:txBody>
-          <a:bodyPr/>
-          <a:lstStyle/>
-          <a:p>
-            <a:pPr/>
-            <a:r>
-              <a:t>Short introduction</a:t>
-            </a:r>
-          </a:p>
-        </p:txBody>
-      </p:sp>
-      <p:sp>
-        <p:nvSpPr>
-          <p:cNvPr id="178" name="Text Placeholder 4"/>
-          <p:cNvSpPr txBox="1"/>
-          <p:nvPr>
-            <p:ph type="body" sz="quarter" idx="1"/>
-          </p:nvPr>
-        </p:nvSpPr>
-        <p:spPr>
-          <a:prstGeom prst="rect">
-            <a:avLst/>
-          </a:prstGeom>
-        </p:spPr>
-        <p:txBody>
-          <a:bodyPr/>
-          <a:lstStyle/>
-          <a:p>
-            <a:pPr/>
-          </a:p>
-        </p:txBody>
-      </p:sp>
-      <p:pic>
-        <p:nvPicPr>
-          <p:cNvPr id="179" name="Graphic 5" descr="Graphic 5"/>
-          <p:cNvPicPr>
-            <a:picLocks noChangeAspect="1"/>
-          </p:cNvPicPr>
-          <p:nvPr/>
-        </p:nvPicPr>
-        <p:blipFill>
-          <a:blip r:embed="rId2">
-            <a:extLst/>
-          </a:blip>
-          <a:stretch>
-            <a:fillRect/>
-          </a:stretch>
-        </p:blipFill>
-        <p:spPr>
-          <a:xfrm>
-            <a:off x="5535121" y="3394947"/>
-            <a:ext cx="1121758" cy="1127725"/>
-          </a:xfrm>
-          <a:prstGeom prst="rect">
-            <a:avLst/>
-          </a:prstGeom>
-          <a:ln w="12700">
-            <a:miter lim="400000"/>
-          </a:ln>
-        </p:spPr>
-      </p:pic>
-    </p:spTree>
-  </p:cSld>
-  <p:clrMapOvr>
-    <a:masterClrMapping/>
-  </p:clrMapOvr>
-  <p:transition xmlns:p14="http://schemas.microsoft.com/office/powerpoint/2010/main" spd="med" advClick="1"/>
-</p:sld>
-</file>
-
-<file path=ppt/slides/slide20.xml><?xml version="1.0" encoding="utf-8"?>
-<p:sld xmlns:a="http://schemas.openxmlformats.org/drawingml/2006/main" xmlns:r="http://schemas.openxmlformats.org/officeDocument/2006/relationships" xmlns:p="http://schemas.openxmlformats.org/presentationml/2006/main" xmlns:m="http://schemas.openxmlformats.org/officeDocument/2006/math" xmlns:a14="http://schemas.microsoft.com/office/drawing/2010/main" showMasterSp="1" showMasterPhAnim="1">
-  <p:cSld>
-    <p:spTree>
-      <p:nvGrpSpPr>
-        <p:cNvPr id="1" name=""/>
-        <p:cNvGrpSpPr/>
-        <p:nvPr/>
-      </p:nvGrpSpPr>
-      <p:grpSpPr>
-        <a:xfrm>
-          <a:off x="0" y="0"/>
-          <a:ext cx="0" cy="0"/>
-          <a:chOff x="0" y="0"/>
-          <a:chExt cx="0" cy="0"/>
-        </a:xfrm>
-      </p:grpSpPr>
-      <p:sp>
-        <p:nvSpPr>
-          <p:cNvPr id="533" name="SlideTitle1"/>
+          <p:cNvPr id="530" name="SlideTitle1"/>
           <p:cNvSpPr txBox="1"/>
           <p:nvPr>
             <p:ph type="title"/>
@@ -15869,7 +15685,7 @@
       </p:sp>
       <p:grpSp>
         <p:nvGrpSpPr>
-          <p:cNvPr id="536" name="Rectangle1"/>
+          <p:cNvPr id="533" name="Rectangle1"/>
           <p:cNvGrpSpPr/>
           <p:nvPr/>
         </p:nvGrpSpPr>
@@ -15883,7 +15699,7 @@
         </p:grpSpPr>
         <p:sp>
           <p:nvSpPr>
-            <p:cNvPr id="534" name="Rectangle"/>
+            <p:cNvPr id="531" name="Rectangle"/>
             <p:cNvSpPr/>
             <p:nvPr/>
           </p:nvSpPr>
@@ -15939,7 +15755,7 @@
         </p:sp>
         <p:sp>
           <p:nvSpPr>
-            <p:cNvPr id="535" name="Original…"/>
+            <p:cNvPr id="532" name="Original…"/>
             <p:cNvSpPr txBox="1"/>
             <p:nvPr/>
           </p:nvSpPr>
@@ -16025,7 +15841,7 @@
       </p:grpSp>
       <p:grpSp>
         <p:nvGrpSpPr>
-          <p:cNvPr id="539" name="AutoShape1"/>
+          <p:cNvPr id="536" name="AutoShape1"/>
           <p:cNvGrpSpPr/>
           <p:nvPr/>
         </p:nvGrpSpPr>
@@ -16039,7 +15855,7 @@
         </p:grpSpPr>
         <p:sp>
           <p:nvSpPr>
-            <p:cNvPr id="537" name="Rounded Rectangle"/>
+            <p:cNvPr id="534" name="Rounded Rectangle"/>
             <p:cNvSpPr/>
             <p:nvPr/>
           </p:nvSpPr>
@@ -16097,7 +15913,7 @@
         </p:sp>
         <p:sp>
           <p:nvSpPr>
-            <p:cNvPr id="538" name="«C.StateMachine»…"/>
+            <p:cNvPr id="535" name="«C.StateMachine»…"/>
             <p:cNvSpPr txBox="1"/>
             <p:nvPr/>
           </p:nvSpPr>
@@ -16183,7 +15999,7 @@
       </p:grpSp>
       <p:grpSp>
         <p:nvGrpSpPr>
-          <p:cNvPr id="542" name="AutoShape2"/>
+          <p:cNvPr id="539" name="AutoShape2"/>
           <p:cNvGrpSpPr/>
           <p:nvPr/>
         </p:nvGrpSpPr>
@@ -16197,7 +16013,7 @@
         </p:grpSpPr>
         <p:sp>
           <p:nvSpPr>
-            <p:cNvPr id="540" name="Rounded Rectangle"/>
+            <p:cNvPr id="537" name="Rounded Rectangle"/>
             <p:cNvSpPr/>
             <p:nvPr/>
           </p:nvSpPr>
@@ -16255,7 +16071,7 @@
         </p:sp>
         <p:sp>
           <p:nvSpPr>
-            <p:cNvPr id="541" name="«C.State»…"/>
+            <p:cNvPr id="538" name="«C.State»…"/>
             <p:cNvSpPr txBox="1"/>
             <p:nvPr/>
           </p:nvSpPr>
@@ -16341,7 +16157,7 @@
       </p:grpSp>
       <p:sp>
         <p:nvSpPr>
-          <p:cNvPr id="543" name="Connector2"/>
+          <p:cNvPr id="540" name="Connector2"/>
           <p:cNvSpPr/>
           <p:nvPr/>
         </p:nvSpPr>
@@ -16377,7 +16193,7 @@
       </p:sp>
       <p:grpSp>
         <p:nvGrpSpPr>
-          <p:cNvPr id="546" name="AutoShape3"/>
+          <p:cNvPr id="543" name="AutoShape3"/>
           <p:cNvGrpSpPr/>
           <p:nvPr/>
         </p:nvGrpSpPr>
@@ -16391,7 +16207,7 @@
         </p:grpSpPr>
         <p:sp>
           <p:nvSpPr>
-            <p:cNvPr id="544" name="Rounded Rectangle"/>
+            <p:cNvPr id="541" name="Rounded Rectangle"/>
             <p:cNvSpPr/>
             <p:nvPr/>
           </p:nvSpPr>
@@ -16449,7 +16265,7 @@
         </p:sp>
         <p:sp>
           <p:nvSpPr>
-            <p:cNvPr id="545" name="«A.IncomingAnnotation»…"/>
+            <p:cNvPr id="542" name="«A.IncomingAnnotation»…"/>
             <p:cNvSpPr txBox="1"/>
             <p:nvPr/>
           </p:nvSpPr>
@@ -16535,7 +16351,7 @@
       </p:grpSp>
       <p:sp>
         <p:nvSpPr>
-          <p:cNvPr id="547" name="Connector3"/>
+          <p:cNvPr id="544" name="Connector3"/>
           <p:cNvSpPr/>
           <p:nvPr/>
         </p:nvSpPr>
@@ -16571,7 +16387,7 @@
       </p:sp>
       <p:sp>
         <p:nvSpPr>
-          <p:cNvPr id="613" name="Connector4"/>
+          <p:cNvPr id="610" name="Connector4"/>
           <p:cNvSpPr/>
           <p:nvPr/>
         </p:nvSpPr>
@@ -16629,7 +16445,7 @@
       </p:sp>
       <p:sp>
         <p:nvSpPr>
-          <p:cNvPr id="549" name="Textbox1"/>
+          <p:cNvPr id="546" name="Textbox1"/>
           <p:cNvSpPr txBox="1"/>
           <p:nvPr/>
         </p:nvSpPr>
@@ -16665,7 +16481,7 @@
       </p:sp>
       <p:sp>
         <p:nvSpPr>
-          <p:cNvPr id="550" name="Connector5"/>
+          <p:cNvPr id="547" name="Connector5"/>
           <p:cNvSpPr/>
           <p:nvPr/>
         </p:nvSpPr>
@@ -16701,7 +16517,7 @@
       </p:sp>
       <p:grpSp>
         <p:nvGrpSpPr>
-          <p:cNvPr id="553" name="Textbox2"/>
+          <p:cNvPr id="550" name="Textbox2"/>
           <p:cNvGrpSpPr/>
           <p:nvPr/>
         </p:nvGrpSpPr>
@@ -16715,7 +16531,7 @@
         </p:grpSpPr>
         <p:sp>
           <p:nvSpPr>
-            <p:cNvPr id="551" name="Rectangle"/>
+            <p:cNvPr id="548" name="Rectangle"/>
             <p:cNvSpPr/>
             <p:nvPr/>
           </p:nvSpPr>
@@ -16755,7 +16571,7 @@
         </p:sp>
         <p:sp>
           <p:nvSpPr>
-            <p:cNvPr id="552" name="C"/>
+            <p:cNvPr id="549" name="C"/>
             <p:cNvSpPr txBox="1"/>
             <p:nvPr/>
           </p:nvSpPr>
@@ -16804,7 +16620,7 @@
       </p:grpSp>
       <p:grpSp>
         <p:nvGrpSpPr>
-          <p:cNvPr id="556" name="Rectangle2"/>
+          <p:cNvPr id="553" name="Rectangle2"/>
           <p:cNvGrpSpPr/>
           <p:nvPr/>
         </p:nvGrpSpPr>
@@ -16812,6 +16628,140 @@
           <a:xfrm>
             <a:off x="1323974" y="2686050"/>
             <a:ext cx="9543417" cy="1582420"/>
+            <a:chOff x="0" y="0"/>
+            <a:chExt cx="9543415" cy="1582419"/>
+          </a:xfrm>
+        </p:grpSpPr>
+        <p:sp>
+          <p:nvSpPr>
+            <p:cNvPr id="551" name="Rectangle"/>
+            <p:cNvSpPr/>
+            <p:nvPr/>
+          </p:nvSpPr>
+          <p:spPr>
+            <a:xfrm>
+              <a:off x="-1" y="0"/>
+              <a:ext cx="9543417" cy="1582420"/>
+            </a:xfrm>
+            <a:prstGeom prst="rect">
+              <a:avLst/>
+            </a:prstGeom>
+            <a:solidFill>
+              <a:srgbClr val="FFFFFF"/>
+            </a:solidFill>
+            <a:ln w="12700" cap="flat">
+              <a:solidFill>
+                <a:srgbClr val="000000"/>
+              </a:solidFill>
+              <a:prstDash val="solid"/>
+              <a:round/>
+            </a:ln>
+            <a:effectLst/>
+          </p:spPr>
+          <p:txBody>
+            <a:bodyPr wrap="square" lIns="45719" tIns="45719" rIns="45719" bIns="45719" numCol="1" anchor="ctr">
+              <a:noAutofit/>
+            </a:bodyPr>
+            <a:lstStyle/>
+            <a:p>
+              <a:pPr>
+                <a:tabLst>
+                  <a:tab pos="914400" algn="l"/>
+                  <a:tab pos="1828800" algn="l"/>
+                  <a:tab pos="2743200" algn="l"/>
+                  <a:tab pos="3657600" algn="l"/>
+                  <a:tab pos="4572000" algn="l"/>
+                  <a:tab pos="5486400" algn="l"/>
+                  <a:tab pos="6400800" algn="l"/>
+                  <a:tab pos="7315200" algn="l"/>
+                  <a:tab pos="8229600" algn="l"/>
+                  <a:tab pos="9144000" algn="l"/>
+                  <a:tab pos="10058400" algn="l"/>
+                </a:tabLst>
+                <a:defRPr>
+                  <a:latin typeface="Lato Regular"/>
+                  <a:ea typeface="Lato Regular"/>
+                  <a:cs typeface="Lato Regular"/>
+                  <a:sym typeface="Lato Regular"/>
+                </a:defRPr>
+              </a:pPr>
+            </a:p>
+          </p:txBody>
+        </p:sp>
+        <p:sp>
+          <p:nvSpPr>
+            <p:cNvPr id="552" name="Derived model"/>
+            <p:cNvSpPr txBox="1"/>
+            <p:nvPr/>
+          </p:nvSpPr>
+          <p:spPr>
+            <a:xfrm>
+              <a:off x="52069" y="466089"/>
+              <a:ext cx="9439276" cy="650241"/>
+            </a:xfrm>
+            <a:prstGeom prst="rect">
+              <a:avLst/>
+            </a:prstGeom>
+            <a:noFill/>
+            <a:ln w="12700" cap="flat">
+              <a:noFill/>
+              <a:miter lim="400000"/>
+            </a:ln>
+            <a:effectLst/>
+            <a:extLst>
+              <a:ext uri="{C572A759-6A51-4108-AA02-DFA0A04FC94B}">
+                <ma14:wrappingTextBoxFlag xmlns:ma14="http://schemas.microsoft.com/office/mac/drawingml/2011/main" val="1"/>
+              </a:ext>
+            </a:extLst>
+          </p:spPr>
+          <p:txBody>
+            <a:bodyPr wrap="square" lIns="45719" tIns="45719" rIns="45719" bIns="45719" numCol="1" anchor="ctr">
+              <a:spAutoFit/>
+            </a:bodyPr>
+            <a:lstStyle/>
+            <a:p>
+              <a:pPr>
+                <a:tabLst>
+                  <a:tab pos="914400" algn="l"/>
+                  <a:tab pos="1828800" algn="l"/>
+                  <a:tab pos="2743200" algn="l"/>
+                  <a:tab pos="3657600" algn="l"/>
+                  <a:tab pos="4572000" algn="l"/>
+                  <a:tab pos="5486400" algn="l"/>
+                  <a:tab pos="6400800" algn="l"/>
+                  <a:tab pos="7315200" algn="l"/>
+                  <a:tab pos="8229600" algn="l"/>
+                  <a:tab pos="9144000" algn="l"/>
+                  <a:tab pos="10058400" algn="l"/>
+                </a:tabLst>
+                <a:defRPr>
+                  <a:latin typeface="Lato Regular"/>
+                  <a:ea typeface="Lato Regular"/>
+                  <a:cs typeface="Lato Regular"/>
+                  <a:sym typeface="Lato Regular"/>
+                </a:defRPr>
+              </a:pPr>
+              <a:r>
+                <a:t>Derived</a:t>
+              </a:r>
+              <a:br/>
+              <a:r>
+                <a:t>model</a:t>
+              </a:r>
+            </a:p>
+          </p:txBody>
+        </p:sp>
+      </p:grpSp>
+      <p:grpSp>
+        <p:nvGrpSpPr>
+          <p:cNvPr id="556" name="Rectangle3"/>
+          <p:cNvGrpSpPr/>
+          <p:nvPr/>
+        </p:nvGrpSpPr>
+        <p:grpSpPr>
+          <a:xfrm>
+            <a:off x="1323974" y="986789"/>
+            <a:ext cx="9543417" cy="1582421"/>
             <a:chOff x="0" y="0"/>
             <a:chExt cx="9543415" cy="1582419"/>
           </a:xfrm>
@@ -16938,141 +16888,7 @@
       </p:grpSp>
       <p:grpSp>
         <p:nvGrpSpPr>
-          <p:cNvPr id="559" name="Rectangle3"/>
-          <p:cNvGrpSpPr/>
-          <p:nvPr/>
-        </p:nvGrpSpPr>
-        <p:grpSpPr>
-          <a:xfrm>
-            <a:off x="1323974" y="986789"/>
-            <a:ext cx="9543417" cy="1582421"/>
-            <a:chOff x="0" y="0"/>
-            <a:chExt cx="9543415" cy="1582419"/>
-          </a:xfrm>
-        </p:grpSpPr>
-        <p:sp>
-          <p:nvSpPr>
-            <p:cNvPr id="557" name="Rectangle"/>
-            <p:cNvSpPr/>
-            <p:nvPr/>
-          </p:nvSpPr>
-          <p:spPr>
-            <a:xfrm>
-              <a:off x="-1" y="0"/>
-              <a:ext cx="9543417" cy="1582420"/>
-            </a:xfrm>
-            <a:prstGeom prst="rect">
-              <a:avLst/>
-            </a:prstGeom>
-            <a:solidFill>
-              <a:srgbClr val="FFFFFF"/>
-            </a:solidFill>
-            <a:ln w="12700" cap="flat">
-              <a:solidFill>
-                <a:srgbClr val="000000"/>
-              </a:solidFill>
-              <a:prstDash val="solid"/>
-              <a:round/>
-            </a:ln>
-            <a:effectLst/>
-          </p:spPr>
-          <p:txBody>
-            <a:bodyPr wrap="square" lIns="45719" tIns="45719" rIns="45719" bIns="45719" numCol="1" anchor="ctr">
-              <a:noAutofit/>
-            </a:bodyPr>
-            <a:lstStyle/>
-            <a:p>
-              <a:pPr>
-                <a:tabLst>
-                  <a:tab pos="914400" algn="l"/>
-                  <a:tab pos="1828800" algn="l"/>
-                  <a:tab pos="2743200" algn="l"/>
-                  <a:tab pos="3657600" algn="l"/>
-                  <a:tab pos="4572000" algn="l"/>
-                  <a:tab pos="5486400" algn="l"/>
-                  <a:tab pos="6400800" algn="l"/>
-                  <a:tab pos="7315200" algn="l"/>
-                  <a:tab pos="8229600" algn="l"/>
-                  <a:tab pos="9144000" algn="l"/>
-                  <a:tab pos="10058400" algn="l"/>
-                </a:tabLst>
-                <a:defRPr>
-                  <a:latin typeface="Lato Regular"/>
-                  <a:ea typeface="Lato Regular"/>
-                  <a:cs typeface="Lato Regular"/>
-                  <a:sym typeface="Lato Regular"/>
-                </a:defRPr>
-              </a:pPr>
-            </a:p>
-          </p:txBody>
-        </p:sp>
-        <p:sp>
-          <p:nvSpPr>
-            <p:cNvPr id="558" name="Derived model"/>
-            <p:cNvSpPr txBox="1"/>
-            <p:nvPr/>
-          </p:nvSpPr>
-          <p:spPr>
-            <a:xfrm>
-              <a:off x="52069" y="466089"/>
-              <a:ext cx="9439276" cy="650241"/>
-            </a:xfrm>
-            <a:prstGeom prst="rect">
-              <a:avLst/>
-            </a:prstGeom>
-            <a:noFill/>
-            <a:ln w="12700" cap="flat">
-              <a:noFill/>
-              <a:miter lim="400000"/>
-            </a:ln>
-            <a:effectLst/>
-            <a:extLst>
-              <a:ext uri="{C572A759-6A51-4108-AA02-DFA0A04FC94B}">
-                <ma14:wrappingTextBoxFlag xmlns:ma14="http://schemas.microsoft.com/office/mac/drawingml/2011/main" val="1"/>
-              </a:ext>
-            </a:extLst>
-          </p:spPr>
-          <p:txBody>
-            <a:bodyPr wrap="square" lIns="45719" tIns="45719" rIns="45719" bIns="45719" numCol="1" anchor="ctr">
-              <a:spAutoFit/>
-            </a:bodyPr>
-            <a:lstStyle/>
-            <a:p>
-              <a:pPr>
-                <a:tabLst>
-                  <a:tab pos="914400" algn="l"/>
-                  <a:tab pos="1828800" algn="l"/>
-                  <a:tab pos="2743200" algn="l"/>
-                  <a:tab pos="3657600" algn="l"/>
-                  <a:tab pos="4572000" algn="l"/>
-                  <a:tab pos="5486400" algn="l"/>
-                  <a:tab pos="6400800" algn="l"/>
-                  <a:tab pos="7315200" algn="l"/>
-                  <a:tab pos="8229600" algn="l"/>
-                  <a:tab pos="9144000" algn="l"/>
-                  <a:tab pos="10058400" algn="l"/>
-                </a:tabLst>
-                <a:defRPr>
-                  <a:latin typeface="Lato Regular"/>
-                  <a:ea typeface="Lato Regular"/>
-                  <a:cs typeface="Lato Regular"/>
-                  <a:sym typeface="Lato Regular"/>
-                </a:defRPr>
-              </a:pPr>
-              <a:r>
-                <a:t>Derived</a:t>
-              </a:r>
-              <a:br/>
-              <a:r>
-                <a:t>model</a:t>
-              </a:r>
-            </a:p>
-          </p:txBody>
-        </p:sp>
-      </p:grpSp>
-      <p:grpSp>
-        <p:nvGrpSpPr>
-          <p:cNvPr id="562" name="Textbox3"/>
+          <p:cNvPr id="559" name="Textbox3"/>
           <p:cNvGrpSpPr/>
           <p:nvPr/>
         </p:nvGrpSpPr>
@@ -17086,7 +16902,7 @@
         </p:grpSpPr>
         <p:sp>
           <p:nvSpPr>
-            <p:cNvPr id="560" name="Rectangle"/>
+            <p:cNvPr id="557" name="Rectangle"/>
             <p:cNvSpPr/>
             <p:nvPr/>
           </p:nvSpPr>
@@ -17126,7 +16942,7 @@
         </p:sp>
         <p:sp>
           <p:nvSpPr>
-            <p:cNvPr id="561" name="A"/>
+            <p:cNvPr id="558" name="A"/>
             <p:cNvSpPr txBox="1"/>
             <p:nvPr/>
           </p:nvSpPr>
@@ -17175,7 +16991,7 @@
       </p:grpSp>
       <p:sp>
         <p:nvSpPr>
-          <p:cNvPr id="563" name="Textbox4"/>
+          <p:cNvPr id="560" name="Textbox4"/>
           <p:cNvSpPr txBox="1"/>
           <p:nvPr/>
         </p:nvSpPr>
@@ -17223,7 +17039,7 @@
       </p:sp>
       <p:grpSp>
         <p:nvGrpSpPr>
-          <p:cNvPr id="566" name="AutoShape8"/>
+          <p:cNvPr id="563" name="AutoShape8"/>
           <p:cNvGrpSpPr/>
           <p:nvPr/>
         </p:nvGrpSpPr>
@@ -17237,7 +17053,7 @@
         </p:grpSpPr>
         <p:sp>
           <p:nvSpPr>
-            <p:cNvPr id="564" name="Rounded Rectangle"/>
+            <p:cNvPr id="561" name="Rounded Rectangle"/>
             <p:cNvSpPr/>
             <p:nvPr/>
           </p:nvSpPr>
@@ -17295,7 +17111,7 @@
         </p:sp>
         <p:sp>
           <p:nvSpPr>
-            <p:cNvPr id="565" name="«C.Transition»…"/>
+            <p:cNvPr id="562" name="«C.Transition»…"/>
             <p:cNvSpPr txBox="1"/>
             <p:nvPr/>
           </p:nvSpPr>
@@ -17381,7 +17197,7 @@
       </p:grpSp>
       <p:sp>
         <p:nvSpPr>
-          <p:cNvPr id="567" name="Connector7"/>
+          <p:cNvPr id="564" name="Connector7"/>
           <p:cNvSpPr/>
           <p:nvPr/>
         </p:nvSpPr>
@@ -17417,7 +17233,7 @@
       </p:sp>
       <p:grpSp>
         <p:nvGrpSpPr>
-          <p:cNvPr id="570" name="AutoShape4"/>
+          <p:cNvPr id="567" name="AutoShape4"/>
           <p:cNvGrpSpPr/>
           <p:nvPr/>
         </p:nvGrpSpPr>
@@ -17431,7 +17247,7 @@
         </p:grpSpPr>
         <p:sp>
           <p:nvSpPr>
-            <p:cNvPr id="568" name="Rounded Rectangle"/>
+            <p:cNvPr id="565" name="Rounded Rectangle"/>
             <p:cNvSpPr/>
             <p:nvPr/>
           </p:nvSpPr>
@@ -17489,7 +17305,7 @@
         </p:sp>
         <p:sp>
           <p:nvSpPr>
-            <p:cNvPr id="569" name="«C.Transition»…"/>
+            <p:cNvPr id="566" name="«C.Transition»…"/>
             <p:cNvSpPr txBox="1"/>
             <p:nvPr/>
           </p:nvSpPr>
@@ -17575,7 +17391,7 @@
       </p:grpSp>
       <p:sp>
         <p:nvSpPr>
-          <p:cNvPr id="614" name="Connector10"/>
+          <p:cNvPr id="611" name="Connector10"/>
           <p:cNvSpPr/>
           <p:nvPr/>
         </p:nvSpPr>
@@ -17631,7 +17447,7 @@
       </p:sp>
       <p:sp>
         <p:nvSpPr>
-          <p:cNvPr id="572" name="Textbox6"/>
+          <p:cNvPr id="569" name="Textbox6"/>
           <p:cNvSpPr txBox="1"/>
           <p:nvPr/>
         </p:nvSpPr>
@@ -17667,7 +17483,7 @@
       </p:sp>
       <p:grpSp>
         <p:nvGrpSpPr>
-          <p:cNvPr id="575" name="AutoShape5"/>
+          <p:cNvPr id="572" name="AutoShape5"/>
           <p:cNvGrpSpPr/>
           <p:nvPr/>
         </p:nvGrpSpPr>
@@ -17681,7 +17497,7 @@
         </p:grpSpPr>
         <p:sp>
           <p:nvSpPr>
-            <p:cNvPr id="573" name="Rounded Rectangle"/>
+            <p:cNvPr id="570" name="Rounded Rectangle"/>
             <p:cNvSpPr/>
             <p:nvPr/>
           </p:nvSpPr>
@@ -17739,7 +17555,7 @@
         </p:sp>
         <p:sp>
           <p:nvSpPr>
-            <p:cNvPr id="574" name="«A.StateMachine»…"/>
+            <p:cNvPr id="571" name="«A.StateMachine»…"/>
             <p:cNvSpPr txBox="1"/>
             <p:nvPr/>
           </p:nvSpPr>
@@ -17825,7 +17641,7 @@
       </p:grpSp>
       <p:grpSp>
         <p:nvGrpSpPr>
-          <p:cNvPr id="578" name="AutoShape6"/>
+          <p:cNvPr id="575" name="AutoShape6"/>
           <p:cNvGrpSpPr/>
           <p:nvPr/>
         </p:nvGrpSpPr>
@@ -17839,7 +17655,7 @@
         </p:grpSpPr>
         <p:sp>
           <p:nvSpPr>
-            <p:cNvPr id="576" name="Rounded Rectangle"/>
+            <p:cNvPr id="573" name="Rounded Rectangle"/>
             <p:cNvSpPr/>
             <p:nvPr/>
           </p:nvSpPr>
@@ -17897,7 +17713,7 @@
         </p:sp>
         <p:sp>
           <p:nvSpPr>
-            <p:cNvPr id="577" name="«A.State»…"/>
+            <p:cNvPr id="574" name="«A.State»…"/>
             <p:cNvSpPr txBox="1"/>
             <p:nvPr/>
           </p:nvSpPr>
@@ -17983,7 +17799,7 @@
       </p:grpSp>
       <p:sp>
         <p:nvSpPr>
-          <p:cNvPr id="579" name="Connector6"/>
+          <p:cNvPr id="576" name="Connector6"/>
           <p:cNvSpPr/>
           <p:nvPr/>
         </p:nvSpPr>
@@ -18019,7 +17835,7 @@
       </p:sp>
       <p:sp>
         <p:nvSpPr>
-          <p:cNvPr id="615" name="Connector8"/>
+          <p:cNvPr id="612" name="Connector8"/>
           <p:cNvSpPr/>
           <p:nvPr/>
         </p:nvSpPr>
@@ -18077,7 +17893,7 @@
       </p:sp>
       <p:sp>
         <p:nvSpPr>
-          <p:cNvPr id="581" name="Textbox5"/>
+          <p:cNvPr id="578" name="Textbox5"/>
           <p:cNvSpPr txBox="1"/>
           <p:nvPr/>
         </p:nvSpPr>
@@ -18113,13 +17929,171 @@
       </p:sp>
       <p:grpSp>
         <p:nvGrpSpPr>
-          <p:cNvPr id="584" name="AutoShape7"/>
+          <p:cNvPr id="581" name="AutoShape7"/>
           <p:cNvGrpSpPr/>
           <p:nvPr/>
         </p:nvGrpSpPr>
         <p:grpSpPr>
           <a:xfrm>
             <a:off x="7846059" y="3536632"/>
+            <a:ext cx="1628776" cy="631191"/>
+            <a:chOff x="0" y="0"/>
+            <a:chExt cx="1628775" cy="631190"/>
+          </a:xfrm>
+        </p:grpSpPr>
+        <p:sp>
+          <p:nvSpPr>
+            <p:cNvPr id="579" name="Rounded Rectangle"/>
+            <p:cNvSpPr/>
+            <p:nvPr/>
+          </p:nvSpPr>
+          <p:spPr>
+            <a:xfrm>
+              <a:off x="0" y="56832"/>
+              <a:ext cx="1628775" cy="517526"/>
+            </a:xfrm>
+            <a:prstGeom prst="roundRect">
+              <a:avLst>
+                <a:gd name="adj" fmla="val 16662"/>
+              </a:avLst>
+            </a:prstGeom>
+            <a:solidFill>
+              <a:srgbClr val="FFCD1E"/>
+            </a:solidFill>
+            <a:ln w="9525" cap="flat">
+              <a:solidFill>
+                <a:srgbClr val="000000"/>
+              </a:solidFill>
+              <a:prstDash val="solid"/>
+              <a:round/>
+            </a:ln>
+            <a:effectLst/>
+          </p:spPr>
+          <p:txBody>
+            <a:bodyPr wrap="square" lIns="45719" tIns="45719" rIns="45719" bIns="45719" numCol="1" anchor="ctr">
+              <a:noAutofit/>
+            </a:bodyPr>
+            <a:lstStyle/>
+            <a:p>
+              <a:pPr algn="ctr">
+                <a:tabLst>
+                  <a:tab pos="914400" algn="l"/>
+                  <a:tab pos="1828800" algn="l"/>
+                  <a:tab pos="2743200" algn="l"/>
+                  <a:tab pos="3657600" algn="l"/>
+                  <a:tab pos="4572000" algn="l"/>
+                  <a:tab pos="5486400" algn="l"/>
+                  <a:tab pos="6400800" algn="l"/>
+                  <a:tab pos="7315200" algn="l"/>
+                  <a:tab pos="8229600" algn="l"/>
+                  <a:tab pos="9144000" algn="l"/>
+                  <a:tab pos="10058400" algn="l"/>
+                </a:tabLst>
+                <a:defRPr>
+                  <a:latin typeface="Lato Regular"/>
+                  <a:ea typeface="Lato Regular"/>
+                  <a:cs typeface="Lato Regular"/>
+                  <a:sym typeface="Lato Regular"/>
+                </a:defRPr>
+              </a:pPr>
+            </a:p>
+          </p:txBody>
+        </p:sp>
+        <p:sp>
+          <p:nvSpPr>
+            <p:cNvPr id="580" name="«A.Transition»…"/>
+            <p:cNvSpPr txBox="1"/>
+            <p:nvPr/>
+          </p:nvSpPr>
+          <p:spPr>
+            <a:xfrm>
+              <a:off x="30018" y="-1"/>
+              <a:ext cx="1568739" cy="631191"/>
+            </a:xfrm>
+            <a:prstGeom prst="rect">
+              <a:avLst/>
+            </a:prstGeom>
+            <a:noFill/>
+            <a:ln w="12700" cap="flat">
+              <a:noFill/>
+              <a:miter lim="400000"/>
+            </a:ln>
+            <a:effectLst/>
+            <a:extLst>
+              <a:ext uri="{C572A759-6A51-4108-AA02-DFA0A04FC94B}">
+                <ma14:wrappingTextBoxFlag xmlns:ma14="http://schemas.microsoft.com/office/mac/drawingml/2011/main" val="1"/>
+              </a:ext>
+            </a:extLst>
+          </p:spPr>
+          <p:txBody>
+            <a:bodyPr wrap="square" lIns="36194" tIns="36194" rIns="36194" bIns="36194" numCol="1" anchor="ctr">
+              <a:spAutoFit/>
+            </a:bodyPr>
+            <a:lstStyle/>
+            <a:p>
+              <a:pPr algn="ctr">
+                <a:tabLst>
+                  <a:tab pos="914400" algn="l"/>
+                  <a:tab pos="1828800" algn="l"/>
+                  <a:tab pos="2743200" algn="l"/>
+                  <a:tab pos="3657600" algn="l"/>
+                  <a:tab pos="4572000" algn="l"/>
+                  <a:tab pos="5486400" algn="l"/>
+                  <a:tab pos="6400800" algn="l"/>
+                  <a:tab pos="7315200" algn="l"/>
+                  <a:tab pos="8229600" algn="l"/>
+                  <a:tab pos="9144000" algn="l"/>
+                  <a:tab pos="10058400" algn="l"/>
+                </a:tabLst>
+                <a:defRPr>
+                  <a:latin typeface="Lato Regular"/>
+                  <a:ea typeface="Lato Regular"/>
+                  <a:cs typeface="Lato Regular"/>
+                  <a:sym typeface="Lato Regular"/>
+                </a:defRPr>
+              </a:pPr>
+              <a:r>
+                <a:t>«A.Transition»</a:t>
+              </a:r>
+            </a:p>
+            <a:p>
+              <a:pPr algn="ctr">
+                <a:tabLst>
+                  <a:tab pos="914400" algn="l"/>
+                  <a:tab pos="1828800" algn="l"/>
+                  <a:tab pos="2743200" algn="l"/>
+                  <a:tab pos="3657600" algn="l"/>
+                  <a:tab pos="4572000" algn="l"/>
+                  <a:tab pos="5486400" algn="l"/>
+                  <a:tab pos="6400800" algn="l"/>
+                  <a:tab pos="7315200" algn="l"/>
+                  <a:tab pos="8229600" algn="l"/>
+                  <a:tab pos="9144000" algn="l"/>
+                  <a:tab pos="10058400" algn="l"/>
+                </a:tabLst>
+                <a:defRPr>
+                  <a:latin typeface="Lato Regular"/>
+                  <a:ea typeface="Lato Regular"/>
+                  <a:cs typeface="Lato Regular"/>
+                  <a:sym typeface="Lato Regular"/>
+                </a:defRPr>
+              </a:pPr>
+              <a:r>
+                <a:t>begin</a:t>
+              </a:r>
+            </a:p>
+          </p:txBody>
+        </p:sp>
+      </p:grpSp>
+      <p:grpSp>
+        <p:nvGrpSpPr>
+          <p:cNvPr id="584" name="AutoShape9"/>
+          <p:cNvGrpSpPr/>
+          <p:nvPr/>
+        </p:nvGrpSpPr>
+        <p:grpSpPr>
+          <a:xfrm>
+            <a:off x="5977890" y="3536632"/>
             <a:ext cx="1628776" cy="631191"/>
             <a:chOff x="0" y="0"/>
             <a:chExt cx="1628775" cy="631190"/>
@@ -18263,164 +18237,6 @@
                 </a:defRPr>
               </a:pPr>
               <a:r>
-                <a:t>begin</a:t>
-              </a:r>
-            </a:p>
-          </p:txBody>
-        </p:sp>
-      </p:grpSp>
-      <p:grpSp>
-        <p:nvGrpSpPr>
-          <p:cNvPr id="587" name="AutoShape9"/>
-          <p:cNvGrpSpPr/>
-          <p:nvPr/>
-        </p:nvGrpSpPr>
-        <p:grpSpPr>
-          <a:xfrm>
-            <a:off x="5977890" y="3536632"/>
-            <a:ext cx="1628776" cy="631191"/>
-            <a:chOff x="0" y="0"/>
-            <a:chExt cx="1628775" cy="631190"/>
-          </a:xfrm>
-        </p:grpSpPr>
-        <p:sp>
-          <p:nvSpPr>
-            <p:cNvPr id="585" name="Rounded Rectangle"/>
-            <p:cNvSpPr/>
-            <p:nvPr/>
-          </p:nvSpPr>
-          <p:spPr>
-            <a:xfrm>
-              <a:off x="0" y="56832"/>
-              <a:ext cx="1628775" cy="517526"/>
-            </a:xfrm>
-            <a:prstGeom prst="roundRect">
-              <a:avLst>
-                <a:gd name="adj" fmla="val 16662"/>
-              </a:avLst>
-            </a:prstGeom>
-            <a:solidFill>
-              <a:srgbClr val="FFCD1E"/>
-            </a:solidFill>
-            <a:ln w="9525" cap="flat">
-              <a:solidFill>
-                <a:srgbClr val="000000"/>
-              </a:solidFill>
-              <a:prstDash val="solid"/>
-              <a:round/>
-            </a:ln>
-            <a:effectLst/>
-          </p:spPr>
-          <p:txBody>
-            <a:bodyPr wrap="square" lIns="45719" tIns="45719" rIns="45719" bIns="45719" numCol="1" anchor="ctr">
-              <a:noAutofit/>
-            </a:bodyPr>
-            <a:lstStyle/>
-            <a:p>
-              <a:pPr algn="ctr">
-                <a:tabLst>
-                  <a:tab pos="914400" algn="l"/>
-                  <a:tab pos="1828800" algn="l"/>
-                  <a:tab pos="2743200" algn="l"/>
-                  <a:tab pos="3657600" algn="l"/>
-                  <a:tab pos="4572000" algn="l"/>
-                  <a:tab pos="5486400" algn="l"/>
-                  <a:tab pos="6400800" algn="l"/>
-                  <a:tab pos="7315200" algn="l"/>
-                  <a:tab pos="8229600" algn="l"/>
-                  <a:tab pos="9144000" algn="l"/>
-                  <a:tab pos="10058400" algn="l"/>
-                </a:tabLst>
-                <a:defRPr>
-                  <a:latin typeface="Lato Regular"/>
-                  <a:ea typeface="Lato Regular"/>
-                  <a:cs typeface="Lato Regular"/>
-                  <a:sym typeface="Lato Regular"/>
-                </a:defRPr>
-              </a:pPr>
-            </a:p>
-          </p:txBody>
-        </p:sp>
-        <p:sp>
-          <p:nvSpPr>
-            <p:cNvPr id="586" name="«A.Transition»…"/>
-            <p:cNvSpPr txBox="1"/>
-            <p:nvPr/>
-          </p:nvSpPr>
-          <p:spPr>
-            <a:xfrm>
-              <a:off x="30018" y="-1"/>
-              <a:ext cx="1568739" cy="631191"/>
-            </a:xfrm>
-            <a:prstGeom prst="rect">
-              <a:avLst/>
-            </a:prstGeom>
-            <a:noFill/>
-            <a:ln w="12700" cap="flat">
-              <a:noFill/>
-              <a:miter lim="400000"/>
-            </a:ln>
-            <a:effectLst/>
-            <a:extLst>
-              <a:ext uri="{C572A759-6A51-4108-AA02-DFA0A04FC94B}">
-                <ma14:wrappingTextBoxFlag xmlns:ma14="http://schemas.microsoft.com/office/mac/drawingml/2011/main" val="1"/>
-              </a:ext>
-            </a:extLst>
-          </p:spPr>
-          <p:txBody>
-            <a:bodyPr wrap="square" lIns="36194" tIns="36194" rIns="36194" bIns="36194" numCol="1" anchor="ctr">
-              <a:spAutoFit/>
-            </a:bodyPr>
-            <a:lstStyle/>
-            <a:p>
-              <a:pPr algn="ctr">
-                <a:tabLst>
-                  <a:tab pos="914400" algn="l"/>
-                  <a:tab pos="1828800" algn="l"/>
-                  <a:tab pos="2743200" algn="l"/>
-                  <a:tab pos="3657600" algn="l"/>
-                  <a:tab pos="4572000" algn="l"/>
-                  <a:tab pos="5486400" algn="l"/>
-                  <a:tab pos="6400800" algn="l"/>
-                  <a:tab pos="7315200" algn="l"/>
-                  <a:tab pos="8229600" algn="l"/>
-                  <a:tab pos="9144000" algn="l"/>
-                  <a:tab pos="10058400" algn="l"/>
-                </a:tabLst>
-                <a:defRPr>
-                  <a:latin typeface="Lato Regular"/>
-                  <a:ea typeface="Lato Regular"/>
-                  <a:cs typeface="Lato Regular"/>
-                  <a:sym typeface="Lato Regular"/>
-                </a:defRPr>
-              </a:pPr>
-              <a:r>
-                <a:t>«A.Transition»</a:t>
-              </a:r>
-            </a:p>
-            <a:p>
-              <a:pPr algn="ctr">
-                <a:tabLst>
-                  <a:tab pos="914400" algn="l"/>
-                  <a:tab pos="1828800" algn="l"/>
-                  <a:tab pos="2743200" algn="l"/>
-                  <a:tab pos="3657600" algn="l"/>
-                  <a:tab pos="4572000" algn="l"/>
-                  <a:tab pos="5486400" algn="l"/>
-                  <a:tab pos="6400800" algn="l"/>
-                  <a:tab pos="7315200" algn="l"/>
-                  <a:tab pos="8229600" algn="l"/>
-                  <a:tab pos="9144000" algn="l"/>
-                  <a:tab pos="10058400" algn="l"/>
-                </a:tabLst>
-                <a:defRPr>
-                  <a:latin typeface="Lato Regular"/>
-                  <a:ea typeface="Lato Regular"/>
-                  <a:cs typeface="Lato Regular"/>
-                  <a:sym typeface="Lato Regular"/>
-                </a:defRPr>
-              </a:pPr>
-              <a:r>
                 <a:t>deactivate</a:t>
               </a:r>
             </a:p>
@@ -18429,7 +18245,7 @@
       </p:grpSp>
       <p:sp>
         <p:nvSpPr>
-          <p:cNvPr id="588" name="Connector12"/>
+          <p:cNvPr id="585" name="Connector12"/>
           <p:cNvSpPr/>
           <p:nvPr/>
         </p:nvSpPr>
@@ -18465,7 +18281,7 @@
       </p:sp>
       <p:sp>
         <p:nvSpPr>
-          <p:cNvPr id="589" name="Textbox7"/>
+          <p:cNvPr id="586" name="Textbox7"/>
           <p:cNvSpPr txBox="1"/>
           <p:nvPr/>
         </p:nvSpPr>
@@ -18501,7 +18317,7 @@
       </p:sp>
       <p:sp>
         <p:nvSpPr>
-          <p:cNvPr id="616" name="Connector1"/>
+          <p:cNvPr id="613" name="Connector1"/>
           <p:cNvSpPr/>
           <p:nvPr/>
         </p:nvSpPr>
@@ -18558,7 +18374,7 @@
       </p:sp>
       <p:grpSp>
         <p:nvGrpSpPr>
-          <p:cNvPr id="593" name="AutoShape10"/>
+          <p:cNvPr id="590" name="AutoShape10"/>
           <p:cNvGrpSpPr/>
           <p:nvPr/>
         </p:nvGrpSpPr>
@@ -18572,7 +18388,7 @@
         </p:grpSpPr>
         <p:sp>
           <p:nvSpPr>
-            <p:cNvPr id="591" name="Rounded Rectangle"/>
+            <p:cNvPr id="588" name="Rounded Rectangle"/>
             <p:cNvSpPr/>
             <p:nvPr/>
           </p:nvSpPr>
@@ -18630,7 +18446,7 @@
         </p:sp>
         <p:sp>
           <p:nvSpPr>
-            <p:cNvPr id="592" name="«B.StateMachine»…"/>
+            <p:cNvPr id="589" name="«B.StateMachine»…"/>
             <p:cNvSpPr txBox="1"/>
             <p:nvPr/>
           </p:nvSpPr>
@@ -18716,7 +18532,7 @@
       </p:grpSp>
       <p:grpSp>
         <p:nvGrpSpPr>
-          <p:cNvPr id="596" name="AutoShape11"/>
+          <p:cNvPr id="593" name="AutoShape11"/>
           <p:cNvGrpSpPr/>
           <p:nvPr/>
         </p:nvGrpSpPr>
@@ -18730,7 +18546,7 @@
         </p:grpSpPr>
         <p:sp>
           <p:nvSpPr>
-            <p:cNvPr id="594" name="Rounded Rectangle"/>
+            <p:cNvPr id="591" name="Rounded Rectangle"/>
             <p:cNvSpPr/>
             <p:nvPr/>
           </p:nvSpPr>
@@ -18788,7 +18604,7 @@
         </p:sp>
         <p:sp>
           <p:nvSpPr>
-            <p:cNvPr id="595" name="«B.State»…"/>
+            <p:cNvPr id="592" name="«B.State»…"/>
             <p:cNvSpPr txBox="1"/>
             <p:nvPr/>
           </p:nvSpPr>
@@ -18874,7 +18690,7 @@
       </p:grpSp>
       <p:sp>
         <p:nvSpPr>
-          <p:cNvPr id="597" name="Connector9"/>
+          <p:cNvPr id="594" name="Connector9"/>
           <p:cNvSpPr/>
           <p:nvPr/>
         </p:nvSpPr>
@@ -18910,7 +18726,7 @@
       </p:sp>
       <p:sp>
         <p:nvSpPr>
-          <p:cNvPr id="598" name="Connector11"/>
+          <p:cNvPr id="595" name="Connector11"/>
           <p:cNvSpPr/>
           <p:nvPr/>
         </p:nvSpPr>
@@ -18946,7 +18762,7 @@
       </p:sp>
       <p:sp>
         <p:nvSpPr>
-          <p:cNvPr id="599" name="Textbox8"/>
+          <p:cNvPr id="596" name="Textbox8"/>
           <p:cNvSpPr txBox="1"/>
           <p:nvPr/>
         </p:nvSpPr>
@@ -18982,16 +18798,174 @@
       </p:sp>
       <p:grpSp>
         <p:nvGrpSpPr>
-          <p:cNvPr id="602" name="AutoShape12"/>
+          <p:cNvPr id="599" name="AutoShape12"/>
           <p:cNvGrpSpPr/>
           <p:nvPr/>
         </p:nvGrpSpPr>
         <p:grpSpPr>
           <a:xfrm>
             <a:off x="7846059" y="1902460"/>
-            <a:ext cx="1628776" cy="517526"/>
+            <a:ext cx="1740999" cy="553183"/>
             <a:chOff x="0" y="0"/>
-            <a:chExt cx="1628775" cy="517525"/>
+            <a:chExt cx="1740997" cy="553182"/>
+          </a:xfrm>
+        </p:grpSpPr>
+        <p:sp>
+          <p:nvSpPr>
+            <p:cNvPr id="597" name="Rounded Rectangle"/>
+            <p:cNvSpPr/>
+            <p:nvPr/>
+          </p:nvSpPr>
+          <p:spPr>
+            <a:xfrm>
+              <a:off x="0" y="0"/>
+              <a:ext cx="1740998" cy="553183"/>
+            </a:xfrm>
+            <a:prstGeom prst="roundRect">
+              <a:avLst>
+                <a:gd name="adj" fmla="val 16662"/>
+              </a:avLst>
+            </a:prstGeom>
+            <a:solidFill>
+              <a:srgbClr val="C0C0FF"/>
+            </a:solidFill>
+            <a:ln w="9525" cap="flat">
+              <a:solidFill>
+                <a:srgbClr val="000000"/>
+              </a:solidFill>
+              <a:prstDash val="solid"/>
+              <a:round/>
+            </a:ln>
+            <a:effectLst/>
+          </p:spPr>
+          <p:txBody>
+            <a:bodyPr wrap="square" lIns="45719" tIns="45719" rIns="45719" bIns="45719" numCol="1" anchor="ctr">
+              <a:noAutofit/>
+            </a:bodyPr>
+            <a:lstStyle/>
+            <a:p>
+              <a:pPr algn="ctr">
+                <a:tabLst>
+                  <a:tab pos="914400" algn="l"/>
+                  <a:tab pos="1828800" algn="l"/>
+                  <a:tab pos="2743200" algn="l"/>
+                  <a:tab pos="3657600" algn="l"/>
+                  <a:tab pos="4572000" algn="l"/>
+                  <a:tab pos="5486400" algn="l"/>
+                  <a:tab pos="6400800" algn="l"/>
+                  <a:tab pos="7315200" algn="l"/>
+                  <a:tab pos="8229600" algn="l"/>
+                  <a:tab pos="9144000" algn="l"/>
+                  <a:tab pos="10058400" algn="l"/>
+                </a:tabLst>
+                <a:defRPr>
+                  <a:latin typeface="Lato Regular"/>
+                  <a:ea typeface="Lato Regular"/>
+                  <a:cs typeface="Lato Regular"/>
+                  <a:sym typeface="Lato Regular"/>
+                </a:defRPr>
+              </a:pPr>
+            </a:p>
+          </p:txBody>
+        </p:sp>
+        <p:sp>
+          <p:nvSpPr>
+            <p:cNvPr id="598" name="«B.Transition»…"/>
+            <p:cNvSpPr txBox="1"/>
+            <p:nvPr/>
+          </p:nvSpPr>
+          <p:spPr>
+            <a:xfrm>
+              <a:off x="32086" y="32086"/>
+              <a:ext cx="1676826" cy="489010"/>
+            </a:xfrm>
+            <a:prstGeom prst="rect">
+              <a:avLst/>
+            </a:prstGeom>
+            <a:noFill/>
+            <a:ln w="12700" cap="flat">
+              <a:noFill/>
+              <a:miter lim="400000"/>
+            </a:ln>
+            <a:effectLst/>
+            <a:extLst>
+              <a:ext uri="{C572A759-6A51-4108-AA02-DFA0A04FC94B}">
+                <ma14:wrappingTextBoxFlag xmlns:ma14="http://schemas.microsoft.com/office/mac/drawingml/2011/main" val="1"/>
+              </a:ext>
+            </a:extLst>
+          </p:spPr>
+          <p:txBody>
+            <a:bodyPr wrap="square" lIns="36194" tIns="36194" rIns="36194" bIns="36194" numCol="1" anchor="ctr">
+              <a:normAutofit fontScale="100000" lnSpcReduction="0"/>
+            </a:bodyPr>
+            <a:lstStyle/>
+            <a:p>
+              <a:pPr algn="ctr" defTabSz="740663">
+                <a:tabLst>
+                  <a:tab pos="736600" algn="l"/>
+                  <a:tab pos="1473200" algn="l"/>
+                  <a:tab pos="2209800" algn="l"/>
+                  <a:tab pos="2959100" algn="l"/>
+                  <a:tab pos="3695700" algn="l"/>
+                  <a:tab pos="4432300" algn="l"/>
+                  <a:tab pos="5181600" algn="l"/>
+                  <a:tab pos="5918200" algn="l"/>
+                  <a:tab pos="6654800" algn="l"/>
+                  <a:tab pos="7404100" algn="l"/>
+                  <a:tab pos="8140700" algn="l"/>
+                </a:tabLst>
+                <a:defRPr sz="1458">
+                  <a:latin typeface="Lato Regular"/>
+                  <a:ea typeface="Lato Regular"/>
+                  <a:cs typeface="Lato Regular"/>
+                  <a:sym typeface="Lato Regular"/>
+                </a:defRPr>
+              </a:pPr>
+              <a:r>
+                <a:t>«B.Transition»</a:t>
+              </a:r>
+            </a:p>
+            <a:p>
+              <a:pPr algn="ctr" defTabSz="740663">
+                <a:tabLst>
+                  <a:tab pos="736600" algn="l"/>
+                  <a:tab pos="1473200" algn="l"/>
+                  <a:tab pos="2209800" algn="l"/>
+                  <a:tab pos="2959100" algn="l"/>
+                  <a:tab pos="3695700" algn="l"/>
+                  <a:tab pos="4432300" algn="l"/>
+                  <a:tab pos="5181600" algn="l"/>
+                  <a:tab pos="5918200" algn="l"/>
+                  <a:tab pos="6654800" algn="l"/>
+                  <a:tab pos="7404100" algn="l"/>
+                  <a:tab pos="8140700" algn="l"/>
+                </a:tabLst>
+                <a:defRPr sz="1458">
+                  <a:latin typeface="Lato Regular"/>
+                  <a:ea typeface="Lato Regular"/>
+                  <a:cs typeface="Lato Regular"/>
+                  <a:sym typeface="Lato Regular"/>
+                </a:defRPr>
+              </a:pPr>
+              <a:r>
+                <a:t>begin</a:t>
+              </a:r>
+            </a:p>
+          </p:txBody>
+        </p:sp>
+      </p:grpSp>
+      <p:grpSp>
+        <p:nvGrpSpPr>
+          <p:cNvPr id="602" name="AutoShape13"/>
+          <p:cNvGrpSpPr/>
+          <p:nvPr/>
+        </p:nvGrpSpPr>
+        <p:grpSpPr>
+          <a:xfrm>
+            <a:off x="5865667" y="1902460"/>
+            <a:ext cx="1740999" cy="553183"/>
+            <a:chOff x="0" y="0"/>
+            <a:chExt cx="1740997" cy="553182"/>
           </a:xfrm>
         </p:grpSpPr>
         <p:sp>
@@ -19003,7 +18977,7 @@
           <p:spPr>
             <a:xfrm>
               <a:off x="0" y="0"/>
-              <a:ext cx="1628775" cy="517525"/>
+              <a:ext cx="1740998" cy="553183"/>
             </a:xfrm>
             <a:prstGeom prst="roundRect">
               <a:avLst>
@@ -19060,8 +19034,8 @@
           </p:nvSpPr>
           <p:spPr>
             <a:xfrm>
-              <a:off x="30018" y="30018"/>
-              <a:ext cx="1568739" cy="457489"/>
+              <a:off x="32086" y="32086"/>
+              <a:ext cx="1676826" cy="489010"/>
             </a:xfrm>
             <a:prstGeom prst="rect">
               <a:avLst/>
@@ -19084,21 +19058,21 @@
             </a:bodyPr>
             <a:lstStyle/>
             <a:p>
-              <a:pPr algn="ctr" defTabSz="640079">
+              <a:pPr algn="ctr" defTabSz="740663">
                 <a:tabLst>
-                  <a:tab pos="635000" algn="l"/>
-                  <a:tab pos="1270000" algn="l"/>
-                  <a:tab pos="1917700" algn="l"/>
-                  <a:tab pos="2552700" algn="l"/>
-                  <a:tab pos="3187700" algn="l"/>
-                  <a:tab pos="3835400" algn="l"/>
-                  <a:tab pos="4470400" algn="l"/>
-                  <a:tab pos="5118100" algn="l"/>
-                  <a:tab pos="5753100" algn="l"/>
-                  <a:tab pos="6388100" algn="l"/>
-                  <a:tab pos="7035800" algn="l"/>
+                  <a:tab pos="736600" algn="l"/>
+                  <a:tab pos="1473200" algn="l"/>
+                  <a:tab pos="2209800" algn="l"/>
+                  <a:tab pos="2959100" algn="l"/>
+                  <a:tab pos="3695700" algn="l"/>
+                  <a:tab pos="4432300" algn="l"/>
+                  <a:tab pos="5181600" algn="l"/>
+                  <a:tab pos="5918200" algn="l"/>
+                  <a:tab pos="6654800" algn="l"/>
+                  <a:tab pos="7404100" algn="l"/>
+                  <a:tab pos="8140700" algn="l"/>
                 </a:tabLst>
-                <a:defRPr sz="1260">
+                <a:defRPr sz="1458">
                   <a:latin typeface="Lato Regular"/>
                   <a:ea typeface="Lato Regular"/>
                   <a:cs typeface="Lato Regular"/>
@@ -19110,179 +19084,21 @@
               </a:r>
             </a:p>
             <a:p>
-              <a:pPr algn="ctr" defTabSz="640079">
+              <a:pPr algn="ctr" defTabSz="740663">
                 <a:tabLst>
-                  <a:tab pos="635000" algn="l"/>
-                  <a:tab pos="1270000" algn="l"/>
-                  <a:tab pos="1917700" algn="l"/>
-                  <a:tab pos="2552700" algn="l"/>
-                  <a:tab pos="3187700" algn="l"/>
-                  <a:tab pos="3835400" algn="l"/>
-                  <a:tab pos="4470400" algn="l"/>
-                  <a:tab pos="5118100" algn="l"/>
-                  <a:tab pos="5753100" algn="l"/>
-                  <a:tab pos="6388100" algn="l"/>
-                  <a:tab pos="7035800" algn="l"/>
+                  <a:tab pos="736600" algn="l"/>
+                  <a:tab pos="1473200" algn="l"/>
+                  <a:tab pos="2209800" algn="l"/>
+                  <a:tab pos="2959100" algn="l"/>
+                  <a:tab pos="3695700" algn="l"/>
+                  <a:tab pos="4432300" algn="l"/>
+                  <a:tab pos="5181600" algn="l"/>
+                  <a:tab pos="5918200" algn="l"/>
+                  <a:tab pos="6654800" algn="l"/>
+                  <a:tab pos="7404100" algn="l"/>
+                  <a:tab pos="8140700" algn="l"/>
                 </a:tabLst>
-                <a:defRPr sz="1260">
-                  <a:latin typeface="Lato Regular"/>
-                  <a:ea typeface="Lato Regular"/>
-                  <a:cs typeface="Lato Regular"/>
-                  <a:sym typeface="Lato Regular"/>
-                </a:defRPr>
-              </a:pPr>
-              <a:r>
-                <a:t>begin</a:t>
-              </a:r>
-            </a:p>
-          </p:txBody>
-        </p:sp>
-      </p:grpSp>
-      <p:grpSp>
-        <p:nvGrpSpPr>
-          <p:cNvPr id="605" name="AutoShape13"/>
-          <p:cNvGrpSpPr/>
-          <p:nvPr/>
-        </p:nvGrpSpPr>
-        <p:grpSpPr>
-          <a:xfrm>
-            <a:off x="5977890" y="1902460"/>
-            <a:ext cx="1628776" cy="517526"/>
-            <a:chOff x="0" y="0"/>
-            <a:chExt cx="1628775" cy="517525"/>
-          </a:xfrm>
-        </p:grpSpPr>
-        <p:sp>
-          <p:nvSpPr>
-            <p:cNvPr id="603" name="Rounded Rectangle"/>
-            <p:cNvSpPr/>
-            <p:nvPr/>
-          </p:nvSpPr>
-          <p:spPr>
-            <a:xfrm>
-              <a:off x="0" y="0"/>
-              <a:ext cx="1628775" cy="517525"/>
-            </a:xfrm>
-            <a:prstGeom prst="roundRect">
-              <a:avLst>
-                <a:gd name="adj" fmla="val 16662"/>
-              </a:avLst>
-            </a:prstGeom>
-            <a:solidFill>
-              <a:srgbClr val="C0C0FF"/>
-            </a:solidFill>
-            <a:ln w="9525" cap="flat">
-              <a:solidFill>
-                <a:srgbClr val="000000"/>
-              </a:solidFill>
-              <a:prstDash val="solid"/>
-              <a:round/>
-            </a:ln>
-            <a:effectLst/>
-          </p:spPr>
-          <p:txBody>
-            <a:bodyPr wrap="square" lIns="45719" tIns="45719" rIns="45719" bIns="45719" numCol="1" anchor="ctr">
-              <a:noAutofit/>
-            </a:bodyPr>
-            <a:lstStyle/>
-            <a:p>
-              <a:pPr algn="ctr">
-                <a:tabLst>
-                  <a:tab pos="914400" algn="l"/>
-                  <a:tab pos="1828800" algn="l"/>
-                  <a:tab pos="2743200" algn="l"/>
-                  <a:tab pos="3657600" algn="l"/>
-                  <a:tab pos="4572000" algn="l"/>
-                  <a:tab pos="5486400" algn="l"/>
-                  <a:tab pos="6400800" algn="l"/>
-                  <a:tab pos="7315200" algn="l"/>
-                  <a:tab pos="8229600" algn="l"/>
-                  <a:tab pos="9144000" algn="l"/>
-                  <a:tab pos="10058400" algn="l"/>
-                </a:tabLst>
-                <a:defRPr>
-                  <a:latin typeface="Lato Regular"/>
-                  <a:ea typeface="Lato Regular"/>
-                  <a:cs typeface="Lato Regular"/>
-                  <a:sym typeface="Lato Regular"/>
-                </a:defRPr>
-              </a:pPr>
-            </a:p>
-          </p:txBody>
-        </p:sp>
-        <p:sp>
-          <p:nvSpPr>
-            <p:cNvPr id="604" name="«B.Transition»…"/>
-            <p:cNvSpPr txBox="1"/>
-            <p:nvPr/>
-          </p:nvSpPr>
-          <p:spPr>
-            <a:xfrm>
-              <a:off x="30018" y="30018"/>
-              <a:ext cx="1568739" cy="457489"/>
-            </a:xfrm>
-            <a:prstGeom prst="rect">
-              <a:avLst/>
-            </a:prstGeom>
-            <a:noFill/>
-            <a:ln w="12700" cap="flat">
-              <a:noFill/>
-              <a:miter lim="400000"/>
-            </a:ln>
-            <a:effectLst/>
-            <a:extLst>
-              <a:ext uri="{C572A759-6A51-4108-AA02-DFA0A04FC94B}">
-                <ma14:wrappingTextBoxFlag xmlns:ma14="http://schemas.microsoft.com/office/mac/drawingml/2011/main" val="1"/>
-              </a:ext>
-            </a:extLst>
-          </p:spPr>
-          <p:txBody>
-            <a:bodyPr wrap="square" lIns="36194" tIns="36194" rIns="36194" bIns="36194" numCol="1" anchor="ctr">
-              <a:normAutofit fontScale="100000" lnSpcReduction="0"/>
-            </a:bodyPr>
-            <a:lstStyle/>
-            <a:p>
-              <a:pPr algn="ctr" defTabSz="640079">
-                <a:tabLst>
-                  <a:tab pos="635000" algn="l"/>
-                  <a:tab pos="1270000" algn="l"/>
-                  <a:tab pos="1917700" algn="l"/>
-                  <a:tab pos="2552700" algn="l"/>
-                  <a:tab pos="3187700" algn="l"/>
-                  <a:tab pos="3835400" algn="l"/>
-                  <a:tab pos="4470400" algn="l"/>
-                  <a:tab pos="5118100" algn="l"/>
-                  <a:tab pos="5753100" algn="l"/>
-                  <a:tab pos="6388100" algn="l"/>
-                  <a:tab pos="7035800" algn="l"/>
-                </a:tabLst>
-                <a:defRPr sz="1260">
-                  <a:latin typeface="Lato Regular"/>
-                  <a:ea typeface="Lato Regular"/>
-                  <a:cs typeface="Lato Regular"/>
-                  <a:sym typeface="Lato Regular"/>
-                </a:defRPr>
-              </a:pPr>
-              <a:r>
-                <a:t>«B.Transition»</a:t>
-              </a:r>
-            </a:p>
-            <a:p>
-              <a:pPr algn="ctr" defTabSz="640079">
-                <a:tabLst>
-                  <a:tab pos="635000" algn="l"/>
-                  <a:tab pos="1270000" algn="l"/>
-                  <a:tab pos="1917700" algn="l"/>
-                  <a:tab pos="2552700" algn="l"/>
-                  <a:tab pos="3187700" algn="l"/>
-                  <a:tab pos="3835400" algn="l"/>
-                  <a:tab pos="4470400" algn="l"/>
-                  <a:tab pos="5118100" algn="l"/>
-                  <a:tab pos="5753100" algn="l"/>
-                  <a:tab pos="6388100" algn="l"/>
-                  <a:tab pos="7035800" algn="l"/>
-                </a:tabLst>
-                <a:defRPr sz="1260">
+                <a:defRPr sz="1458">
                   <a:latin typeface="Lato Regular"/>
                   <a:ea typeface="Lato Regular"/>
                   <a:cs typeface="Lato Regular"/>
@@ -19298,14 +19114,14 @@
       </p:grpSp>
       <p:sp>
         <p:nvSpPr>
-          <p:cNvPr id="617" name="Connector13"/>
+          <p:cNvPr id="614" name="Connector13"/>
           <p:cNvSpPr/>
           <p:nvPr/>
         </p:nvSpPr>
         <p:spPr>
           <a:xfrm>
-            <a:off x="7561523" y="1710372"/>
-            <a:ext cx="456596" cy="187326"/>
+            <a:off x="7566616" y="1710372"/>
+            <a:ext cx="459618" cy="187326"/>
           </a:xfrm>
           <a:custGeom>
             <a:avLst/>
@@ -19354,7 +19170,7 @@
       </p:sp>
       <p:sp>
         <p:nvSpPr>
-          <p:cNvPr id="607" name="Textbox9"/>
+          <p:cNvPr id="604" name="Textbox9"/>
           <p:cNvSpPr txBox="1"/>
           <p:nvPr/>
         </p:nvSpPr>
@@ -19390,7 +19206,7 @@
       </p:sp>
       <p:grpSp>
         <p:nvGrpSpPr>
-          <p:cNvPr id="610" name="AutoShape14"/>
+          <p:cNvPr id="607" name="AutoShape14"/>
           <p:cNvGrpSpPr/>
           <p:nvPr/>
         </p:nvGrpSpPr>
@@ -19404,7 +19220,7 @@
         </p:grpSpPr>
         <p:sp>
           <p:nvSpPr>
-            <p:cNvPr id="608" name="Rounded Rectangle"/>
+            <p:cNvPr id="605" name="Rounded Rectangle"/>
             <p:cNvSpPr/>
             <p:nvPr/>
           </p:nvSpPr>
@@ -19462,7 +19278,7 @@
         </p:sp>
         <p:sp>
           <p:nvSpPr>
-            <p:cNvPr id="609" name="«B.DiagramAnnotation»…"/>
+            <p:cNvPr id="606" name="«B.DiagramAnnotation»…"/>
             <p:cNvSpPr txBox="1"/>
             <p:nvPr/>
           </p:nvSpPr>
@@ -19548,7 +19364,7 @@
       </p:grpSp>
       <p:sp>
         <p:nvSpPr>
-          <p:cNvPr id="611" name="Connector14"/>
+          <p:cNvPr id="608" name="Connector14"/>
           <p:cNvSpPr/>
           <p:nvPr/>
         </p:nvSpPr>
@@ -19584,7 +19400,7 @@
       </p:sp>
       <p:sp>
         <p:nvSpPr>
-          <p:cNvPr id="618" name="Connector15"/>
+          <p:cNvPr id="615" name="Connector15"/>
           <p:cNvSpPr/>
           <p:nvPr/>
         </p:nvSpPr>
@@ -19678,7 +19494,7 @@
                                       <p:cBhvr>
                                         <p:cTn id="6" fill="hold"/>
                                         <p:tgtEl>
-                                          <p:spTgt spid="616"/>
+                                          <p:spTgt spid="613"/>
                                         </p:tgtEl>
                                         <p:attrNameLst>
                                           <p:attrName>style.visibility</p:attrName>
@@ -19713,7 +19529,7 @@
                                       <p:cBhvr>
                                         <p:cTn id="9" fill="hold"/>
                                         <p:tgtEl>
-                                          <p:spTgt spid="556"/>
+                                          <p:spTgt spid="553"/>
                                         </p:tgtEl>
                                         <p:attrNameLst>
                                           <p:attrName>style.visibility</p:attrName>
@@ -19748,7 +19564,7 @@
                                       <p:cBhvr>
                                         <p:cTn id="12" fill="hold"/>
                                         <p:tgtEl>
-                                          <p:spTgt spid="562"/>
+                                          <p:spTgt spid="559"/>
                                         </p:tgtEl>
                                         <p:attrNameLst>
                                           <p:attrName>style.visibility</p:attrName>
@@ -19783,7 +19599,7 @@
                                       <p:cBhvr>
                                         <p:cTn id="15" fill="hold"/>
                                         <p:tgtEl>
-                                          <p:spTgt spid="575"/>
+                                          <p:spTgt spid="572"/>
                                         </p:tgtEl>
                                         <p:attrNameLst>
                                           <p:attrName>style.visibility</p:attrName>
@@ -19818,7 +19634,7 @@
                                       <p:cBhvr>
                                         <p:cTn id="18" fill="hold"/>
                                         <p:tgtEl>
-                                          <p:spTgt spid="578"/>
+                                          <p:spTgt spid="575"/>
                                         </p:tgtEl>
                                         <p:attrNameLst>
                                           <p:attrName>style.visibility</p:attrName>
@@ -19853,7 +19669,7 @@
                                       <p:cBhvr>
                                         <p:cTn id="21" fill="hold"/>
                                         <p:tgtEl>
-                                          <p:spTgt spid="579"/>
+                                          <p:spTgt spid="576"/>
                                         </p:tgtEl>
                                         <p:attrNameLst>
                                           <p:attrName>style.visibility</p:attrName>
@@ -19888,7 +19704,7 @@
                                       <p:cBhvr>
                                         <p:cTn id="24" fill="hold"/>
                                         <p:tgtEl>
-                                          <p:spTgt spid="615"/>
+                                          <p:spTgt spid="612"/>
                                         </p:tgtEl>
                                         <p:attrNameLst>
                                           <p:attrName>style.visibility</p:attrName>
@@ -19923,7 +19739,7 @@
                                       <p:cBhvr>
                                         <p:cTn id="27" fill="hold"/>
                                         <p:tgtEl>
-                                          <p:spTgt spid="581"/>
+                                          <p:spTgt spid="578"/>
                                         </p:tgtEl>
                                         <p:attrNameLst>
                                           <p:attrName>style.visibility</p:attrName>
@@ -19958,7 +19774,7 @@
                                       <p:cBhvr>
                                         <p:cTn id="30" fill="hold"/>
                                         <p:tgtEl>
-                                          <p:spTgt spid="584"/>
+                                          <p:spTgt spid="581"/>
                                         </p:tgtEl>
                                         <p:attrNameLst>
                                           <p:attrName>style.visibility</p:attrName>
@@ -19993,7 +19809,7 @@
                                       <p:cBhvr>
                                         <p:cTn id="33" fill="hold"/>
                                         <p:tgtEl>
-                                          <p:spTgt spid="587"/>
+                                          <p:spTgt spid="584"/>
                                         </p:tgtEl>
                                         <p:attrNameLst>
                                           <p:attrName>style.visibility</p:attrName>
@@ -20028,7 +19844,7 @@
                                       <p:cBhvr>
                                         <p:cTn id="36" fill="hold"/>
                                         <p:tgtEl>
-                                          <p:spTgt spid="588"/>
+                                          <p:spTgt spid="585"/>
                                         </p:tgtEl>
                                         <p:attrNameLst>
                                           <p:attrName>style.visibility</p:attrName>
@@ -20063,7 +19879,7 @@
                                       <p:cBhvr>
                                         <p:cTn id="39" fill="hold"/>
                                         <p:tgtEl>
-                                          <p:spTgt spid="589"/>
+                                          <p:spTgt spid="586"/>
                                         </p:tgtEl>
                                         <p:attrNameLst>
                                           <p:attrName>style.visibility</p:attrName>
@@ -20107,7 +19923,7 @@
                                       <p:cBhvr>
                                         <p:cTn id="43" fill="hold"/>
                                         <p:tgtEl>
-                                          <p:spTgt spid="546"/>
+                                          <p:spTgt spid="543"/>
                                         </p:tgtEl>
                                         <p:attrNameLst>
                                           <p:attrName>style.visibility</p:attrName>
@@ -20142,7 +19958,7 @@
                                       <p:cBhvr>
                                         <p:cTn id="46" fill="hold"/>
                                         <p:tgtEl>
-                                          <p:spTgt spid="547"/>
+                                          <p:spTgt spid="544"/>
                                         </p:tgtEl>
                                         <p:attrNameLst>
                                           <p:attrName>style.visibility</p:attrName>
@@ -20190,7 +20006,7 @@
                                           </p:stCondLst>
                                         </p:cTn>
                                         <p:tgtEl>
-                                          <p:spTgt spid="616"/>
+                                          <p:spTgt spid="613"/>
                                         </p:tgtEl>
                                         <p:attrNameLst>
                                           <p:attrName>style.visibility</p:attrName>
@@ -20234,7 +20050,7 @@
                                       <p:cBhvr>
                                         <p:cTn id="54" fill="hold"/>
                                         <p:tgtEl>
-                                          <p:spTgt spid="610"/>
+                                          <p:spTgt spid="607"/>
                                         </p:tgtEl>
                                         <p:attrNameLst>
                                           <p:attrName>style.visibility</p:attrName>
@@ -20269,7 +20085,7 @@
                                       <p:cBhvr>
                                         <p:cTn id="57" fill="hold"/>
                                         <p:tgtEl>
-                                          <p:spTgt spid="611"/>
+                                          <p:spTgt spid="608"/>
                                         </p:tgtEl>
                                         <p:attrNameLst>
                                           <p:attrName>style.visibility</p:attrName>
@@ -20304,7 +20120,7 @@
                                       <p:cBhvr>
                                         <p:cTn id="60" fill="hold"/>
                                         <p:tgtEl>
-                                          <p:spTgt spid="618"/>
+                                          <p:spTgt spid="615"/>
                                         </p:tgtEl>
                                         <p:attrNameLst>
                                           <p:attrName>style.visibility</p:attrName>
@@ -20339,7 +20155,7 @@
                                       <p:cBhvr>
                                         <p:cTn id="63" fill="hold"/>
                                         <p:tgtEl>
-                                          <p:spTgt spid="559"/>
+                                          <p:spTgt spid="556"/>
                                         </p:tgtEl>
                                         <p:attrNameLst>
                                           <p:attrName>style.visibility</p:attrName>
@@ -20374,7 +20190,7 @@
                                       <p:cBhvr>
                                         <p:cTn id="66" fill="hold"/>
                                         <p:tgtEl>
-                                          <p:spTgt spid="563"/>
+                                          <p:spTgt spid="560"/>
                                         </p:tgtEl>
                                         <p:attrNameLst>
                                           <p:attrName>style.visibility</p:attrName>
@@ -20409,7 +20225,7 @@
                                       <p:cBhvr>
                                         <p:cTn id="69" fill="hold"/>
                                         <p:tgtEl>
-                                          <p:spTgt spid="593"/>
+                                          <p:spTgt spid="590"/>
                                         </p:tgtEl>
                                         <p:attrNameLst>
                                           <p:attrName>style.visibility</p:attrName>
@@ -20444,7 +20260,7 @@
                                       <p:cBhvr>
                                         <p:cTn id="72" fill="hold"/>
                                         <p:tgtEl>
-                                          <p:spTgt spid="596"/>
+                                          <p:spTgt spid="593"/>
                                         </p:tgtEl>
                                         <p:attrNameLst>
                                           <p:attrName>style.visibility</p:attrName>
@@ -20479,7 +20295,7 @@
                                       <p:cBhvr>
                                         <p:cTn id="75" fill="hold"/>
                                         <p:tgtEl>
-                                          <p:spTgt spid="597"/>
+                                          <p:spTgt spid="594"/>
                                         </p:tgtEl>
                                         <p:attrNameLst>
                                           <p:attrName>style.visibility</p:attrName>
@@ -20514,7 +20330,7 @@
                                       <p:cBhvr>
                                         <p:cTn id="78" fill="hold"/>
                                         <p:tgtEl>
-                                          <p:spTgt spid="598"/>
+                                          <p:spTgt spid="595"/>
                                         </p:tgtEl>
                                         <p:attrNameLst>
                                           <p:attrName>style.visibility</p:attrName>
@@ -20549,7 +20365,7 @@
                                       <p:cBhvr>
                                         <p:cTn id="81" fill="hold"/>
                                         <p:tgtEl>
-                                          <p:spTgt spid="599"/>
+                                          <p:spTgt spid="596"/>
                                         </p:tgtEl>
                                         <p:attrNameLst>
                                           <p:attrName>style.visibility</p:attrName>
@@ -20584,7 +20400,7 @@
                                       <p:cBhvr>
                                         <p:cTn id="84" fill="hold"/>
                                         <p:tgtEl>
-                                          <p:spTgt spid="602"/>
+                                          <p:spTgt spid="599"/>
                                         </p:tgtEl>
                                         <p:attrNameLst>
                                           <p:attrName>style.visibility</p:attrName>
@@ -20619,7 +20435,7 @@
                                       <p:cBhvr>
                                         <p:cTn id="87" fill="hold"/>
                                         <p:tgtEl>
-                                          <p:spTgt spid="605"/>
+                                          <p:spTgt spid="602"/>
                                         </p:tgtEl>
                                         <p:attrNameLst>
                                           <p:attrName>style.visibility</p:attrName>
@@ -20654,7 +20470,7 @@
                                       <p:cBhvr>
                                         <p:cTn id="90" fill="hold"/>
                                         <p:tgtEl>
-                                          <p:spTgt spid="617"/>
+                                          <p:spTgt spid="614"/>
                                         </p:tgtEl>
                                         <p:attrNameLst>
                                           <p:attrName>style.visibility</p:attrName>
@@ -20689,7 +20505,7 @@
                                       <p:cBhvr>
                                         <p:cTn id="93" fill="hold"/>
                                         <p:tgtEl>
-                                          <p:spTgt spid="607"/>
+                                          <p:spTgt spid="604"/>
                                         </p:tgtEl>
                                         <p:attrNameLst>
                                           <p:attrName>style.visibility</p:attrName>
@@ -20730,41 +20546,141 @@
       </p:par>
     </p:tnLst>
     <p:bldLst>
-      <p:bldP build="whole" bldLvl="1" animBg="1" rev="0" advAuto="0" spid="563" grpId="20"/>
-      <p:bldP build="whole" bldLvl="1" animBg="1" rev="0" advAuto="0" spid="598" grpId="24"/>
-      <p:bldP build="whole" bldLvl="1" animBg="1" rev="0" advAuto="0" spid="599" grpId="25"/>
-      <p:bldP build="whole" bldLvl="1" animBg="1" rev="0" advAuto="0" spid="602" grpId="26"/>
-      <p:bldP build="whole" bldLvl="1" animBg="1" rev="0" advAuto="0" spid="559" grpId="19"/>
-      <p:bldP build="whole" bldLvl="1" animBg="1" rev="0" advAuto="0" spid="607" grpId="29"/>
-      <p:bldP build="whole" bldLvl="1" animBg="1" rev="0" advAuto="0" spid="616" grpId="1"/>
-      <p:bldP build="whole" bldLvl="1" animBg="1" rev="0" advAuto="0" spid="579" grpId="6"/>
-      <p:bldP build="whole" bldLvl="1" animBg="1" rev="0" advAuto="0" spid="605" grpId="27"/>
-      <p:bldP build="whole" bldLvl="1" animBg="1" rev="0" advAuto="0" spid="556" grpId="2"/>
-      <p:bldP build="whole" bldLvl="1" animBg="1" rev="0" advAuto="0" spid="593" grpId="21"/>
-      <p:bldP build="whole" bldLvl="1" animBg="1" rev="0" advAuto="0" spid="584" grpId="9"/>
-      <p:bldP build="whole" bldLvl="1" animBg="1" rev="0" advAuto="0" spid="615" grpId="7"/>
-      <p:bldP build="whole" bldLvl="1" animBg="1" rev="0" advAuto="0" spid="610" grpId="16"/>
-      <p:bldP build="whole" bldLvl="1" animBg="1" rev="0" advAuto="0" spid="596" grpId="22"/>
-      <p:bldP build="whole" bldLvl="1" animBg="1" rev="0" advAuto="0" spid="597" grpId="23"/>
-      <p:bldP build="whole" bldLvl="1" animBg="1" rev="0" advAuto="0" spid="589" grpId="12"/>
-      <p:bldP build="whole" bldLvl="1" animBg="1" rev="0" advAuto="0" spid="587" grpId="10"/>
-      <p:bldP build="whole" bldLvl="1" animBg="1" rev="0" advAuto="0" spid="547" grpId="14"/>
-      <p:bldP build="whole" bldLvl="1" animBg="1" rev="0" advAuto="0" spid="616" grpId="15"/>
-      <p:bldP build="whole" bldLvl="1" animBg="1" rev="0" advAuto="0" spid="575" grpId="4"/>
-      <p:bldP build="whole" bldLvl="1" animBg="1" rev="0" advAuto="0" spid="546" grpId="13"/>
-      <p:bldP build="whole" bldLvl="1" animBg="1" rev="0" advAuto="0" spid="588" grpId="11"/>
-      <p:bldP build="whole" bldLvl="1" animBg="1" rev="0" advAuto="0" spid="578" grpId="5"/>
-      <p:bldP build="whole" bldLvl="1" animBg="1" rev="0" advAuto="0" spid="581" grpId="8"/>
-      <p:bldP build="whole" bldLvl="1" animBg="1" rev="0" advAuto="0" spid="618" grpId="18"/>
-      <p:bldP build="whole" bldLvl="1" animBg="1" rev="0" advAuto="0" spid="562" grpId="3"/>
-      <p:bldP build="whole" bldLvl="1" animBg="1" rev="0" advAuto="0" spid="617" grpId="28"/>
-      <p:bldP build="whole" bldLvl="1" animBg="1" rev="0" advAuto="0" spid="611" grpId="17"/>
+      <p:bldP build="whole" bldLvl="1" animBg="1" rev="0" advAuto="0" spid="581" grpId="9"/>
+      <p:bldP build="whole" bldLvl="1" animBg="1" rev="0" advAuto="0" spid="559" grpId="3"/>
+      <p:bldP build="whole" bldLvl="1" animBg="1" rev="0" advAuto="0" spid="544" grpId="14"/>
+      <p:bldP build="whole" bldLvl="1" animBg="1" rev="0" advAuto="0" spid="578" grpId="8"/>
+      <p:bldP build="whole" bldLvl="1" animBg="1" rev="0" advAuto="0" spid="586" grpId="12"/>
+      <p:bldP build="whole" bldLvl="1" animBg="1" rev="0" advAuto="0" spid="553" grpId="2"/>
+      <p:bldP build="whole" bldLvl="1" animBg="1" rev="0" advAuto="0" spid="615" grpId="18"/>
+      <p:bldP build="whole" bldLvl="1" animBg="1" rev="0" advAuto="0" spid="595" grpId="24"/>
+      <p:bldP build="whole" bldLvl="1" animBg="1" rev="0" advAuto="0" spid="590" grpId="21"/>
+      <p:bldP build="whole" bldLvl="1" animBg="1" rev="0" advAuto="0" spid="599" grpId="26"/>
+      <p:bldP build="whole" bldLvl="1" animBg="1" rev="0" advAuto="0" spid="594" grpId="23"/>
+      <p:bldP build="whole" bldLvl="1" animBg="1" rev="0" advAuto="0" spid="602" grpId="27"/>
+      <p:bldP build="whole" bldLvl="1" animBg="1" rev="0" advAuto="0" spid="614" grpId="28"/>
+      <p:bldP build="whole" bldLvl="1" animBg="1" rev="0" advAuto="0" spid="596" grpId="25"/>
+      <p:bldP build="whole" bldLvl="1" animBg="1" rev="0" advAuto="0" spid="556" grpId="19"/>
+      <p:bldP build="whole" bldLvl="1" animBg="1" rev="0" advAuto="0" spid="612" grpId="7"/>
+      <p:bldP build="whole" bldLvl="1" animBg="1" rev="0" advAuto="0" spid="604" grpId="29"/>
+      <p:bldP build="whole" bldLvl="1" animBg="1" rev="0" advAuto="0" spid="584" grpId="10"/>
+      <p:bldP build="whole" bldLvl="1" animBg="1" rev="0" advAuto="0" spid="613" grpId="1"/>
+      <p:bldP build="whole" bldLvl="1" animBg="1" rev="0" advAuto="0" spid="543" grpId="13"/>
+      <p:bldP build="whole" bldLvl="1" animBg="1" rev="0" advAuto="0" spid="607" grpId="16"/>
+      <p:bldP build="whole" bldLvl="1" animBg="1" rev="0" advAuto="0" spid="572" grpId="4"/>
+      <p:bldP build="whole" bldLvl="1" animBg="1" rev="0" advAuto="0" spid="593" grpId="22"/>
+      <p:bldP build="whole" bldLvl="1" animBg="1" rev="0" advAuto="0" spid="560" grpId="20"/>
+      <p:bldP build="whole" bldLvl="1" animBg="1" rev="0" advAuto="0" spid="585" grpId="11"/>
+      <p:bldP build="whole" bldLvl="1" animBg="1" rev="0" advAuto="0" spid="575" grpId="5"/>
+      <p:bldP build="whole" bldLvl="1" animBg="1" rev="0" advAuto="0" spid="608" grpId="17"/>
+      <p:bldP build="whole" bldLvl="1" animBg="1" rev="0" advAuto="0" spid="576" grpId="6"/>
+      <p:bldP build="whole" bldLvl="1" animBg="1" rev="0" advAuto="0" spid="613" grpId="15"/>
     </p:bldLst>
   </p:timing>
 </p:sld>
 </file>
 
-<file path=ppt/slides/slide21.xml><?xml version="1.0" encoding="utf-8"?>
+<file path=ppt/slides/slide2.xml><?xml version="1.0" encoding="utf-8"?>
+<p:sld xmlns:a="http://schemas.openxmlformats.org/drawingml/2006/main" xmlns:r="http://schemas.openxmlformats.org/officeDocument/2006/relationships" xmlns:p="http://schemas.openxmlformats.org/presentationml/2006/main" xmlns:m="http://schemas.openxmlformats.org/officeDocument/2006/math" xmlns:a14="http://schemas.microsoft.com/office/drawing/2010/main" showMasterSp="1" showMasterPhAnim="1">
+  <p:cSld>
+    <p:spTree>
+      <p:nvGrpSpPr>
+        <p:cNvPr id="1" name=""/>
+        <p:cNvGrpSpPr/>
+        <p:nvPr/>
+      </p:nvGrpSpPr>
+      <p:grpSpPr>
+        <a:xfrm>
+          <a:off x="0" y="0"/>
+          <a:ext cx="0" cy="0"/>
+          <a:chOff x="0" y="0"/>
+          <a:chExt cx="0" cy="0"/>
+        </a:xfrm>
+      </p:grpSpPr>
+      <p:sp>
+        <p:nvSpPr>
+          <p:cNvPr id="177" name="Title 2"/>
+          <p:cNvSpPr txBox="1"/>
+          <p:nvPr>
+            <p:ph type="title"/>
+          </p:nvPr>
+        </p:nvSpPr>
+        <p:spPr>
+          <a:prstGeom prst="rect">
+            <a:avLst/>
+          </a:prstGeom>
+        </p:spPr>
+        <p:txBody>
+          <a:bodyPr/>
+          <a:lstStyle/>
+          <a:p>
+            <a:pPr/>
+            <a:r>
+              <a:t>Short introduction</a:t>
+            </a:r>
+          </a:p>
+        </p:txBody>
+      </p:sp>
+      <p:sp>
+        <p:nvSpPr>
+          <p:cNvPr id="178" name="Text Placeholder 4"/>
+          <p:cNvSpPr txBox="1"/>
+          <p:nvPr>
+            <p:ph type="body" sz="quarter" idx="1"/>
+          </p:nvPr>
+        </p:nvSpPr>
+        <p:spPr>
+          <a:prstGeom prst="rect">
+            <a:avLst/>
+          </a:prstGeom>
+        </p:spPr>
+        <p:txBody>
+          <a:bodyPr/>
+          <a:lstStyle/>
+          <a:p>
+            <a:pPr/>
+          </a:p>
+        </p:txBody>
+      </p:sp>
+      <p:pic>
+        <p:nvPicPr>
+          <p:cNvPr id="179" name="Graphic 5" descr="Graphic 5"/>
+          <p:cNvPicPr>
+            <a:picLocks noChangeAspect="1"/>
+          </p:cNvPicPr>
+          <p:nvPr/>
+        </p:nvPicPr>
+        <p:blipFill>
+          <a:blip r:embed="rId2">
+            <a:extLst/>
+          </a:blip>
+          <a:stretch>
+            <a:fillRect/>
+          </a:stretch>
+        </p:blipFill>
+        <p:spPr>
+          <a:xfrm>
+            <a:off x="5535121" y="3394947"/>
+            <a:ext cx="1121758" cy="1127725"/>
+          </a:xfrm>
+          <a:prstGeom prst="rect">
+            <a:avLst/>
+          </a:prstGeom>
+          <a:ln w="12700">
+            <a:miter lim="400000"/>
+          </a:ln>
+        </p:spPr>
+      </p:pic>
+    </p:spTree>
+  </p:cSld>
+  <p:clrMapOvr>
+    <a:masterClrMapping/>
+  </p:clrMapOvr>
+  <p:transition xmlns:p14="http://schemas.microsoft.com/office/powerpoint/2010/main" spd="med" advClick="1"/>
+</p:sld>
+</file>
+
+<file path=ppt/slides/slide20.xml><?xml version="1.0" encoding="utf-8"?>
 <p:sld xmlns:a="http://schemas.openxmlformats.org/drawingml/2006/main" xmlns:r="http://schemas.openxmlformats.org/officeDocument/2006/relationships" xmlns:p="http://schemas.openxmlformats.org/presentationml/2006/main" xmlns:m="http://schemas.openxmlformats.org/officeDocument/2006/math" xmlns:a14="http://schemas.microsoft.com/office/drawing/2010/main" showMasterSp="1" showMasterPhAnim="1">
   <p:cSld>
     <p:spTree>
@@ -20783,7 +20699,7 @@
       </p:grpSpPr>
       <p:grpSp>
         <p:nvGrpSpPr>
-          <p:cNvPr id="622" name="TextBox 7"/>
+          <p:cNvPr id="619" name="TextBox 7"/>
           <p:cNvGrpSpPr/>
           <p:nvPr/>
         </p:nvGrpSpPr>
@@ -20797,7 +20713,7 @@
         </p:grpSpPr>
         <p:sp>
           <p:nvSpPr>
-            <p:cNvPr id="620" name="Rectangle"/>
+            <p:cNvPr id="617" name="Rectangle"/>
             <p:cNvSpPr/>
             <p:nvPr/>
           </p:nvSpPr>
@@ -20841,7 +20757,7 @@
         </p:sp>
         <p:sp>
           <p:nvSpPr>
-            <p:cNvPr id="621" name="Meinte Boersma DSL Consultancy…"/>
+            <p:cNvPr id="618" name="Meinte Boersma DSL Consultancy…"/>
             <p:cNvSpPr txBox="1"/>
             <p:nvPr/>
           </p:nvSpPr>
@@ -21093,7 +21009,7 @@
       </p:grpSp>
       <p:sp>
         <p:nvSpPr>
-          <p:cNvPr id="623" name="PlaceHolder 1"/>
+          <p:cNvPr id="620" name="PlaceHolder 1"/>
           <p:cNvSpPr txBox="1"/>
           <p:nvPr>
             <p:ph type="title"/>
@@ -21121,7 +21037,7 @@
       </p:sp>
       <p:grpSp>
         <p:nvGrpSpPr>
-          <p:cNvPr id="626" name="Title 1"/>
+          <p:cNvPr id="623" name="Title 1"/>
           <p:cNvGrpSpPr/>
           <p:nvPr/>
         </p:nvGrpSpPr>
@@ -21135,7 +21051,7 @@
         </p:grpSpPr>
         <p:sp>
           <p:nvSpPr>
-            <p:cNvPr id="624" name="Rectangle"/>
+            <p:cNvPr id="621" name="Rectangle"/>
             <p:cNvSpPr/>
             <p:nvPr/>
           </p:nvSpPr>
@@ -21177,7 +21093,7 @@
         </p:sp>
         <p:sp>
           <p:nvSpPr>
-            <p:cNvPr id="625" name="Team"/>
+            <p:cNvPr id="622" name="Team"/>
             <p:cNvSpPr txBox="1"/>
             <p:nvPr/>
           </p:nvSpPr>
@@ -21239,7 +21155,7 @@
       </p:grpSp>
       <p:grpSp>
         <p:nvGrpSpPr>
-          <p:cNvPr id="629" name="TextBox 14"/>
+          <p:cNvPr id="626" name="TextBox 14"/>
           <p:cNvGrpSpPr/>
           <p:nvPr/>
         </p:nvGrpSpPr>
@@ -21253,7 +21169,7 @@
         </p:grpSpPr>
         <p:sp>
           <p:nvSpPr>
-            <p:cNvPr id="627" name="Rectangle"/>
+            <p:cNvPr id="624" name="Rectangle"/>
             <p:cNvSpPr/>
             <p:nvPr/>
           </p:nvSpPr>
@@ -21294,7 +21210,7 @@
         </p:sp>
         <p:sp>
           <p:nvSpPr>
-            <p:cNvPr id="628" name="Want to work with us: GitHub: Web:…"/>
+            <p:cNvPr id="625" name="Want to work with us: GitHub: Web:…"/>
             <p:cNvSpPr txBox="1"/>
             <p:nvPr/>
           </p:nvSpPr>
@@ -21507,7 +21423,7 @@
       </p:grpSp>
       <p:grpSp>
         <p:nvGrpSpPr>
-          <p:cNvPr id="632" name="Title 1"/>
+          <p:cNvPr id="629" name="Title 1"/>
           <p:cNvGrpSpPr/>
           <p:nvPr/>
         </p:nvGrpSpPr>
@@ -21521,7 +21437,7 @@
         </p:grpSpPr>
         <p:sp>
           <p:nvSpPr>
-            <p:cNvPr id="630" name="Rectangle"/>
+            <p:cNvPr id="627" name="Rectangle"/>
             <p:cNvSpPr/>
             <p:nvPr/>
           </p:nvSpPr>
@@ -21563,7 +21479,7 @@
         </p:sp>
         <p:sp>
           <p:nvSpPr>
-            <p:cNvPr id="631" name="Contact"/>
+            <p:cNvPr id="628" name="Contact"/>
             <p:cNvSpPr txBox="1"/>
             <p:nvPr/>
           </p:nvSpPr>
@@ -21625,7 +21541,7 @@
       </p:grpSp>
       <p:grpSp>
         <p:nvGrpSpPr>
-          <p:cNvPr id="635" name="TextBox 15"/>
+          <p:cNvPr id="632" name="TextBox 15"/>
           <p:cNvGrpSpPr/>
           <p:nvPr/>
         </p:nvGrpSpPr>
@@ -21639,7 +21555,7 @@
         </p:grpSpPr>
         <p:sp>
           <p:nvSpPr>
-            <p:cNvPr id="633" name="Rectangle"/>
+            <p:cNvPr id="630" name="Rectangle"/>
             <p:cNvSpPr/>
             <p:nvPr/>
           </p:nvSpPr>
@@ -21683,7 +21599,7 @@
         </p:sp>
         <p:sp>
           <p:nvSpPr>
-            <p:cNvPr id="634" name="Alex Shatalin JetBrains (MPS)…"/>
+            <p:cNvPr id="631" name="Alex Shatalin JetBrains (MPS)…"/>
             <p:cNvSpPr txBox="1"/>
             <p:nvPr/>
           </p:nvSpPr>
@@ -21939,7 +21855,7 @@
       </p:grpSp>
       <p:pic>
         <p:nvPicPr>
-          <p:cNvPr id="636" name="Picture 3" descr="Picture 3"/>
+          <p:cNvPr id="633" name="Picture 3" descr="Picture 3"/>
           <p:cNvPicPr>
             <a:picLocks noChangeAspect="1"/>
           </p:cNvPicPr>
@@ -21968,7 +21884,7 @@
       </p:pic>
       <p:pic>
         <p:nvPicPr>
-          <p:cNvPr id="637" name="Graphic 6" descr="Graphic 6"/>
+          <p:cNvPr id="634" name="Graphic 6" descr="Graphic 6"/>
           <p:cNvPicPr>
             <a:picLocks noChangeAspect="1"/>
           </p:cNvPicPr>
@@ -32245,10 +32161,6 @@
             <a:r>
               <a:t> with a large customer</a:t>
             </a:r>
-            <a:r>
-              <a:rPr baseline="31999"/>
-              <a:t>2</a:t>
-            </a:r>
           </a:p>
           <a:p>
             <a:pPr lvl="1" marL="0" indent="731519">

</xml_diff>